<commit_message>
docs: drop the RESULTS slide and reword the closing statement
RESULTS was internal build detail (dummy-data variance, chat persistence
counts, bar-width deltas), so the slide and its chart part are removed.
The closing declaration drops the direct address to 부서장 and now covers
both reporting the diagnosis and guiding organisational action; the box
widens to the deck's 12.09in content width at 34pt so the specified
two-line break survives. 13 slides -> 12.

Co-Authored-By: Claude Opus 5 <noreply@anthropic.com>
</commit_message>
<xml_diff>
--- a/Org_health_diag/docs/2026_조직건강도_AI_Agent_수행결과.pptx
+++ b/Org_health_diag/docs/2026_조직건강도_AI_Agent_수행결과.pptx
@@ -17,7 +17,6 @@
     <p:sldId id="262" r:id="rId11"/>
     <p:sldId id="263" r:id="rId12"/>
     <p:sldId id="266" r:id="rId15"/>
-    <p:sldId id="268" r:id="rId17"/>
     <p:sldId id="269" r:id="rId18"/>
     <p:sldId id="270" r:id="rId19"/>
     <p:sldId id="271" r:id="rId20"/>
@@ -261,266 +260,6 @@
     </a:lvl9pPr>
   </p:defaultTextStyle>
 </p:presentation>
-</file>
-
-<file path=ppt/charts/chart1.xml><?xml version="1.0" encoding="utf-8"?>
-<c:chartSpace xmlns:c="http://schemas.openxmlformats.org/drawingml/2006/chart" xmlns:a="http://schemas.openxmlformats.org/drawingml/2006/main" xmlns:r="http://schemas.openxmlformats.org/officeDocument/2006/relationships">
-  <c:date1904 val="0"/>
-  <c:roundedCorners val="1"/>
-  <c:chart>
-    <c:autoTitleDeleted val="1"/>
-    <c:plotArea>
-      <c:layout/>
-      <c:barChart>
-        <c:barDir val="col"/>
-        <c:grouping val="clustered"/>
-        <c:varyColors val="0"/>
-        <c:ser>
-          <c:idx val="0"/>
-          <c:order val="0"/>
-          <c:tx>
-            <c:strRef>
-              <c:f>Sheet1!$B$1</c:f>
-              <c:strCache>
-                <c:ptCount val="1"/>
-                <c:pt idx="0">
-                  <c:v>긍정 응답 비중</c:v>
-                </c:pt>
-              </c:strCache>
-            </c:strRef>
-          </c:tx>
-          <c:spPr>
-            <a:solidFill>
-              <a:srgbClr val="004381"/>
-            </a:solidFill>
-            <a:effectLst/>
-          </c:spPr>
-          <c:invertIfNegative val="0"/>
-          <c:dLbls>
-            <c:numFmt formatCode="#,##0" sourceLinked="0"/>
-            <c:txPr>
-              <a:bodyPr/>
-              <a:lstStyle/>
-              <a:p>
-                <a:pPr>
-                  <a:defRPr b="0" i="0" strike="noStrike" sz="1000" u="none">
-                    <a:solidFill>
-                      <a:srgbClr val="172033"/>
-                    </a:solidFill>
-                    <a:latin typeface="Malgun Gothic"/>
-                  </a:defRPr>
-                </a:pPr>
-              </a:p>
-            </c:txPr>
-            <c:showLegendKey val="0"/>
-            <c:showVal val="1"/>
-            <c:showCatName val="0"/>
-            <c:showSerName val="0"/>
-            <c:showPercent val="0"/>
-            <c:showBubbleSize val="0"/>
-            <c:showLeaderLines val="0"/>
-          </c:dLbls>
-          <c:cat>
-            <c:multiLvlStrRef>
-              <c:f>Sheet1!$A$2:$A$7</c:f>
-              <c:multiLvlStrCache>
-                <c:ptCount val="6"/>
-                <c:lvl>
-                  <c:pt idx="0">
-                    <c:v>철강사업실</c:v>
-                  </c:pt>
-                  <c:pt idx="1">
-                    <c:v>철강설계실</c:v>
-                  </c:pt>
-                  <c:pt idx="2">
-                    <c:v>기술기획실</c:v>
-                  </c:pt>
-                  <c:pt idx="3">
-                    <c:v>플랜트설계실</c:v>
-                  </c:pt>
-                  <c:pt idx="4">
-                    <c:v>건설전략실</c:v>
-                  </c:pt>
-                  <c:pt idx="5">
-                    <c:v>경영혁신실</c:v>
-                  </c:pt>
-                </c:lvl>
-              </c:multiLvlStrCache>
-            </c:multiLvlStrRef>
-          </c:cat>
-          <c:val>
-            <c:numRef>
-              <c:f>Sheet1!$B$2:$B$7</c:f>
-              <c:numCache>
-                <c:formatCode>General</c:formatCode>
-                <c:ptCount val="6"/>
-                <c:pt idx="0">
-                  <c:v>73.6</c:v>
-                </c:pt>
-                <c:pt idx="1">
-                  <c:v>73.5</c:v>
-                </c:pt>
-                <c:pt idx="2">
-                  <c:v>59.2</c:v>
-                </c:pt>
-                <c:pt idx="3">
-                  <c:v>58.2</c:v>
-                </c:pt>
-                <c:pt idx="4">
-                  <c:v>53</c:v>
-                </c:pt>
-                <c:pt idx="5">
-                  <c:v>52.4</c:v>
-                </c:pt>
-              </c:numCache>
-            </c:numRef>
-          </c:val>
-        </c:ser>
-        <c:dLbls>
-          <c:numFmt formatCode="#,##0" sourceLinked="0"/>
-          <c:txPr>
-            <a:bodyPr/>
-            <a:lstStyle/>
-            <a:p>
-              <a:pPr>
-                <a:defRPr b="0" i="0" strike="noStrike" sz="1000" u="none">
-                  <a:solidFill>
-                    <a:srgbClr val="172033"/>
-                  </a:solidFill>
-                  <a:latin typeface="Malgun Gothic"/>
-                </a:defRPr>
-              </a:pPr>
-            </a:p>
-          </c:txPr>
-          <c:showLegendKey val="0"/>
-          <c:showVal val="1"/>
-          <c:showCatName val="0"/>
-          <c:showSerName val="0"/>
-          <c:showPercent val="0"/>
-          <c:showBubbleSize val="0"/>
-          <c:showLeaderLines val="0"/>
-        </c:dLbls>
-        <c:gapWidth val="150"/>
-        <c:overlap val="0"/>
-        <c:axId val="2094734554"/>
-        <c:axId val="2094734552"/>
-        <c:axId val="2094734556"/>
-      </c:barChart>
-      <c:catAx>
-        <c:axId val="2094734554"/>
-        <c:scaling>
-          <c:orientation val="minMax"/>
-        </c:scaling>
-        <c:delete val="0"/>
-        <c:axPos val="b"/>
-        <c:numFmt formatCode="General" sourceLinked="1"/>
-        <c:majorTickMark val="out"/>
-        <c:minorTickMark val="none"/>
-        <c:tickLblPos val="low"/>
-        <c:spPr>
-          <a:ln w="12700" cap="flat">
-            <a:solidFill>
-              <a:srgbClr val="888888"/>
-            </a:solidFill>
-            <a:prstDash val="solid"/>
-            <a:round/>
-          </a:ln>
-        </c:spPr>
-        <c:txPr>
-          <a:bodyPr/>
-          <a:lstStyle/>
-          <a:p>
-            <a:pPr>
-              <a:defRPr sz="950" b="0" i="0" u="none" strike="noStrike">
-                <a:solidFill>
-                  <a:srgbClr val="65708A"/>
-                </a:solidFill>
-                <a:latin typeface="Malgun Gothic"/>
-              </a:defRPr>
-            </a:pPr>
-            <a:endParaRPr lang="en-US"/>
-          </a:p>
-        </c:txPr>
-        <c:crossAx val="2094734552"/>
-        <c:crosses val="autoZero"/>
-        <c:auto val="1"/>
-        <c:lblAlgn val="ctr"/>
-        <c:noMultiLvlLbl val="1"/>
-      </c:catAx>
-      <c:valAx>
-        <c:axId val="2094734552"/>
-        <c:scaling>
-          <c:orientation val="minMax"/>
-          <c:max val="90"/>
-          <c:min val="0"/>
-        </c:scaling>
-        <c:delete val="0"/>
-        <c:axPos val="l"/>
-        <c:majorGridlines>
-          <c:spPr>
-            <a:ln w="12700" cap="flat">
-              <a:solidFill>
-                <a:srgbClr val="DFE5EF"/>
-              </a:solidFill>
-              <a:prstDash val="solid"/>
-              <a:round/>
-            </a:ln>
-          </c:spPr>
-        </c:majorGridlines>
-        <c:numFmt formatCode="General" sourceLinked="0"/>
-        <c:majorTickMark val="out"/>
-        <c:minorTickMark val="none"/>
-        <c:tickLblPos val="nextTo"/>
-        <c:spPr>
-          <a:ln w="12700" cap="flat">
-            <a:solidFill>
-              <a:srgbClr val="888888"/>
-            </a:solidFill>
-            <a:prstDash val="solid"/>
-            <a:round/>
-          </a:ln>
-        </c:spPr>
-        <c:txPr>
-          <a:bodyPr/>
-          <a:lstStyle/>
-          <a:p>
-            <a:pPr>
-              <a:defRPr sz="950" b="0" i="0" u="none" strike="noStrike">
-                <a:solidFill>
-                  <a:srgbClr val="65708A"/>
-                </a:solidFill>
-                <a:latin typeface="Arial"/>
-              </a:defRPr>
-            </a:pPr>
-            <a:endParaRPr lang="en-US"/>
-          </a:p>
-        </c:txPr>
-        <c:crossAx val="2094734554"/>
-        <c:crosses val="autoZero"/>
-        <c:crossBetween val="between"/>
-      </c:valAx>
-      <c:spPr>
-        <a:noFill/>
-        <a:ln>
-          <a:noFill/>
-        </a:ln>
-        <a:effectLst/>
-      </c:spPr>
-    </c:plotArea>
-    <c:plotVisOnly val="1"/>
-    <c:dispBlanksAs val="span"/>
-  </c:chart>
-  <c:spPr>
-    <a:noFill/>
-    <a:ln>
-      <a:noFill/>
-    </a:ln>
-    <a:effectLst/>
-  </c:spPr>
-  <c:externalData r:id="rId1">
-    <c:autoUpdate val="0"/>
-  </c:externalData>
-</c:chartSpace>
 </file>
 
 <file path=ppt/notesMasters/notesMaster1.xml><?xml version="1.0" encoding="utf-8"?>
@@ -1958,164 +1697,6 @@
       <p:sp>
         <p:nvSpPr>
           <p:cNvPr id="325" name="Google Shape;325;p11:notes"/>
-          <p:cNvSpPr txBox="1"/>
-          <p:nvPr>
-            <p:ph idx="12" type="sldNum"/>
-          </p:nvPr>
-        </p:nvSpPr>
-        <p:spPr>
-          <a:xfrm>
-            <a:off x="3884613" y="8685213"/>
-            <a:ext cx="2971800" cy="458787"/>
-          </a:xfrm>
-          <a:prstGeom prst="rect">
-            <a:avLst/>
-          </a:prstGeom>
-          <a:noFill/>
-          <a:ln>
-            <a:noFill/>
-          </a:ln>
-        </p:spPr>
-        <p:txBody>
-          <a:bodyPr anchorCtr="0" anchor="b" bIns="45700" lIns="91425" spcFirstLastPara="1" rIns="91425" wrap="square" tIns="45700">
-            <a:noAutofit/>
-          </a:bodyPr>
-          <a:lstStyle/>
-          <a:p>
-            <a:pPr indent="0" lvl="0" marL="0" rtl="0" algn="r">
-              <a:spcBef>
-                <a:spcPts val="0"/>
-              </a:spcBef>
-              <a:spcAft>
-                <a:spcPts val="0"/>
-              </a:spcAft>
-              <a:buNone/>
-            </a:pPr>
-            <a:fld id="{00000000-1234-1234-1234-123412341234}" type="slidenum">
-              <a:rPr lang="en-US"/>
-              <a:t>‹#›</a:t>
-            </a:fld>
-            <a:endParaRPr/>
-          </a:p>
-        </p:txBody>
-      </p:sp>
-    </p:spTree>
-  </p:cSld>
-  <p:clrMapOvr>
-    <a:masterClrMapping/>
-  </p:clrMapOvr>
-</p:notes>
-</file>
-
-<file path=ppt/notesSlides/notesSlide13.xml><?xml version="1.0" encoding="utf-8"?>
-<p:notes xmlns:a="http://schemas.openxmlformats.org/drawingml/2006/main" xmlns:r="http://schemas.openxmlformats.org/officeDocument/2006/relationships" xmlns:mc="http://schemas.openxmlformats.org/markup-compatibility/2006" xmlns:mv="urn:schemas-microsoft-com:mac:vml" xmlns:p="http://schemas.openxmlformats.org/presentationml/2006/main" xmlns:c="http://schemas.openxmlformats.org/drawingml/2006/chart" xmlns:dgm="http://schemas.openxmlformats.org/drawingml/2006/diagram" xmlns:o="urn:schemas-microsoft-com:office:office" xmlns:v="urn:schemas-microsoft-com:vml" xmlns:pvml="urn:schemas-microsoft-com:office:powerpoint" xmlns:com="http://schemas.openxmlformats.org/drawingml/2006/compatibility" xmlns:p14="http://schemas.microsoft.com/office/powerpoint/2010/main" xmlns:p15="http://schemas.microsoft.com/office/powerpoint/2012/main" xmlns:ahyp="http://schemas.microsoft.com/office/drawing/2018/hyperlinkcolor" showMasterPhAnim="0" showMasterSp="0">
-  <p:cSld>
-    <p:spTree>
-      <p:nvGrpSpPr>
-        <p:cNvPr id="393" name="Shape 393"/>
-        <p:cNvGrpSpPr/>
-        <p:nvPr/>
-      </p:nvGrpSpPr>
-      <p:grpSpPr>
-        <a:xfrm>
-          <a:off x="0" y="0"/>
-          <a:ext cx="0" cy="0"/>
-          <a:chOff x="0" y="0"/>
-          <a:chExt cx="0" cy="0"/>
-        </a:xfrm>
-      </p:grpSpPr>
-      <p:sp>
-        <p:nvSpPr>
-          <p:cNvPr id="394" name="Google Shape;394;p13:notes"/>
-          <p:cNvSpPr/>
-          <p:nvPr>
-            <p:ph idx="2" type="sldImg"/>
-          </p:nvPr>
-        </p:nvSpPr>
-        <p:spPr>
-          <a:xfrm>
-            <a:off x="685800" y="1143000"/>
-            <a:ext cx="5486400" cy="3086100"/>
-          </a:xfrm>
-          <a:custGeom>
-            <a:rect b="b" l="l" r="r" t="t"/>
-            <a:pathLst>
-              <a:path extrusionOk="0" h="120000" w="120000">
-                <a:moveTo>
-                  <a:pt x="0" y="0"/>
-                </a:moveTo>
-                <a:lnTo>
-                  <a:pt x="120000" y="0"/>
-                </a:lnTo>
-                <a:lnTo>
-                  <a:pt x="120000" y="120000"/>
-                </a:lnTo>
-                <a:lnTo>
-                  <a:pt x="0" y="120000"/>
-                </a:lnTo>
-                <a:close/>
-              </a:path>
-            </a:pathLst>
-          </a:custGeom>
-          <a:noFill/>
-          <a:ln cap="flat" cmpd="sng" w="12700">
-            <a:solidFill>
-              <a:srgbClr val="000000"/>
-            </a:solidFill>
-            <a:prstDash val="solid"/>
-            <a:round/>
-            <a:headEnd len="sm" w="sm" type="none"/>
-            <a:tailEnd len="sm" w="sm" type="none"/>
-          </a:ln>
-        </p:spPr>
-      </p:sp>
-      <p:sp>
-        <p:nvSpPr>
-          <p:cNvPr id="395" name="Google Shape;395;p13:notes"/>
-          <p:cNvSpPr txBox="1"/>
-          <p:nvPr>
-            <p:ph idx="1" type="body"/>
-          </p:nvPr>
-        </p:nvSpPr>
-        <p:spPr>
-          <a:xfrm>
-            <a:off x="685800" y="4400550"/>
-            <a:ext cx="5486400" cy="3600450"/>
-          </a:xfrm>
-          <a:prstGeom prst="rect">
-            <a:avLst/>
-          </a:prstGeom>
-          <a:noFill/>
-          <a:ln>
-            <a:noFill/>
-          </a:ln>
-        </p:spPr>
-        <p:txBody>
-          <a:bodyPr anchorCtr="0" anchor="t" bIns="45700" lIns="91425" spcFirstLastPara="1" rIns="91425" wrap="square" tIns="45700">
-            <a:noAutofit/>
-          </a:bodyPr>
-          <a:lstStyle/>
-          <a:p>
-            <a:pPr indent="0" lvl="0" marL="0" rtl="0" algn="l">
-              <a:spcBef>
-                <a:spcPts val="0"/>
-              </a:spcBef>
-              <a:spcAft>
-                <a:spcPts val="0"/>
-              </a:spcAft>
-              <a:buNone/>
-            </a:pPr>
-            <a:r>
-              <a:rPr lang="en-US"/>
-              <a:t>피드백을 받은 뒤 데이터를 다시 만들되, 다른 화면의 결론이 흔들리지 않도록 제약을 걸었습니다.</a:t>
-            </a:r>
-            <a:endParaRPr/>
-          </a:p>
-        </p:txBody>
-      </p:sp>
-      <p:sp>
-        <p:nvSpPr>
-          <p:cNvPr id="396" name="Google Shape;396;p13:notes"/>
           <p:cNvSpPr txBox="1"/>
           <p:nvPr>
             <p:ph idx="12" type="sldNum"/>
@@ -7227,1619 +6808,6 @@
 </p:sld>
 </file>
 
-<file path=ppt/slides/slide13.xml><?xml version="1.0" encoding="utf-8"?>
-<p:sld xmlns:a="http://schemas.openxmlformats.org/drawingml/2006/main" xmlns:r="http://schemas.openxmlformats.org/officeDocument/2006/relationships" xmlns:mc="http://schemas.openxmlformats.org/markup-compatibility/2006" xmlns:mv="urn:schemas-microsoft-com:mac:vml" xmlns:p="http://schemas.openxmlformats.org/presentationml/2006/main" xmlns:c="http://schemas.openxmlformats.org/drawingml/2006/chart" xmlns:dgm="http://schemas.openxmlformats.org/drawingml/2006/diagram" xmlns:o="urn:schemas-microsoft-com:office:office" xmlns:v="urn:schemas-microsoft-com:vml" xmlns:pvml="urn:schemas-microsoft-com:office:powerpoint" xmlns:com="http://schemas.openxmlformats.org/drawingml/2006/compatibility" xmlns:p14="http://schemas.microsoft.com/office/powerpoint/2010/main" xmlns:p15="http://schemas.microsoft.com/office/powerpoint/2012/main" xmlns:ahyp="http://schemas.microsoft.com/office/drawing/2018/hyperlinkcolor">
-  <p:cSld>
-    <p:bg>
-      <p:bgPr>
-        <a:solidFill>
-          <a:srgbClr val="F5F7FB"/>
-        </a:solidFill>
-      </p:bgPr>
-    </p:bg>
-    <p:spTree>
-      <p:nvGrpSpPr>
-        <p:cNvPr id="397" name="Shape 397"/>
-        <p:cNvGrpSpPr/>
-        <p:nvPr/>
-      </p:nvGrpSpPr>
-      <p:grpSpPr>
-        <a:xfrm>
-          <a:off x="0" y="0"/>
-          <a:ext cx="0" cy="0"/>
-          <a:chOff x="0" y="0"/>
-          <a:chExt cx="0" cy="0"/>
-        </a:xfrm>
-      </p:grpSpPr>
-      <p:sp>
-        <p:nvSpPr>
-          <p:cNvPr id="398" name="Google Shape;398;p15"/>
-          <p:cNvSpPr/>
-          <p:nvPr/>
-        </p:nvSpPr>
-        <p:spPr>
-          <a:xfrm>
-            <a:off x="566928" y="365760"/>
-            <a:ext cx="11057839" cy="219456"/>
-          </a:xfrm>
-          <a:prstGeom prst="rect">
-            <a:avLst/>
-          </a:prstGeom>
-          <a:noFill/>
-          <a:ln>
-            <a:noFill/>
-          </a:ln>
-        </p:spPr>
-        <p:txBody>
-          <a:bodyPr anchorCtr="0" anchor="ctr" bIns="0" lIns="0" spcFirstLastPara="1" rIns="0" wrap="square" tIns="0">
-            <a:noAutofit/>
-          </a:bodyPr>
-          <a:lstStyle/>
-          <a:p>
-            <a:pPr indent="0" lvl="0" marL="0" marR="0" rtl="0" algn="l">
-              <a:spcBef>
-                <a:spcPts val="0"/>
-              </a:spcBef>
-              <a:spcAft>
-                <a:spcPts val="0"/>
-              </a:spcAft>
-              <a:buClr>
-                <a:srgbClr val="0098D9"/>
-              </a:buClr>
-              <a:buSzPts val="1100"/>
-              <a:buFont typeface="Malgun Gothic"/>
-              <a:buNone/>
-            </a:pPr>
-            <a:r>
-              <a:rPr b="1" i="0" lang="en-US" sz="1100" u="none" cap="none" strike="noStrike">
-                <a:solidFill>
-                  <a:srgbClr val="0098D9"/>
-                </a:solidFill>
-                <a:latin typeface="Malgun Gothic"/>
-                <a:ea typeface="Malgun Gothic"/>
-                <a:cs typeface="Malgun Gothic"/>
-                <a:sym typeface="Malgun Gothic"/>
-              </a:rPr>
-              <a:t>RESULTS</a:t>
-            </a:r>
-            <a:endParaRPr b="0" i="0" sz="1100" u="none" cap="none" strike="noStrike">
-              <a:solidFill>
-                <a:schemeClr val="dk1"/>
-              </a:solidFill>
-              <a:latin typeface="Calibri"/>
-              <a:ea typeface="Calibri"/>
-              <a:cs typeface="Calibri"/>
-              <a:sym typeface="Calibri"/>
-            </a:endParaRPr>
-          </a:p>
-        </p:txBody>
-      </p:sp>
-      <p:sp>
-        <p:nvSpPr>
-          <p:cNvPr id="399" name="Google Shape;399;p15"/>
-          <p:cNvSpPr/>
-          <p:nvPr/>
-        </p:nvSpPr>
-        <p:spPr>
-          <a:xfrm>
-            <a:off x="566928" y="603504"/>
-            <a:ext cx="11057839" cy="566928"/>
-          </a:xfrm>
-          <a:prstGeom prst="rect">
-            <a:avLst/>
-          </a:prstGeom>
-          <a:noFill/>
-          <a:ln>
-            <a:noFill/>
-          </a:ln>
-        </p:spPr>
-        <p:txBody>
-          <a:bodyPr anchorCtr="0" anchor="ctr" bIns="0" lIns="0" spcFirstLastPara="1" rIns="0" wrap="square" tIns="0">
-            <a:noAutofit/>
-          </a:bodyPr>
-          <a:lstStyle/>
-          <a:p>
-            <a:pPr indent="0" lvl="0" marL="0" marR="0" rtl="0" algn="l">
-              <a:spcBef>
-                <a:spcPts val="0"/>
-              </a:spcBef>
-              <a:spcAft>
-                <a:spcPts val="0"/>
-              </a:spcAft>
-              <a:buClr>
-                <a:srgbClr val="002D5A"/>
-              </a:buClr>
-              <a:buSzPts val="3000"/>
-              <a:buFont typeface="Malgun Gothic"/>
-              <a:buNone/>
-            </a:pPr>
-            <a:r>
-              <a:rPr b="1" i="0" lang="en-US" sz="3000" u="none" cap="none" strike="noStrike">
-                <a:solidFill>
-                  <a:srgbClr val="002D5A"/>
-                </a:solidFill>
-                <a:latin typeface="Malgun Gothic"/>
-                <a:ea typeface="Malgun Gothic"/>
-                <a:cs typeface="Malgun Gothic"/>
-                <a:sym typeface="Malgun Gothic"/>
-              </a:rPr>
-              <a:t>해석이 실제로 갈리는지 수치로 확인</a:t>
-            </a:r>
-            <a:endParaRPr b="0" i="0" sz="3000" u="none" cap="none" strike="noStrike">
-              <a:solidFill>
-                <a:schemeClr val="dk1"/>
-              </a:solidFill>
-              <a:latin typeface="Calibri"/>
-              <a:ea typeface="Calibri"/>
-              <a:cs typeface="Calibri"/>
-              <a:sym typeface="Calibri"/>
-            </a:endParaRPr>
-          </a:p>
-        </p:txBody>
-      </p:sp>
-      <p:sp>
-        <p:nvSpPr>
-          <p:cNvPr id="400" name="Google Shape;400;p15"/>
-          <p:cNvSpPr/>
-          <p:nvPr/>
-        </p:nvSpPr>
-        <p:spPr>
-          <a:xfrm>
-            <a:off x="11076127" y="6355080"/>
-            <a:ext cx="548640" cy="256032"/>
-          </a:xfrm>
-          <a:prstGeom prst="rect">
-            <a:avLst/>
-          </a:prstGeom>
-          <a:noFill/>
-          <a:ln>
-            <a:noFill/>
-          </a:ln>
-        </p:spPr>
-        <p:txBody>
-          <a:bodyPr anchorCtr="0" anchor="ctr" bIns="0" lIns="0" spcFirstLastPara="1" rIns="0" wrap="square" tIns="0">
-            <a:noAutofit/>
-          </a:bodyPr>
-          <a:lstStyle/>
-          <a:p>
-            <a:pPr indent="0" lvl="0" marL="0" marR="0" rtl="0" algn="r">
-              <a:spcBef>
-                <a:spcPts val="0"/>
-              </a:spcBef>
-              <a:spcAft>
-                <a:spcPts val="0"/>
-              </a:spcAft>
-              <a:buClr>
-                <a:srgbClr val="65708A"/>
-              </a:buClr>
-              <a:buSzPts val="1000"/>
-              <a:buFont typeface="Malgun Gothic"/>
-              <a:buNone/>
-            </a:pPr>
-            <a:r>
-              <a:rPr b="0" i="0" lang="en-US" sz="1000" u="none" cap="none" strike="noStrike">
-                <a:solidFill>
-                  <a:srgbClr val="65708A"/>
-                </a:solidFill>
-                <a:latin typeface="Malgun Gothic"/>
-                <a:ea typeface="Malgun Gothic"/>
-                <a:cs typeface="Malgun Gothic"/>
-                <a:sym typeface="Malgun Gothic"/>
-              </a:rPr>
-              <a:t>9</a:t>
-            </a:r>
-            <a:endParaRPr b="0" i="0" sz="1000" u="none" cap="none" strike="noStrike">
-              <a:solidFill>
-                <a:schemeClr val="dk1"/>
-              </a:solidFill>
-              <a:latin typeface="Calibri"/>
-              <a:ea typeface="Calibri"/>
-              <a:cs typeface="Calibri"/>
-              <a:sym typeface="Calibri"/>
-            </a:endParaRPr>
-          </a:p>
-        </p:txBody>
-      </p:sp>
-      <p:sp>
-        <p:nvSpPr>
-          <p:cNvPr id="401" name="Google Shape;401;p15"/>
-          <p:cNvSpPr/>
-          <p:nvPr/>
-        </p:nvSpPr>
-        <p:spPr>
-          <a:xfrm>
-            <a:off x="566928" y="1389888"/>
-            <a:ext cx="6126480" cy="3749040"/>
-          </a:xfrm>
-          <a:prstGeom prst="roundRect">
-            <a:avLst>
-              <a:gd fmla="val 1951" name="adj"/>
-            </a:avLst>
-          </a:prstGeom>
-          <a:solidFill>
-            <a:srgbClr val="FFFFFF"/>
-          </a:solidFill>
-          <a:ln cap="flat" cmpd="sng" w="12700">
-            <a:solidFill>
-              <a:srgbClr val="DFE5EF"/>
-            </a:solidFill>
-            <a:prstDash val="solid"/>
-            <a:round/>
-            <a:headEnd len="sm" w="sm" type="none"/>
-            <a:tailEnd len="sm" w="sm" type="none"/>
-          </a:ln>
-          <a:effectLst>
-            <a:outerShdw blurRad="127000" rotWithShape="0" algn="bl" dir="5400000" dist="25400">
-              <a:srgbClr val="8894A8">
-                <a:alpha val="18039"/>
-              </a:srgbClr>
-            </a:outerShdw>
-          </a:effectLst>
-        </p:spPr>
-        <p:txBody>
-          <a:bodyPr anchorCtr="0" anchor="ctr" bIns="91425" lIns="91425" spcFirstLastPara="1" rIns="91425" wrap="square" tIns="91425">
-            <a:noAutofit/>
-          </a:bodyPr>
-          <a:lstStyle/>
-          <a:p>
-            <a:pPr indent="0" lvl="0" marL="0" rtl="0" algn="l">
-              <a:spcBef>
-                <a:spcPts val="0"/>
-              </a:spcBef>
-              <a:spcAft>
-                <a:spcPts val="0"/>
-              </a:spcAft>
-              <a:buNone/>
-            </a:pPr>
-            <a:r>
-              <a:t/>
-            </a:r>
-            <a:endParaRPr/>
-          </a:p>
-        </p:txBody>
-      </p:sp>
-      <p:sp>
-        <p:nvSpPr>
-          <p:cNvPr id="402" name="Google Shape;402;p15"/>
-          <p:cNvSpPr/>
-          <p:nvPr/>
-        </p:nvSpPr>
-        <p:spPr>
-          <a:xfrm>
-            <a:off x="859536" y="1572768"/>
-            <a:ext cx="5486400" cy="292608"/>
-          </a:xfrm>
-          <a:prstGeom prst="rect">
-            <a:avLst/>
-          </a:prstGeom>
-          <a:noFill/>
-          <a:ln>
-            <a:noFill/>
-          </a:ln>
-        </p:spPr>
-        <p:txBody>
-          <a:bodyPr anchorCtr="0" anchor="ctr" bIns="0" lIns="0" spcFirstLastPara="1" rIns="0" wrap="square" tIns="0">
-            <a:noAutofit/>
-          </a:bodyPr>
-          <a:lstStyle/>
-          <a:p>
-            <a:pPr indent="0" lvl="0" marL="0" marR="0" rtl="0" algn="l">
-              <a:spcBef>
-                <a:spcPts val="0"/>
-              </a:spcBef>
-              <a:spcAft>
-                <a:spcPts val="0"/>
-              </a:spcAft>
-              <a:buClr>
-                <a:srgbClr val="002D5A"/>
-              </a:buClr>
-              <a:buSzPts val="1350"/>
-              <a:buFont typeface="Malgun Gothic"/>
-              <a:buNone/>
-            </a:pPr>
-            <a:r>
-              <a:rPr b="1" i="0" lang="en-US" sz="1350" u="none" cap="none" strike="noStrike">
-                <a:solidFill>
-                  <a:srgbClr val="002D5A"/>
-                </a:solidFill>
-                <a:latin typeface="Malgun Gothic"/>
-                <a:ea typeface="Malgun Gothic"/>
-                <a:cs typeface="Malgun Gothic"/>
-                <a:sym typeface="Malgun Gothic"/>
-              </a:rPr>
-              <a:t>부서별 긍정 응답 비중 (2026)</a:t>
-            </a:r>
-            <a:endParaRPr b="0" i="0" sz="1350" u="none" cap="none" strike="noStrike">
-              <a:solidFill>
-                <a:schemeClr val="dk1"/>
-              </a:solidFill>
-              <a:latin typeface="Calibri"/>
-              <a:ea typeface="Calibri"/>
-              <a:cs typeface="Calibri"/>
-              <a:sym typeface="Calibri"/>
-            </a:endParaRPr>
-          </a:p>
-        </p:txBody>
-      </p:sp>
-      <p:graphicFrame>
-        <p:nvGraphicFramePr>
-          <p:cNvPr id="403" name="Google Shape;403;p15"/>
-          <p:cNvGraphicFramePr/>
-          <p:nvPr/>
-        </p:nvGraphicFramePr>
-        <p:xfrm>
-          <a:off x="768096" y="1938528"/>
-          <a:ext cx="5724144" cy="3035808"/>
-        </p:xfrm>
-        <a:graphic>
-          <a:graphicData uri="http://schemas.openxmlformats.org/drawingml/2006/chart">
-            <c:chart r:id="rId3"/>
-          </a:graphicData>
-        </a:graphic>
-      </p:graphicFrame>
-      <p:sp>
-        <p:nvSpPr>
-          <p:cNvPr id="404" name="Google Shape;404;p15"/>
-          <p:cNvSpPr/>
-          <p:nvPr/>
-        </p:nvSpPr>
-        <p:spPr>
-          <a:xfrm>
-            <a:off x="6912864" y="1389888"/>
-            <a:ext cx="4711903" cy="292608"/>
-          </a:xfrm>
-          <a:prstGeom prst="rect">
-            <a:avLst/>
-          </a:prstGeom>
-          <a:noFill/>
-          <a:ln>
-            <a:noFill/>
-          </a:ln>
-        </p:spPr>
-        <p:txBody>
-          <a:bodyPr anchorCtr="0" anchor="ctr" bIns="0" lIns="0" spcFirstLastPara="1" rIns="0" wrap="square" tIns="0">
-            <a:noAutofit/>
-          </a:bodyPr>
-          <a:lstStyle/>
-          <a:p>
-            <a:pPr indent="0" lvl="0" marL="0" marR="0" rtl="0" algn="l">
-              <a:spcBef>
-                <a:spcPts val="0"/>
-              </a:spcBef>
-              <a:spcAft>
-                <a:spcPts val="0"/>
-              </a:spcAft>
-              <a:buClr>
-                <a:srgbClr val="002D5A"/>
-              </a:buClr>
-              <a:buSzPts val="1350"/>
-              <a:buFont typeface="Malgun Gothic"/>
-              <a:buNone/>
-            </a:pPr>
-            <a:r>
-              <a:rPr b="1" i="0" lang="en-US" sz="1350" u="none" cap="none" strike="noStrike">
-                <a:solidFill>
-                  <a:srgbClr val="002D5A"/>
-                </a:solidFill>
-                <a:latin typeface="Malgun Gothic"/>
-                <a:ea typeface="Malgun Gothic"/>
-                <a:cs typeface="Malgun Gothic"/>
-                <a:sym typeface="Malgun Gothic"/>
-              </a:rPr>
-              <a:t>개선 전후 비교</a:t>
-            </a:r>
-            <a:endParaRPr b="0" i="0" sz="1350" u="none" cap="none" strike="noStrike">
-              <a:solidFill>
-                <a:schemeClr val="dk1"/>
-              </a:solidFill>
-              <a:latin typeface="Calibri"/>
-              <a:ea typeface="Calibri"/>
-              <a:cs typeface="Calibri"/>
-              <a:sym typeface="Calibri"/>
-            </a:endParaRPr>
-          </a:p>
-        </p:txBody>
-      </p:sp>
-      <p:sp>
-        <p:nvSpPr>
-          <p:cNvPr id="405" name="Google Shape;405;p15"/>
-          <p:cNvSpPr/>
-          <p:nvPr/>
-        </p:nvSpPr>
-        <p:spPr>
-          <a:xfrm>
-            <a:off x="6912864" y="1792224"/>
-            <a:ext cx="4711903" cy="969264"/>
-          </a:xfrm>
-          <a:prstGeom prst="roundRect">
-            <a:avLst>
-              <a:gd fmla="val 7547" name="adj"/>
-            </a:avLst>
-          </a:prstGeom>
-          <a:solidFill>
-            <a:srgbClr val="FFFFFF"/>
-          </a:solidFill>
-          <a:ln cap="flat" cmpd="sng" w="12700">
-            <a:solidFill>
-              <a:srgbClr val="DFE5EF"/>
-            </a:solidFill>
-            <a:prstDash val="solid"/>
-            <a:round/>
-            <a:headEnd len="sm" w="sm" type="none"/>
-            <a:tailEnd len="sm" w="sm" type="none"/>
-          </a:ln>
-          <a:effectLst>
-            <a:outerShdw blurRad="127000" rotWithShape="0" algn="bl" dir="5400000" dist="25400">
-              <a:srgbClr val="8894A8">
-                <a:alpha val="18039"/>
-              </a:srgbClr>
-            </a:outerShdw>
-          </a:effectLst>
-        </p:spPr>
-        <p:txBody>
-          <a:bodyPr anchorCtr="0" anchor="ctr" bIns="91425" lIns="91425" spcFirstLastPara="1" rIns="91425" wrap="square" tIns="91425">
-            <a:noAutofit/>
-          </a:bodyPr>
-          <a:lstStyle/>
-          <a:p>
-            <a:pPr indent="0" lvl="0" marL="0" rtl="0" algn="l">
-              <a:spcBef>
-                <a:spcPts val="0"/>
-              </a:spcBef>
-              <a:spcAft>
-                <a:spcPts val="0"/>
-              </a:spcAft>
-              <a:buNone/>
-            </a:pPr>
-            <a:r>
-              <a:t/>
-            </a:r>
-            <a:endParaRPr/>
-          </a:p>
-        </p:txBody>
-      </p:sp>
-      <p:sp>
-        <p:nvSpPr>
-          <p:cNvPr id="406" name="Google Shape;406;p15"/>
-          <p:cNvSpPr/>
-          <p:nvPr/>
-        </p:nvSpPr>
-        <p:spPr>
-          <a:xfrm>
-            <a:off x="7150608" y="1920240"/>
-            <a:ext cx="4236415" cy="237744"/>
-          </a:xfrm>
-          <a:prstGeom prst="rect">
-            <a:avLst/>
-          </a:prstGeom>
-          <a:noFill/>
-          <a:ln>
-            <a:noFill/>
-          </a:ln>
-        </p:spPr>
-        <p:txBody>
-          <a:bodyPr anchorCtr="0" anchor="ctr" bIns="0" lIns="0" spcFirstLastPara="1" rIns="0" wrap="square" tIns="0">
-            <a:noAutofit/>
-          </a:bodyPr>
-          <a:lstStyle/>
-          <a:p>
-            <a:pPr indent="0" lvl="0" marL="0" marR="0" rtl="0" algn="l">
-              <a:spcBef>
-                <a:spcPts val="0"/>
-              </a:spcBef>
-              <a:spcAft>
-                <a:spcPts val="0"/>
-              </a:spcAft>
-              <a:buClr>
-                <a:srgbClr val="002D5A"/>
-              </a:buClr>
-              <a:buSzPts val="1150"/>
-              <a:buFont typeface="Malgun Gothic"/>
-              <a:buNone/>
-            </a:pPr>
-            <a:r>
-              <a:rPr b="1" i="0" lang="en-US" sz="1150" u="none" cap="none" strike="noStrike">
-                <a:solidFill>
-                  <a:srgbClr val="002D5A"/>
-                </a:solidFill>
-                <a:latin typeface="Malgun Gothic"/>
-                <a:ea typeface="Malgun Gothic"/>
-                <a:cs typeface="Malgun Gothic"/>
-                <a:sym typeface="Malgun Gothic"/>
-              </a:rPr>
-              <a:t>더미 데이터 편차 주입</a:t>
-            </a:r>
-            <a:endParaRPr b="0" i="0" sz="1150" u="none" cap="none" strike="noStrike">
-              <a:solidFill>
-                <a:schemeClr val="dk1"/>
-              </a:solidFill>
-              <a:latin typeface="Calibri"/>
-              <a:ea typeface="Calibri"/>
-              <a:cs typeface="Calibri"/>
-              <a:sym typeface="Calibri"/>
-            </a:endParaRPr>
-          </a:p>
-        </p:txBody>
-      </p:sp>
-      <p:sp>
-        <p:nvSpPr>
-          <p:cNvPr id="407" name="Google Shape;407;p15"/>
-          <p:cNvSpPr/>
-          <p:nvPr/>
-        </p:nvSpPr>
-        <p:spPr>
-          <a:xfrm>
-            <a:off x="7150608" y="2157984"/>
-            <a:ext cx="4236415" cy="201168"/>
-          </a:xfrm>
-          <a:prstGeom prst="rect">
-            <a:avLst/>
-          </a:prstGeom>
-          <a:noFill/>
-          <a:ln>
-            <a:noFill/>
-          </a:ln>
-        </p:spPr>
-        <p:txBody>
-          <a:bodyPr anchorCtr="0" anchor="ctr" bIns="0" lIns="0" spcFirstLastPara="1" rIns="0" wrap="square" tIns="0">
-            <a:noAutofit/>
-          </a:bodyPr>
-          <a:lstStyle/>
-          <a:p>
-            <a:pPr indent="0" lvl="0" marL="0" marR="0" rtl="0" algn="l">
-              <a:spcBef>
-                <a:spcPts val="0"/>
-              </a:spcBef>
-              <a:spcAft>
-                <a:spcPts val="0"/>
-              </a:spcAft>
-              <a:buClr>
-                <a:srgbClr val="65708A"/>
-              </a:buClr>
-              <a:buSzPts val="950"/>
-              <a:buFont typeface="Malgun Gothic"/>
-              <a:buNone/>
-            </a:pPr>
-            <a:r>
-              <a:rPr b="0" i="0" lang="en-US" sz="950" u="none" cap="none" strike="noStrike">
-                <a:solidFill>
-                  <a:srgbClr val="65708A"/>
-                </a:solidFill>
-                <a:latin typeface="Malgun Gothic"/>
-                <a:ea typeface="Malgun Gothic"/>
-                <a:cs typeface="Malgun Gothic"/>
-                <a:sym typeface="Malgun Gothic"/>
-              </a:rPr>
-              <a:t>"비슷한 수준" 문구 비율</a:t>
-            </a:r>
-            <a:endParaRPr b="0" i="0" sz="950" u="none" cap="none" strike="noStrike">
-              <a:solidFill>
-                <a:schemeClr val="dk1"/>
-              </a:solidFill>
-              <a:latin typeface="Calibri"/>
-              <a:ea typeface="Calibri"/>
-              <a:cs typeface="Calibri"/>
-              <a:sym typeface="Calibri"/>
-            </a:endParaRPr>
-          </a:p>
-        </p:txBody>
-      </p:sp>
-      <p:sp>
-        <p:nvSpPr>
-          <p:cNvPr id="408" name="Google Shape;408;p15"/>
-          <p:cNvSpPr/>
-          <p:nvPr/>
-        </p:nvSpPr>
-        <p:spPr>
-          <a:xfrm>
-            <a:off x="7150608" y="2359152"/>
-            <a:ext cx="1188720" cy="310896"/>
-          </a:xfrm>
-          <a:prstGeom prst="rect">
-            <a:avLst/>
-          </a:prstGeom>
-          <a:noFill/>
-          <a:ln>
-            <a:noFill/>
-          </a:ln>
-        </p:spPr>
-        <p:txBody>
-          <a:bodyPr anchorCtr="0" anchor="ctr" bIns="0" lIns="0" spcFirstLastPara="1" rIns="0" wrap="square" tIns="0">
-            <a:noAutofit/>
-          </a:bodyPr>
-          <a:lstStyle/>
-          <a:p>
-            <a:pPr indent="0" lvl="0" marL="0" marR="0" rtl="0" algn="l">
-              <a:spcBef>
-                <a:spcPts val="0"/>
-              </a:spcBef>
-              <a:spcAft>
-                <a:spcPts val="0"/>
-              </a:spcAft>
-              <a:buClr>
-                <a:srgbClr val="65708A"/>
-              </a:buClr>
-              <a:buSzPts val="1600"/>
-              <a:buFont typeface="Malgun Gothic"/>
-              <a:buNone/>
-            </a:pPr>
-            <a:r>
-              <a:rPr b="1" i="0" lang="en-US" sz="1600" u="none" cap="none" strike="noStrike">
-                <a:solidFill>
-                  <a:srgbClr val="65708A"/>
-                </a:solidFill>
-                <a:latin typeface="Malgun Gothic"/>
-                <a:ea typeface="Malgun Gothic"/>
-                <a:cs typeface="Malgun Gothic"/>
-                <a:sym typeface="Malgun Gothic"/>
-              </a:rPr>
-              <a:t>64%</a:t>
-            </a:r>
-            <a:endParaRPr b="0" i="0" sz="1600" u="none" cap="none" strike="noStrike">
-              <a:solidFill>
-                <a:schemeClr val="dk1"/>
-              </a:solidFill>
-              <a:latin typeface="Calibri"/>
-              <a:ea typeface="Calibri"/>
-              <a:cs typeface="Calibri"/>
-              <a:sym typeface="Calibri"/>
-            </a:endParaRPr>
-          </a:p>
-        </p:txBody>
-      </p:sp>
-      <p:sp>
-        <p:nvSpPr>
-          <p:cNvPr id="409" name="Google Shape;409;p15"/>
-          <p:cNvSpPr/>
-          <p:nvPr/>
-        </p:nvSpPr>
-        <p:spPr>
-          <a:xfrm>
-            <a:off x="8339328" y="2468880"/>
-            <a:ext cx="237744" cy="128016"/>
-          </a:xfrm>
-          <a:prstGeom prst="rightArrow">
-            <a:avLst>
-              <a:gd fmla="val 50000" name="adj1"/>
-              <a:gd fmla="val 50000" name="adj2"/>
-            </a:avLst>
-          </a:prstGeom>
-          <a:solidFill>
-            <a:srgbClr val="65708A"/>
-          </a:solidFill>
-          <a:ln>
-            <a:noFill/>
-          </a:ln>
-        </p:spPr>
-        <p:txBody>
-          <a:bodyPr anchorCtr="0" anchor="ctr" bIns="91425" lIns="91425" spcFirstLastPara="1" rIns="91425" wrap="square" tIns="91425">
-            <a:noAutofit/>
-          </a:bodyPr>
-          <a:lstStyle/>
-          <a:p>
-            <a:pPr indent="0" lvl="0" marL="0" rtl="0" algn="l">
-              <a:spcBef>
-                <a:spcPts val="0"/>
-              </a:spcBef>
-              <a:spcAft>
-                <a:spcPts val="0"/>
-              </a:spcAft>
-              <a:buNone/>
-            </a:pPr>
-            <a:r>
-              <a:t/>
-            </a:r>
-            <a:endParaRPr/>
-          </a:p>
-        </p:txBody>
-      </p:sp>
-      <p:sp>
-        <p:nvSpPr>
-          <p:cNvPr id="410" name="Google Shape;410;p15"/>
-          <p:cNvSpPr/>
-          <p:nvPr/>
-        </p:nvSpPr>
-        <p:spPr>
-          <a:xfrm>
-            <a:off x="8686800" y="2359152"/>
-            <a:ext cx="1463040" cy="310896"/>
-          </a:xfrm>
-          <a:prstGeom prst="rect">
-            <a:avLst/>
-          </a:prstGeom>
-          <a:noFill/>
-          <a:ln>
-            <a:noFill/>
-          </a:ln>
-        </p:spPr>
-        <p:txBody>
-          <a:bodyPr anchorCtr="0" anchor="ctr" bIns="0" lIns="0" spcFirstLastPara="1" rIns="0" wrap="square" tIns="0">
-            <a:noAutofit/>
-          </a:bodyPr>
-          <a:lstStyle/>
-          <a:p>
-            <a:pPr indent="0" lvl="0" marL="0" marR="0" rtl="0" algn="l">
-              <a:spcBef>
-                <a:spcPts val="0"/>
-              </a:spcBef>
-              <a:spcAft>
-                <a:spcPts val="0"/>
-              </a:spcAft>
-              <a:buClr>
-                <a:srgbClr val="00A950"/>
-              </a:buClr>
-              <a:buSzPts val="1600"/>
-              <a:buFont typeface="Malgun Gothic"/>
-              <a:buNone/>
-            </a:pPr>
-            <a:r>
-              <a:rPr b="1" i="0" lang="en-US" sz="1600" u="none" cap="none" strike="noStrike">
-                <a:solidFill>
-                  <a:srgbClr val="00A950"/>
-                </a:solidFill>
-                <a:latin typeface="Malgun Gothic"/>
-                <a:ea typeface="Malgun Gothic"/>
-                <a:cs typeface="Malgun Gothic"/>
-                <a:sym typeface="Malgun Gothic"/>
-              </a:rPr>
-              <a:t>18%</a:t>
-            </a:r>
-            <a:endParaRPr b="0" i="0" sz="1600" u="none" cap="none" strike="noStrike">
-              <a:solidFill>
-                <a:schemeClr val="dk1"/>
-              </a:solidFill>
-              <a:latin typeface="Calibri"/>
-              <a:ea typeface="Calibri"/>
-              <a:cs typeface="Calibri"/>
-              <a:sym typeface="Calibri"/>
-            </a:endParaRPr>
-          </a:p>
-        </p:txBody>
-      </p:sp>
-      <p:sp>
-        <p:nvSpPr>
-          <p:cNvPr id="411" name="Google Shape;411;p15"/>
-          <p:cNvSpPr/>
-          <p:nvPr/>
-        </p:nvSpPr>
-        <p:spPr>
-          <a:xfrm>
-            <a:off x="6912864" y="2926080"/>
-            <a:ext cx="4711903" cy="969264"/>
-          </a:xfrm>
-          <a:prstGeom prst="roundRect">
-            <a:avLst>
-              <a:gd fmla="val 7547" name="adj"/>
-            </a:avLst>
-          </a:prstGeom>
-          <a:solidFill>
-            <a:srgbClr val="FFFFFF"/>
-          </a:solidFill>
-          <a:ln cap="flat" cmpd="sng" w="12700">
-            <a:solidFill>
-              <a:srgbClr val="DFE5EF"/>
-            </a:solidFill>
-            <a:prstDash val="solid"/>
-            <a:round/>
-            <a:headEnd len="sm" w="sm" type="none"/>
-            <a:tailEnd len="sm" w="sm" type="none"/>
-          </a:ln>
-          <a:effectLst>
-            <a:outerShdw blurRad="127000" rotWithShape="0" algn="bl" dir="5400000" dist="25400">
-              <a:srgbClr val="8894A8">
-                <a:alpha val="18039"/>
-              </a:srgbClr>
-            </a:outerShdw>
-          </a:effectLst>
-        </p:spPr>
-        <p:txBody>
-          <a:bodyPr anchorCtr="0" anchor="ctr" bIns="91425" lIns="91425" spcFirstLastPara="1" rIns="91425" wrap="square" tIns="91425">
-            <a:noAutofit/>
-          </a:bodyPr>
-          <a:lstStyle/>
-          <a:p>
-            <a:pPr indent="0" lvl="0" marL="0" rtl="0" algn="l">
-              <a:spcBef>
-                <a:spcPts val="0"/>
-              </a:spcBef>
-              <a:spcAft>
-                <a:spcPts val="0"/>
-              </a:spcAft>
-              <a:buNone/>
-            </a:pPr>
-            <a:r>
-              <a:t/>
-            </a:r>
-            <a:endParaRPr/>
-          </a:p>
-        </p:txBody>
-      </p:sp>
-      <p:sp>
-        <p:nvSpPr>
-          <p:cNvPr id="412" name="Google Shape;412;p15"/>
-          <p:cNvSpPr/>
-          <p:nvPr/>
-        </p:nvSpPr>
-        <p:spPr>
-          <a:xfrm>
-            <a:off x="7150608" y="3054096"/>
-            <a:ext cx="4236415" cy="237744"/>
-          </a:xfrm>
-          <a:prstGeom prst="rect">
-            <a:avLst/>
-          </a:prstGeom>
-          <a:noFill/>
-          <a:ln>
-            <a:noFill/>
-          </a:ln>
-        </p:spPr>
-        <p:txBody>
-          <a:bodyPr anchorCtr="0" anchor="ctr" bIns="0" lIns="0" spcFirstLastPara="1" rIns="0" wrap="square" tIns="0">
-            <a:noAutofit/>
-          </a:bodyPr>
-          <a:lstStyle/>
-          <a:p>
-            <a:pPr indent="0" lvl="0" marL="0" marR="0" rtl="0" algn="l">
-              <a:spcBef>
-                <a:spcPts val="0"/>
-              </a:spcBef>
-              <a:spcAft>
-                <a:spcPts val="0"/>
-              </a:spcAft>
-              <a:buClr>
-                <a:srgbClr val="002D5A"/>
-              </a:buClr>
-              <a:buSzPts val="1150"/>
-              <a:buFont typeface="Malgun Gothic"/>
-              <a:buNone/>
-            </a:pPr>
-            <a:r>
-              <a:rPr b="1" i="0" lang="en-US" sz="1150" u="none" cap="none" strike="noStrike">
-                <a:solidFill>
-                  <a:srgbClr val="002D5A"/>
-                </a:solidFill>
-                <a:latin typeface="Malgun Gothic"/>
-                <a:ea typeface="Malgun Gothic"/>
-                <a:cs typeface="Malgun Gothic"/>
-                <a:sym typeface="Malgun Gothic"/>
-              </a:rPr>
-              <a:t>대화 기록 저장 방식 전환</a:t>
-            </a:r>
-            <a:endParaRPr b="0" i="0" sz="1150" u="none" cap="none" strike="noStrike">
-              <a:solidFill>
-                <a:schemeClr val="dk1"/>
-              </a:solidFill>
-              <a:latin typeface="Calibri"/>
-              <a:ea typeface="Calibri"/>
-              <a:cs typeface="Calibri"/>
-              <a:sym typeface="Calibri"/>
-            </a:endParaRPr>
-          </a:p>
-        </p:txBody>
-      </p:sp>
-      <p:sp>
-        <p:nvSpPr>
-          <p:cNvPr id="413" name="Google Shape;413;p15"/>
-          <p:cNvSpPr/>
-          <p:nvPr/>
-        </p:nvSpPr>
-        <p:spPr>
-          <a:xfrm>
-            <a:off x="7150608" y="3291840"/>
-            <a:ext cx="4236415" cy="201168"/>
-          </a:xfrm>
-          <a:prstGeom prst="rect">
-            <a:avLst/>
-          </a:prstGeom>
-          <a:noFill/>
-          <a:ln>
-            <a:noFill/>
-          </a:ln>
-        </p:spPr>
-        <p:txBody>
-          <a:bodyPr anchorCtr="0" anchor="ctr" bIns="0" lIns="0" spcFirstLastPara="1" rIns="0" wrap="square" tIns="0">
-            <a:noAutofit/>
-          </a:bodyPr>
-          <a:lstStyle/>
-          <a:p>
-            <a:pPr indent="0" lvl="0" marL="0" marR="0" rtl="0" algn="l">
-              <a:spcBef>
-                <a:spcPts val="0"/>
-              </a:spcBef>
-              <a:spcAft>
-                <a:spcPts val="0"/>
-              </a:spcAft>
-              <a:buClr>
-                <a:srgbClr val="65708A"/>
-              </a:buClr>
-              <a:buSzPts val="950"/>
-              <a:buFont typeface="Malgun Gothic"/>
-              <a:buNone/>
-            </a:pPr>
-            <a:r>
-              <a:rPr b="0" i="0" lang="en-US" sz="950" u="none" cap="none" strike="noStrike">
-                <a:solidFill>
-                  <a:srgbClr val="65708A"/>
-                </a:solidFill>
-                <a:latin typeface="Malgun Gothic"/>
-                <a:ea typeface="Malgun Gothic"/>
-                <a:cs typeface="Malgun Gothic"/>
-                <a:sym typeface="Malgun Gothic"/>
-              </a:rPr>
-              <a:t>다운로드에 남는 문답 수</a:t>
-            </a:r>
-            <a:endParaRPr b="0" i="0" sz="950" u="none" cap="none" strike="noStrike">
-              <a:solidFill>
-                <a:schemeClr val="dk1"/>
-              </a:solidFill>
-              <a:latin typeface="Calibri"/>
-              <a:ea typeface="Calibri"/>
-              <a:cs typeface="Calibri"/>
-              <a:sym typeface="Calibri"/>
-            </a:endParaRPr>
-          </a:p>
-        </p:txBody>
-      </p:sp>
-      <p:sp>
-        <p:nvSpPr>
-          <p:cNvPr id="414" name="Google Shape;414;p15"/>
-          <p:cNvSpPr/>
-          <p:nvPr/>
-        </p:nvSpPr>
-        <p:spPr>
-          <a:xfrm>
-            <a:off x="7150608" y="3493008"/>
-            <a:ext cx="1188720" cy="310896"/>
-          </a:xfrm>
-          <a:prstGeom prst="rect">
-            <a:avLst/>
-          </a:prstGeom>
-          <a:noFill/>
-          <a:ln>
-            <a:noFill/>
-          </a:ln>
-        </p:spPr>
-        <p:txBody>
-          <a:bodyPr anchorCtr="0" anchor="ctr" bIns="0" lIns="0" spcFirstLastPara="1" rIns="0" wrap="square" tIns="0">
-            <a:noAutofit/>
-          </a:bodyPr>
-          <a:lstStyle/>
-          <a:p>
-            <a:pPr indent="0" lvl="0" marL="0" marR="0" rtl="0" algn="l">
-              <a:spcBef>
-                <a:spcPts val="0"/>
-              </a:spcBef>
-              <a:spcAft>
-                <a:spcPts val="0"/>
-              </a:spcAft>
-              <a:buClr>
-                <a:srgbClr val="65708A"/>
-              </a:buClr>
-              <a:buSzPts val="1600"/>
-              <a:buFont typeface="Malgun Gothic"/>
-              <a:buNone/>
-            </a:pPr>
-            <a:r>
-              <a:rPr b="1" i="0" lang="en-US" sz="1600" u="none" cap="none" strike="noStrike">
-                <a:solidFill>
-                  <a:srgbClr val="65708A"/>
-                </a:solidFill>
-                <a:latin typeface="Malgun Gothic"/>
-                <a:ea typeface="Malgun Gothic"/>
-                <a:cs typeface="Malgun Gothic"/>
-                <a:sym typeface="Malgun Gothic"/>
-              </a:rPr>
-              <a:t>1턴</a:t>
-            </a:r>
-            <a:endParaRPr b="0" i="0" sz="1600" u="none" cap="none" strike="noStrike">
-              <a:solidFill>
-                <a:schemeClr val="dk1"/>
-              </a:solidFill>
-              <a:latin typeface="Calibri"/>
-              <a:ea typeface="Calibri"/>
-              <a:cs typeface="Calibri"/>
-              <a:sym typeface="Calibri"/>
-            </a:endParaRPr>
-          </a:p>
-        </p:txBody>
-      </p:sp>
-      <p:sp>
-        <p:nvSpPr>
-          <p:cNvPr id="415" name="Google Shape;415;p15"/>
-          <p:cNvSpPr/>
-          <p:nvPr/>
-        </p:nvSpPr>
-        <p:spPr>
-          <a:xfrm>
-            <a:off x="8339328" y="3602736"/>
-            <a:ext cx="237744" cy="128016"/>
-          </a:xfrm>
-          <a:prstGeom prst="rightArrow">
-            <a:avLst>
-              <a:gd fmla="val 50000" name="adj1"/>
-              <a:gd fmla="val 50000" name="adj2"/>
-            </a:avLst>
-          </a:prstGeom>
-          <a:solidFill>
-            <a:srgbClr val="65708A"/>
-          </a:solidFill>
-          <a:ln>
-            <a:noFill/>
-          </a:ln>
-        </p:spPr>
-        <p:txBody>
-          <a:bodyPr anchorCtr="0" anchor="ctr" bIns="91425" lIns="91425" spcFirstLastPara="1" rIns="91425" wrap="square" tIns="91425">
-            <a:noAutofit/>
-          </a:bodyPr>
-          <a:lstStyle/>
-          <a:p>
-            <a:pPr indent="0" lvl="0" marL="0" rtl="0" algn="l">
-              <a:spcBef>
-                <a:spcPts val="0"/>
-              </a:spcBef>
-              <a:spcAft>
-                <a:spcPts val="0"/>
-              </a:spcAft>
-              <a:buNone/>
-            </a:pPr>
-            <a:r>
-              <a:t/>
-            </a:r>
-            <a:endParaRPr/>
-          </a:p>
-        </p:txBody>
-      </p:sp>
-      <p:sp>
-        <p:nvSpPr>
-          <p:cNvPr id="416" name="Google Shape;416;p15"/>
-          <p:cNvSpPr/>
-          <p:nvPr/>
-        </p:nvSpPr>
-        <p:spPr>
-          <a:xfrm>
-            <a:off x="8686800" y="3493008"/>
-            <a:ext cx="1463040" cy="310896"/>
-          </a:xfrm>
-          <a:prstGeom prst="rect">
-            <a:avLst/>
-          </a:prstGeom>
-          <a:noFill/>
-          <a:ln>
-            <a:noFill/>
-          </a:ln>
-        </p:spPr>
-        <p:txBody>
-          <a:bodyPr anchorCtr="0" anchor="ctr" bIns="0" lIns="0" spcFirstLastPara="1" rIns="0" wrap="square" tIns="0">
-            <a:noAutofit/>
-          </a:bodyPr>
-          <a:lstStyle/>
-          <a:p>
-            <a:pPr indent="0" lvl="0" marL="0" marR="0" rtl="0" algn="l">
-              <a:spcBef>
-                <a:spcPts val="0"/>
-              </a:spcBef>
-              <a:spcAft>
-                <a:spcPts val="0"/>
-              </a:spcAft>
-              <a:buClr>
-                <a:srgbClr val="00A950"/>
-              </a:buClr>
-              <a:buSzPts val="1600"/>
-              <a:buFont typeface="Malgun Gothic"/>
-              <a:buNone/>
-            </a:pPr>
-            <a:r>
-              <a:rPr b="1" i="0" lang="en-US" sz="1600" u="none" cap="none" strike="noStrike">
-                <a:solidFill>
-                  <a:srgbClr val="00A950"/>
-                </a:solidFill>
-                <a:latin typeface="Malgun Gothic"/>
-                <a:ea typeface="Malgun Gothic"/>
-                <a:cs typeface="Malgun Gothic"/>
-                <a:sym typeface="Malgun Gothic"/>
-              </a:rPr>
-              <a:t>전체</a:t>
-            </a:r>
-            <a:endParaRPr b="0" i="0" sz="1600" u="none" cap="none" strike="noStrike">
-              <a:solidFill>
-                <a:schemeClr val="dk1"/>
-              </a:solidFill>
-              <a:latin typeface="Calibri"/>
-              <a:ea typeface="Calibri"/>
-              <a:cs typeface="Calibri"/>
-              <a:sym typeface="Calibri"/>
-            </a:endParaRPr>
-          </a:p>
-        </p:txBody>
-      </p:sp>
-      <p:sp>
-        <p:nvSpPr>
-          <p:cNvPr id="417" name="Google Shape;417;p15"/>
-          <p:cNvSpPr/>
-          <p:nvPr/>
-        </p:nvSpPr>
-        <p:spPr>
-          <a:xfrm>
-            <a:off x="6912864" y="4059936"/>
-            <a:ext cx="4711903" cy="969264"/>
-          </a:xfrm>
-          <a:prstGeom prst="roundRect">
-            <a:avLst>
-              <a:gd fmla="val 7547" name="adj"/>
-            </a:avLst>
-          </a:prstGeom>
-          <a:solidFill>
-            <a:srgbClr val="FFFFFF"/>
-          </a:solidFill>
-          <a:ln cap="flat" cmpd="sng" w="12700">
-            <a:solidFill>
-              <a:srgbClr val="DFE5EF"/>
-            </a:solidFill>
-            <a:prstDash val="solid"/>
-            <a:round/>
-            <a:headEnd len="sm" w="sm" type="none"/>
-            <a:tailEnd len="sm" w="sm" type="none"/>
-          </a:ln>
-          <a:effectLst>
-            <a:outerShdw blurRad="127000" rotWithShape="0" algn="bl" dir="5400000" dist="25400">
-              <a:srgbClr val="8894A8">
-                <a:alpha val="18039"/>
-              </a:srgbClr>
-            </a:outerShdw>
-          </a:effectLst>
-        </p:spPr>
-        <p:txBody>
-          <a:bodyPr anchorCtr="0" anchor="ctr" bIns="91425" lIns="91425" spcFirstLastPara="1" rIns="91425" wrap="square" tIns="91425">
-            <a:noAutofit/>
-          </a:bodyPr>
-          <a:lstStyle/>
-          <a:p>
-            <a:pPr indent="0" lvl="0" marL="0" rtl="0" algn="l">
-              <a:spcBef>
-                <a:spcPts val="0"/>
-              </a:spcBef>
-              <a:spcAft>
-                <a:spcPts val="0"/>
-              </a:spcAft>
-              <a:buNone/>
-            </a:pPr>
-            <a:r>
-              <a:t/>
-            </a:r>
-            <a:endParaRPr/>
-          </a:p>
-        </p:txBody>
-      </p:sp>
-      <p:sp>
-        <p:nvSpPr>
-          <p:cNvPr id="418" name="Google Shape;418;p15"/>
-          <p:cNvSpPr/>
-          <p:nvPr/>
-        </p:nvSpPr>
-        <p:spPr>
-          <a:xfrm>
-            <a:off x="7150608" y="4187952"/>
-            <a:ext cx="4236415" cy="237744"/>
-          </a:xfrm>
-          <a:prstGeom prst="rect">
-            <a:avLst/>
-          </a:prstGeom>
-          <a:noFill/>
-          <a:ln>
-            <a:noFill/>
-          </a:ln>
-        </p:spPr>
-        <p:txBody>
-          <a:bodyPr anchorCtr="0" anchor="ctr" bIns="0" lIns="0" spcFirstLastPara="1" rIns="0" wrap="square" tIns="0">
-            <a:noAutofit/>
-          </a:bodyPr>
-          <a:lstStyle/>
-          <a:p>
-            <a:pPr indent="0" lvl="0" marL="0" marR="0" rtl="0" algn="l">
-              <a:spcBef>
-                <a:spcPts val="0"/>
-              </a:spcBef>
-              <a:spcAft>
-                <a:spcPts val="0"/>
-              </a:spcAft>
-              <a:buClr>
-                <a:srgbClr val="002D5A"/>
-              </a:buClr>
-              <a:buSzPts val="1150"/>
-              <a:buFont typeface="Malgun Gothic"/>
-              <a:buNone/>
-            </a:pPr>
-            <a:r>
-              <a:rPr b="1" i="0" lang="en-US" sz="1150" u="none" cap="none" strike="noStrike">
-                <a:solidFill>
-                  <a:srgbClr val="002D5A"/>
-                </a:solidFill>
-                <a:latin typeface="Malgun Gothic"/>
-                <a:ea typeface="Malgun Gothic"/>
-                <a:cs typeface="Malgun Gothic"/>
-                <a:sym typeface="Malgun Gothic"/>
-              </a:rPr>
-              <a:t>막대 정렬 개선</a:t>
-            </a:r>
-            <a:endParaRPr b="0" i="0" sz="1150" u="none" cap="none" strike="noStrike">
-              <a:solidFill>
-                <a:schemeClr val="dk1"/>
-              </a:solidFill>
-              <a:latin typeface="Calibri"/>
-              <a:ea typeface="Calibri"/>
-              <a:cs typeface="Calibri"/>
-              <a:sym typeface="Calibri"/>
-            </a:endParaRPr>
-          </a:p>
-        </p:txBody>
-      </p:sp>
-      <p:sp>
-        <p:nvSpPr>
-          <p:cNvPr id="419" name="Google Shape;419;p15"/>
-          <p:cNvSpPr/>
-          <p:nvPr/>
-        </p:nvSpPr>
-        <p:spPr>
-          <a:xfrm>
-            <a:off x="7150608" y="4425696"/>
-            <a:ext cx="4236415" cy="201168"/>
-          </a:xfrm>
-          <a:prstGeom prst="rect">
-            <a:avLst/>
-          </a:prstGeom>
-          <a:noFill/>
-          <a:ln>
-            <a:noFill/>
-          </a:ln>
-        </p:spPr>
-        <p:txBody>
-          <a:bodyPr anchorCtr="0" anchor="ctr" bIns="0" lIns="0" spcFirstLastPara="1" rIns="0" wrap="square" tIns="0">
-            <a:noAutofit/>
-          </a:bodyPr>
-          <a:lstStyle/>
-          <a:p>
-            <a:pPr indent="0" lvl="0" marL="0" marR="0" rtl="0" algn="l">
-              <a:spcBef>
-                <a:spcPts val="0"/>
-              </a:spcBef>
-              <a:spcAft>
-                <a:spcPts val="0"/>
-              </a:spcAft>
-              <a:buClr>
-                <a:srgbClr val="65708A"/>
-              </a:buClr>
-              <a:buSzPts val="950"/>
-              <a:buFont typeface="Malgun Gothic"/>
-              <a:buNone/>
-            </a:pPr>
-            <a:r>
-              <a:rPr b="0" i="0" lang="en-US" sz="950" u="none" cap="none" strike="noStrike">
-                <a:solidFill>
-                  <a:srgbClr val="65708A"/>
-                </a:solidFill>
-                <a:latin typeface="Malgun Gothic"/>
-                <a:ea typeface="Malgun Gothic"/>
-                <a:cs typeface="Malgun Gothic"/>
-                <a:sym typeface="Malgun Gothic"/>
-              </a:rPr>
-              <a:t>문항별 막대 폭 편차</a:t>
-            </a:r>
-            <a:endParaRPr b="0" i="0" sz="950" u="none" cap="none" strike="noStrike">
-              <a:solidFill>
-                <a:schemeClr val="dk1"/>
-              </a:solidFill>
-              <a:latin typeface="Calibri"/>
-              <a:ea typeface="Calibri"/>
-              <a:cs typeface="Calibri"/>
-              <a:sym typeface="Calibri"/>
-            </a:endParaRPr>
-          </a:p>
-        </p:txBody>
-      </p:sp>
-      <p:sp>
-        <p:nvSpPr>
-          <p:cNvPr id="420" name="Google Shape;420;p15"/>
-          <p:cNvSpPr/>
-          <p:nvPr/>
-        </p:nvSpPr>
-        <p:spPr>
-          <a:xfrm>
-            <a:off x="7150608" y="4626864"/>
-            <a:ext cx="1188720" cy="310896"/>
-          </a:xfrm>
-          <a:prstGeom prst="rect">
-            <a:avLst/>
-          </a:prstGeom>
-          <a:noFill/>
-          <a:ln>
-            <a:noFill/>
-          </a:ln>
-        </p:spPr>
-        <p:txBody>
-          <a:bodyPr anchorCtr="0" anchor="ctr" bIns="0" lIns="0" spcFirstLastPara="1" rIns="0" wrap="square" tIns="0">
-            <a:noAutofit/>
-          </a:bodyPr>
-          <a:lstStyle/>
-          <a:p>
-            <a:pPr indent="0" lvl="0" marL="0" marR="0" rtl="0" algn="l">
-              <a:spcBef>
-                <a:spcPts val="0"/>
-              </a:spcBef>
-              <a:spcAft>
-                <a:spcPts val="0"/>
-              </a:spcAft>
-              <a:buClr>
-                <a:srgbClr val="65708A"/>
-              </a:buClr>
-              <a:buSzPts val="1600"/>
-              <a:buFont typeface="Malgun Gothic"/>
-              <a:buNone/>
-            </a:pPr>
-            <a:r>
-              <a:rPr b="1" i="0" lang="en-US" sz="1600" u="none" cap="none" strike="noStrike">
-                <a:solidFill>
-                  <a:srgbClr val="65708A"/>
-                </a:solidFill>
-                <a:latin typeface="Malgun Gothic"/>
-                <a:ea typeface="Malgun Gothic"/>
-                <a:cs typeface="Malgun Gothic"/>
-                <a:sym typeface="Malgun Gothic"/>
-              </a:rPr>
-              <a:t>3종</a:t>
-            </a:r>
-            <a:endParaRPr b="0" i="0" sz="1600" u="none" cap="none" strike="noStrike">
-              <a:solidFill>
-                <a:schemeClr val="dk1"/>
-              </a:solidFill>
-              <a:latin typeface="Calibri"/>
-              <a:ea typeface="Calibri"/>
-              <a:cs typeface="Calibri"/>
-              <a:sym typeface="Calibri"/>
-            </a:endParaRPr>
-          </a:p>
-        </p:txBody>
-      </p:sp>
-      <p:sp>
-        <p:nvSpPr>
-          <p:cNvPr id="421" name="Google Shape;421;p15"/>
-          <p:cNvSpPr/>
-          <p:nvPr/>
-        </p:nvSpPr>
-        <p:spPr>
-          <a:xfrm>
-            <a:off x="8339328" y="4736592"/>
-            <a:ext cx="237744" cy="128016"/>
-          </a:xfrm>
-          <a:prstGeom prst="rightArrow">
-            <a:avLst>
-              <a:gd fmla="val 50000" name="adj1"/>
-              <a:gd fmla="val 50000" name="adj2"/>
-            </a:avLst>
-          </a:prstGeom>
-          <a:solidFill>
-            <a:srgbClr val="65708A"/>
-          </a:solidFill>
-          <a:ln>
-            <a:noFill/>
-          </a:ln>
-        </p:spPr>
-        <p:txBody>
-          <a:bodyPr anchorCtr="0" anchor="ctr" bIns="91425" lIns="91425" spcFirstLastPara="1" rIns="91425" wrap="square" tIns="91425">
-            <a:noAutofit/>
-          </a:bodyPr>
-          <a:lstStyle/>
-          <a:p>
-            <a:pPr indent="0" lvl="0" marL="0" rtl="0" algn="l">
-              <a:spcBef>
-                <a:spcPts val="0"/>
-              </a:spcBef>
-              <a:spcAft>
-                <a:spcPts val="0"/>
-              </a:spcAft>
-              <a:buNone/>
-            </a:pPr>
-            <a:r>
-              <a:t/>
-            </a:r>
-            <a:endParaRPr/>
-          </a:p>
-        </p:txBody>
-      </p:sp>
-      <p:sp>
-        <p:nvSpPr>
-          <p:cNvPr id="422" name="Google Shape;422;p15"/>
-          <p:cNvSpPr/>
-          <p:nvPr/>
-        </p:nvSpPr>
-        <p:spPr>
-          <a:xfrm>
-            <a:off x="8686800" y="4626864"/>
-            <a:ext cx="1463040" cy="310896"/>
-          </a:xfrm>
-          <a:prstGeom prst="rect">
-            <a:avLst/>
-          </a:prstGeom>
-          <a:noFill/>
-          <a:ln>
-            <a:noFill/>
-          </a:ln>
-        </p:spPr>
-        <p:txBody>
-          <a:bodyPr anchorCtr="0" anchor="ctr" bIns="0" lIns="0" spcFirstLastPara="1" rIns="0" wrap="square" tIns="0">
-            <a:noAutofit/>
-          </a:bodyPr>
-          <a:lstStyle/>
-          <a:p>
-            <a:pPr indent="0" lvl="0" marL="0" marR="0" rtl="0" algn="l">
-              <a:spcBef>
-                <a:spcPts val="0"/>
-              </a:spcBef>
-              <a:spcAft>
-                <a:spcPts val="0"/>
-              </a:spcAft>
-              <a:buClr>
-                <a:srgbClr val="00A950"/>
-              </a:buClr>
-              <a:buSzPts val="1600"/>
-              <a:buFont typeface="Malgun Gothic"/>
-              <a:buNone/>
-            </a:pPr>
-            <a:r>
-              <a:rPr b="1" i="0" lang="en-US" sz="1600" u="none" cap="none" strike="noStrike">
-                <a:solidFill>
-                  <a:srgbClr val="00A950"/>
-                </a:solidFill>
-                <a:latin typeface="Malgun Gothic"/>
-                <a:ea typeface="Malgun Gothic"/>
-                <a:cs typeface="Malgun Gothic"/>
-                <a:sym typeface="Malgun Gothic"/>
-              </a:rPr>
-              <a:t>1종</a:t>
-            </a:r>
-            <a:endParaRPr b="0" i="0" sz="1600" u="none" cap="none" strike="noStrike">
-              <a:solidFill>
-                <a:schemeClr val="dk1"/>
-              </a:solidFill>
-              <a:latin typeface="Calibri"/>
-              <a:ea typeface="Calibri"/>
-              <a:cs typeface="Calibri"/>
-              <a:sym typeface="Calibri"/>
-            </a:endParaRPr>
-          </a:p>
-        </p:txBody>
-      </p:sp>
-      <p:sp>
-        <p:nvSpPr>
-          <p:cNvPr id="423" name="Google Shape;423;p15"/>
-          <p:cNvSpPr/>
-          <p:nvPr/>
-        </p:nvSpPr>
-        <p:spPr>
-          <a:xfrm>
-            <a:off x="566928" y="5321808"/>
-            <a:ext cx="11057839" cy="1024128"/>
-          </a:xfrm>
-          <a:prstGeom prst="roundRect">
-            <a:avLst>
-              <a:gd fmla="val 7143" name="adj"/>
-            </a:avLst>
-          </a:prstGeom>
-          <a:solidFill>
-            <a:srgbClr val="E8F1F8"/>
-          </a:solidFill>
-          <a:ln cap="flat" cmpd="sng" w="12700">
-            <a:solidFill>
-              <a:srgbClr val="DFE5EF"/>
-            </a:solidFill>
-            <a:prstDash val="solid"/>
-            <a:round/>
-            <a:headEnd len="sm" w="sm" type="none"/>
-            <a:tailEnd len="sm" w="sm" type="none"/>
-          </a:ln>
-          <a:effectLst>
-            <a:outerShdw blurRad="127000" rotWithShape="0" algn="bl" dir="5400000" dist="25400">
-              <a:srgbClr val="8894A8">
-                <a:alpha val="18039"/>
-              </a:srgbClr>
-            </a:outerShdw>
-          </a:effectLst>
-        </p:spPr>
-        <p:txBody>
-          <a:bodyPr anchorCtr="0" anchor="ctr" bIns="91425" lIns="91425" spcFirstLastPara="1" rIns="91425" wrap="square" tIns="91425">
-            <a:noAutofit/>
-          </a:bodyPr>
-          <a:lstStyle/>
-          <a:p>
-            <a:pPr indent="0" lvl="0" marL="0" rtl="0" algn="l">
-              <a:spcBef>
-                <a:spcPts val="0"/>
-              </a:spcBef>
-              <a:spcAft>
-                <a:spcPts val="0"/>
-              </a:spcAft>
-              <a:buNone/>
-            </a:pPr>
-            <a:r>
-              <a:t/>
-            </a:r>
-            <a:endParaRPr/>
-          </a:p>
-        </p:txBody>
-      </p:sp>
-      <p:sp>
-        <p:nvSpPr>
-          <p:cNvPr id="424" name="Google Shape;424;p15"/>
-          <p:cNvSpPr/>
-          <p:nvPr/>
-        </p:nvSpPr>
-        <p:spPr>
-          <a:xfrm>
-            <a:off x="859536" y="5468112"/>
-            <a:ext cx="10472623" cy="749808"/>
-          </a:xfrm>
-          <a:prstGeom prst="rect">
-            <a:avLst/>
-          </a:prstGeom>
-          <a:noFill/>
-          <a:ln>
-            <a:noFill/>
-          </a:ln>
-        </p:spPr>
-        <p:txBody>
-          <a:bodyPr anchorCtr="0" anchor="ctr" bIns="0" lIns="0" spcFirstLastPara="1" rIns="0" wrap="square" tIns="0">
-            <a:noAutofit/>
-          </a:bodyPr>
-          <a:lstStyle/>
-          <a:p>
-            <a:pPr indent="0" lvl="0" marL="0" marR="0" rtl="0" algn="l">
-              <a:lnSpc>
-                <a:spcPct val="147826"/>
-              </a:lnSpc>
-              <a:spcBef>
-                <a:spcPts val="0"/>
-              </a:spcBef>
-              <a:spcAft>
-                <a:spcPts val="0"/>
-              </a:spcAft>
-              <a:buClr>
-                <a:srgbClr val="172033"/>
-              </a:buClr>
-              <a:buSzPts val="1150"/>
-              <a:buFont typeface="Malgun Gothic"/>
-              <a:buNone/>
-            </a:pPr>
-            <a:r>
-              <a:rPr b="0" i="0" lang="en-US" sz="1150" u="none" cap="none" strike="noStrike">
-                <a:solidFill>
-                  <a:srgbClr val="172033"/>
-                </a:solidFill>
-                <a:latin typeface="Malgun Gothic"/>
-                <a:ea typeface="Malgun Gothic"/>
-                <a:cs typeface="Malgun Gothic"/>
-                <a:sym typeface="Malgun Gothic"/>
-              </a:rPr>
-              <a:t>시연 중 "대부분의 답변이 비슷한 수준이라 단조롭다"는 피드백 반영 → 조직×중분류마다 목표 편차(±13~17%p)를 부여해 더미 데이터 재생성 · 편차는 대분류 안에서 상쇄되도록 설계해 부서 전체 평균과 HR 화면의 부서 간 비교 결과는 그대로 유지</a:t>
-            </a:r>
-            <a:endParaRPr b="0" i="0" sz="1150" u="none" cap="none" strike="noStrike">
-              <a:solidFill>
-                <a:schemeClr val="dk1"/>
-              </a:solidFill>
-              <a:latin typeface="Calibri"/>
-              <a:ea typeface="Calibri"/>
-              <a:cs typeface="Calibri"/>
-              <a:sym typeface="Calibri"/>
-            </a:endParaRPr>
-          </a:p>
-        </p:txBody>
-      </p:sp>
-    </p:spTree>
-  </p:cSld>
-  <p:clrMapOvr>
-    <a:masterClrMapping/>
-  </p:clrMapOvr>
-</p:sld>
-</file>
-
 <file path=ppt/slides/slide14.xml><?xml version="1.0" encoding="utf-8"?>
 <p:sld xmlns:a="http://schemas.openxmlformats.org/drawingml/2006/main" xmlns:r="http://schemas.openxmlformats.org/officeDocument/2006/relationships" xmlns:mc="http://schemas.openxmlformats.org/markup-compatibility/2006" xmlns:mv="urn:schemas-microsoft-com:mac:vml" xmlns:p="http://schemas.openxmlformats.org/presentationml/2006/main" xmlns:c="http://schemas.openxmlformats.org/drawingml/2006/chart" xmlns:dgm="http://schemas.openxmlformats.org/drawingml/2006/diagram" xmlns:o="urn:schemas-microsoft-com:office:office" xmlns:v="urn:schemas-microsoft-com:vml" xmlns:pvml="urn:schemas-microsoft-com:office:powerpoint" xmlns:com="http://schemas.openxmlformats.org/drawingml/2006/compatibility" xmlns:p14="http://schemas.microsoft.com/office/powerpoint/2010/main" xmlns:p15="http://schemas.microsoft.com/office/powerpoint/2012/main" xmlns:ahyp="http://schemas.microsoft.com/office/drawing/2018/hyperlinkcolor">
   <p:cSld>
@@ -9039,7 +7007,7 @@
                 <a:cs typeface="Malgun Gothic"/>
                 <a:sym typeface="Malgun Gothic"/>
               </a:rPr>
-              <a:t>10</a:t>
+              <a:t>9</a:t>
             </a:r>
             <a:endParaRPr b="0" i="0" sz="1000" u="none" cap="none" strike="noStrike">
               <a:solidFill>
@@ -11070,7 +9038,7 @@
                 <a:cs typeface="Malgun Gothic"/>
                 <a:sym typeface="Malgun Gothic"/>
               </a:rPr>
-              <a:t>11</a:t>
+              <a:t>10</a:t>
             </a:r>
             <a:endParaRPr b="0" i="0" sz="1000" u="none" cap="none" strike="noStrike">
               <a:solidFill>
@@ -12990,7 +10958,7 @@
         <p:spPr>
           <a:xfrm>
             <a:off x="566925" y="2286000"/>
-            <a:ext cx="9805800" cy="2299800"/>
+            <a:ext cx="11055096" cy="2299800"/>
           </a:xfrm>
           <a:prstGeom prst="rect">
             <a:avLst/>
@@ -13024,7 +10992,7 @@
               <a:buNone/>
             </a:pPr>
             <a:r>
-              <a:rPr b="1" i="0" lang="en-US" sz="3800" u="none" cap="none" strike="noStrike">
+              <a:rPr b="1" i="0" lang="en-US" sz="3400" u="none" cap="none" strike="noStrike">
                 <a:solidFill>
                   <a:srgbClr val="FFFFFF"/>
                 </a:solidFill>
@@ -13033,7 +11001,7 @@
                 <a:cs typeface="Malgun Gothic"/>
                 <a:sym typeface="Malgun Gothic"/>
               </a:rPr>
-              <a:t>"부서장에게 우리 조직의</a:t>
+              <a:t>"우리 조직의 건강도 진단 결과를 구체적으로 전달하고,</a:t>
             </a:r>
             <a:endParaRPr b="0" i="0" sz="3800" u="none" cap="none" strike="noStrike">
               <a:solidFill>
@@ -13064,7 +11032,7 @@
               <a:buNone/>
             </a:pPr>
             <a:r>
-              <a:rPr b="1" lang="en-US" sz="3800">
+              <a:rPr b="1" lang="en-US" sz="3400">
                 <a:solidFill>
                   <a:srgbClr val="FFFFFF"/>
                 </a:solidFill>
@@ -13073,7 +11041,7 @@
                 <a:cs typeface="Malgun Gothic"/>
                 <a:sym typeface="Malgun Gothic"/>
               </a:rPr>
-              <a:t>  건강도를 최대한 구체적으로 전달한다."</a:t>
+              <a:t>  조직 운영을 위한 가이드를 제공한다"</a:t>
             </a:r>
             <a:endParaRPr b="1" sz="3800">
               <a:solidFill>

</xml_diff>

<commit_message>
docs: raise the deck to the audience's altitude
ARCHITECTURE slide removed; DETAIL loses its 근거 위치 / 3단 폴백 / 대화 기록
boxes; TECH STACK loses the lines/commits/docs/records row; NEXT STEPS
reworded from operator vocabulary into the user's. Surviving body copy
enlarged to 14pt with cards extended so the reclaimed space is filled.
12 slides -> 11.

Co-Authored-By: Claude Opus 5 <noreply@anthropic.com>
</commit_message>
<xml_diff>
--- a/Org_health_diag/docs/2026_조직건강도_AI_Agent_수행결과.pptx
+++ b/Org_health_diag/docs/2026_조직건강도_AI_Agent_수행결과.pptx
@@ -12,7 +12,6 @@
     <p:sldId id="257" r:id="rId6"/>
     <p:sldId id="258" r:id="rId7"/>
     <p:sldId id="259" r:id="rId8"/>
-    <p:sldId id="260" r:id="rId9"/>
     <p:sldId id="261" r:id="rId10"/>
     <p:sldId id="262" r:id="rId11"/>
     <p:sldId id="263" r:id="rId12"/>
@@ -2645,164 +2644,6 @@
       <p:sp>
         <p:nvSpPr>
           <p:cNvPr id="92" name="Google Shape;92;p4:notes"/>
-          <p:cNvSpPr txBox="1"/>
-          <p:nvPr>
-            <p:ph idx="12" type="sldNum"/>
-          </p:nvPr>
-        </p:nvSpPr>
-        <p:spPr>
-          <a:xfrm>
-            <a:off x="3884613" y="8685213"/>
-            <a:ext cx="2971800" cy="458787"/>
-          </a:xfrm>
-          <a:prstGeom prst="rect">
-            <a:avLst/>
-          </a:prstGeom>
-          <a:noFill/>
-          <a:ln>
-            <a:noFill/>
-          </a:ln>
-        </p:spPr>
-        <p:txBody>
-          <a:bodyPr anchorCtr="0" anchor="b" bIns="45700" lIns="91425" spcFirstLastPara="1" rIns="91425" wrap="square" tIns="45700">
-            <a:noAutofit/>
-          </a:bodyPr>
-          <a:lstStyle/>
-          <a:p>
-            <a:pPr indent="0" lvl="0" marL="0" rtl="0" algn="r">
-              <a:spcBef>
-                <a:spcPts val="0"/>
-              </a:spcBef>
-              <a:spcAft>
-                <a:spcPts val="0"/>
-              </a:spcAft>
-              <a:buNone/>
-            </a:pPr>
-            <a:fld id="{00000000-1234-1234-1234-123412341234}" type="slidenum">
-              <a:rPr lang="en-US"/>
-              <a:t>‹#›</a:t>
-            </a:fld>
-            <a:endParaRPr/>
-          </a:p>
-        </p:txBody>
-      </p:sp>
-    </p:spTree>
-  </p:cSld>
-  <p:clrMapOvr>
-    <a:masterClrMapping/>
-  </p:clrMapOvr>
-</p:notes>
-</file>
-
-<file path=ppt/notesSlides/notesSlide5.xml><?xml version="1.0" encoding="utf-8"?>
-<p:notes xmlns:a="http://schemas.openxmlformats.org/drawingml/2006/main" xmlns:r="http://schemas.openxmlformats.org/officeDocument/2006/relationships" xmlns:mc="http://schemas.openxmlformats.org/markup-compatibility/2006" xmlns:mv="urn:schemas-microsoft-com:mac:vml" xmlns:p="http://schemas.openxmlformats.org/presentationml/2006/main" xmlns:c="http://schemas.openxmlformats.org/drawingml/2006/chart" xmlns:dgm="http://schemas.openxmlformats.org/drawingml/2006/diagram" xmlns:o="urn:schemas-microsoft-com:office:office" xmlns:v="urn:schemas-microsoft-com:vml" xmlns:pvml="urn:schemas-microsoft-com:office:powerpoint" xmlns:com="http://schemas.openxmlformats.org/drawingml/2006/compatibility" xmlns:p14="http://schemas.microsoft.com/office/powerpoint/2010/main" xmlns:p15="http://schemas.microsoft.com/office/powerpoint/2012/main" xmlns:ahyp="http://schemas.microsoft.com/office/drawing/2018/hyperlinkcolor" showMasterPhAnim="0" showMasterSp="0">
-  <p:cSld>
-    <p:spTree>
-      <p:nvGrpSpPr>
-        <p:cNvPr id="117" name="Shape 117"/>
-        <p:cNvGrpSpPr/>
-        <p:nvPr/>
-      </p:nvGrpSpPr>
-      <p:grpSpPr>
-        <a:xfrm>
-          <a:off x="0" y="0"/>
-          <a:ext cx="0" cy="0"/>
-          <a:chOff x="0" y="0"/>
-          <a:chExt cx="0" cy="0"/>
-        </a:xfrm>
-      </p:grpSpPr>
-      <p:sp>
-        <p:nvSpPr>
-          <p:cNvPr id="118" name="Google Shape;118;p5:notes"/>
-          <p:cNvSpPr/>
-          <p:nvPr>
-            <p:ph idx="2" type="sldImg"/>
-          </p:nvPr>
-        </p:nvSpPr>
-        <p:spPr>
-          <a:xfrm>
-            <a:off x="685800" y="1143000"/>
-            <a:ext cx="5486400" cy="3086100"/>
-          </a:xfrm>
-          <a:custGeom>
-            <a:rect b="b" l="l" r="r" t="t"/>
-            <a:pathLst>
-              <a:path extrusionOk="0" h="120000" w="120000">
-                <a:moveTo>
-                  <a:pt x="0" y="0"/>
-                </a:moveTo>
-                <a:lnTo>
-                  <a:pt x="120000" y="0"/>
-                </a:lnTo>
-                <a:lnTo>
-                  <a:pt x="120000" y="120000"/>
-                </a:lnTo>
-                <a:lnTo>
-                  <a:pt x="0" y="120000"/>
-                </a:lnTo>
-                <a:close/>
-              </a:path>
-            </a:pathLst>
-          </a:custGeom>
-          <a:noFill/>
-          <a:ln cap="flat" cmpd="sng" w="12700">
-            <a:solidFill>
-              <a:srgbClr val="000000"/>
-            </a:solidFill>
-            <a:prstDash val="solid"/>
-            <a:round/>
-            <a:headEnd len="sm" w="sm" type="none"/>
-            <a:tailEnd len="sm" w="sm" type="none"/>
-          </a:ln>
-        </p:spPr>
-      </p:sp>
-      <p:sp>
-        <p:nvSpPr>
-          <p:cNvPr id="119" name="Google Shape;119;p5:notes"/>
-          <p:cNvSpPr txBox="1"/>
-          <p:nvPr>
-            <p:ph idx="1" type="body"/>
-          </p:nvPr>
-        </p:nvSpPr>
-        <p:spPr>
-          <a:xfrm>
-            <a:off x="685800" y="4400550"/>
-            <a:ext cx="5486400" cy="3600450"/>
-          </a:xfrm>
-          <a:prstGeom prst="rect">
-            <a:avLst/>
-          </a:prstGeom>
-          <a:noFill/>
-          <a:ln>
-            <a:noFill/>
-          </a:ln>
-        </p:spPr>
-        <p:txBody>
-          <a:bodyPr anchorCtr="0" anchor="t" bIns="45700" lIns="91425" spcFirstLastPara="1" rIns="91425" wrap="square" tIns="45700">
-            <a:noAutofit/>
-          </a:bodyPr>
-          <a:lstStyle/>
-          <a:p>
-            <a:pPr indent="0" lvl="0" marL="0" rtl="0" algn="l">
-              <a:spcBef>
-                <a:spcPts val="0"/>
-              </a:spcBef>
-              <a:spcAft>
-                <a:spcPts val="0"/>
-              </a:spcAft>
-              <a:buNone/>
-            </a:pPr>
-            <a:r>
-              <a:rPr lang="en-US"/>
-              <a:t>3계층 구조. 해석 사전을 공유해 두 프론트엔드가 같은 문장을 내보냅니다.</a:t>
-            </a:r>
-            <a:endParaRPr/>
-          </a:p>
-        </p:txBody>
-      </p:sp>
-      <p:sp>
-        <p:nvSpPr>
-          <p:cNvPr id="120" name="Google Shape;120;p5:notes"/>
           <p:cNvSpPr txBox="1"/>
           <p:nvPr>
             <p:ph idx="12" type="sldNum"/>
@@ -4500,7 +4341,7 @@
                 <a:cs typeface="Malgun Gothic"/>
                 <a:sym typeface="Malgun Gothic"/>
               </a:rPr>
-              <a:t>8</a:t>
+              <a:t>7</a:t>
             </a:r>
             <a:endParaRPr b="0" i="0" sz="1000" u="none" cap="none" strike="noStrike">
               <a:solidFill>
@@ -4688,8 +4529,8 @@
         </p:nvSpPr>
         <p:spPr>
           <a:xfrm>
-            <a:off x="822960" y="2103120"/>
-            <a:ext cx="2954426" cy="640080"/>
+            <a:off x="822960" y="2139696"/>
+            <a:ext cx="2954426" cy="768096"/>
           </a:xfrm>
           <a:prstGeom prst="rect">
             <a:avLst/>
@@ -4723,7 +4564,7 @@
               <a:buNone/>
             </a:pPr>
             <a:r>
-              <a:rPr b="1" i="0" lang="en-US" sz="1350" u="none" cap="none" strike="noStrike">
+              <a:rPr b="1" i="0" lang="en-US" sz="1500" u="none" cap="none" strike="noStrike">
                 <a:solidFill>
                   <a:srgbClr val="002D5A"/>
                 </a:solidFill>
@@ -4754,8 +4595,8 @@
         </p:nvSpPr>
         <p:spPr>
           <a:xfrm>
-            <a:off x="822960" y="2779776"/>
-            <a:ext cx="2954426" cy="219456"/>
+            <a:off x="822960" y="3017520"/>
+            <a:ext cx="2954426" cy="256032"/>
           </a:xfrm>
           <a:prstGeom prst="rect">
             <a:avLst/>
@@ -4786,7 +4627,7 @@
               <a:buNone/>
             </a:pPr>
             <a:r>
-              <a:rPr b="1" i="0" lang="en-US" sz="1000" u="none" cap="none" strike="noStrike">
+              <a:rPr b="1" i="0" lang="en-US" sz="1100" u="none" cap="none" strike="noStrike">
                 <a:solidFill>
                   <a:srgbClr val="65708A"/>
                 </a:solidFill>
@@ -4817,8 +4658,8 @@
         </p:nvSpPr>
         <p:spPr>
           <a:xfrm>
-            <a:off x="822960" y="3017520"/>
-            <a:ext cx="2954426" cy="1225296"/>
+            <a:off x="822960" y="3310128"/>
+            <a:ext cx="2954426" cy="2084831"/>
           </a:xfrm>
           <a:prstGeom prst="rect">
             <a:avLst/>
@@ -4852,7 +4693,7 @@
               <a:buChar char="•"/>
             </a:pPr>
             <a:r>
-              <a:rPr b="0" i="0" lang="en-US" sz="1100" u="none" cap="none" strike="noStrike">
+              <a:rPr b="0" i="0" lang="en-US" sz="1400" u="none" cap="none" strike="noStrike">
                 <a:solidFill>
                   <a:srgbClr val="172033"/>
                 </a:solidFill>
@@ -4879,7 +4720,7 @@
                 <a:spcPct val="100000"/>
               </a:lnSpc>
               <a:spcBef>
-                <a:spcPts val="200"/>
+                <a:spcPts val="600"/>
               </a:spcBef>
               <a:spcAft>
                 <a:spcPts val="0"/>
@@ -4892,7 +4733,7 @@
               <a:buChar char="•"/>
             </a:pPr>
             <a:r>
-              <a:rPr b="0" i="0" lang="en-US" sz="1100" u="none" cap="none" strike="noStrike">
+              <a:rPr b="0" i="0" lang="en-US" sz="1400" u="none" cap="none" strike="noStrike">
                 <a:solidFill>
                   <a:srgbClr val="172033"/>
                 </a:solidFill>
@@ -4919,7 +4760,7 @@
                 <a:spcPct val="100000"/>
               </a:lnSpc>
               <a:spcBef>
-                <a:spcPts val="200"/>
+                <a:spcPts val="600"/>
               </a:spcBef>
               <a:spcAft>
                 <a:spcPts val="0"/>
@@ -4932,7 +4773,7 @@
               <a:buChar char="•"/>
             </a:pPr>
             <a:r>
-              <a:rPr b="0" i="0" lang="en-US" sz="1100" u="none" cap="none" strike="noStrike">
+              <a:rPr b="0" i="0" lang="en-US" sz="1400" u="none" cap="none" strike="noStrike">
                 <a:solidFill>
                   <a:srgbClr val="172033"/>
                 </a:solidFill>
@@ -4959,7 +4800,7 @@
                 <a:spcPct val="100000"/>
               </a:lnSpc>
               <a:spcBef>
-                <a:spcPts val="200"/>
+                <a:spcPts val="600"/>
               </a:spcBef>
               <a:spcAft>
                 <a:spcPts val="0"/>
@@ -4972,7 +4813,7 @@
               <a:buChar char="•"/>
             </a:pPr>
             <a:r>
-              <a:rPr b="0" i="0" lang="en-US" sz="1100" u="none" cap="none" strike="noStrike">
+              <a:rPr b="0" i="0" lang="en-US" sz="1400" u="none" cap="none" strike="noStrike">
                 <a:solidFill>
                   <a:srgbClr val="172033"/>
                 </a:solidFill>
@@ -4999,7 +4840,7 @@
                 <a:spcPct val="100000"/>
               </a:lnSpc>
               <a:spcBef>
-                <a:spcPts val="200"/>
+                <a:spcPts val="600"/>
               </a:spcBef>
               <a:spcAft>
                 <a:spcPts val="0"/>
@@ -5012,7 +4853,7 @@
               <a:buChar char="•"/>
             </a:pPr>
             <a:r>
-              <a:rPr b="0" i="0" lang="en-US" sz="1100" u="none" cap="none" strike="noStrike">
+              <a:rPr b="0" i="0" lang="en-US" sz="1400" u="none" cap="none" strike="noStrike">
                 <a:solidFill>
                   <a:srgbClr val="172033"/>
                 </a:solidFill>
@@ -5039,7 +4880,7 @@
                 <a:spcPct val="100000"/>
               </a:lnSpc>
               <a:spcBef>
-                <a:spcPts val="200"/>
+                <a:spcPts val="600"/>
               </a:spcBef>
               <a:spcAft>
                 <a:spcPts val="0"/>
@@ -5052,7 +4893,7 @@
               <a:buChar char="•"/>
             </a:pPr>
             <a:r>
-              <a:rPr b="0" i="0" lang="en-US" sz="1100" u="none" cap="none" strike="noStrike">
+              <a:rPr b="0" i="0" lang="en-US" sz="1400" u="none" cap="none" strike="noStrike">
                 <a:solidFill>
                   <a:srgbClr val="172033"/>
                 </a:solidFill>
@@ -5064,220 +4905,6 @@
               <a:t>로그인·챗봇·다운로드 전량 로깅</a:t>
             </a:r>
             <a:endParaRPr b="0" i="0" sz="1100" u="none" cap="none" strike="noStrike">
-              <a:solidFill>
-                <a:schemeClr val="dk1"/>
-              </a:solidFill>
-              <a:latin typeface="Calibri"/>
-              <a:ea typeface="Calibri"/>
-              <a:cs typeface="Calibri"/>
-              <a:sym typeface="Calibri"/>
-            </a:endParaRPr>
-          </a:p>
-        </p:txBody>
-      </p:sp>
-      <p:sp>
-        <p:nvSpPr>
-          <p:cNvPr id="336" name="Google Shape;336;p13"/>
-          <p:cNvSpPr/>
-          <p:nvPr/>
-        </p:nvSpPr>
-        <p:spPr>
-          <a:xfrm>
-            <a:off x="822960" y="4315968"/>
-            <a:ext cx="2954426" cy="1188720"/>
-          </a:xfrm>
-          <a:prstGeom prst="roundRect">
-            <a:avLst>
-              <a:gd fmla="val 4667" name="adj"/>
-            </a:avLst>
-          </a:prstGeom>
-          <a:solidFill>
-            <a:srgbClr val="E8F1F8"/>
-          </a:solidFill>
-          <a:ln>
-            <a:noFill/>
-          </a:ln>
-        </p:spPr>
-        <p:txBody>
-          <a:bodyPr anchorCtr="0" anchor="ctr" bIns="91425" lIns="91425" spcFirstLastPara="1" rIns="91425" wrap="square" tIns="91425">
-            <a:noAutofit/>
-          </a:bodyPr>
-          <a:lstStyle/>
-          <a:p>
-            <a:pPr indent="0" lvl="0" marL="0" rtl="0" algn="l">
-              <a:spcBef>
-                <a:spcPts val="0"/>
-              </a:spcBef>
-              <a:spcAft>
-                <a:spcPts val="0"/>
-              </a:spcAft>
-              <a:buNone/>
-            </a:pPr>
-            <a:r>
-              <a:t/>
-            </a:r>
-            <a:endParaRPr/>
-          </a:p>
-        </p:txBody>
-      </p:sp>
-      <p:sp>
-        <p:nvSpPr>
-          <p:cNvPr id="337" name="Google Shape;337;p13"/>
-          <p:cNvSpPr/>
-          <p:nvPr/>
-        </p:nvSpPr>
-        <p:spPr>
-          <a:xfrm>
-            <a:off x="987552" y="4425696"/>
-            <a:ext cx="2625242" cy="219456"/>
-          </a:xfrm>
-          <a:prstGeom prst="rect">
-            <a:avLst/>
-          </a:prstGeom>
-          <a:noFill/>
-          <a:ln>
-            <a:noFill/>
-          </a:ln>
-        </p:spPr>
-        <p:txBody>
-          <a:bodyPr anchorCtr="0" anchor="ctr" bIns="0" lIns="0" spcFirstLastPara="1" rIns="0" wrap="square" tIns="0">
-            <a:noAutofit/>
-          </a:bodyPr>
-          <a:lstStyle/>
-          <a:p>
-            <a:pPr indent="0" lvl="0" marL="0" marR="0" rtl="0" algn="l">
-              <a:spcBef>
-                <a:spcPts val="0"/>
-              </a:spcBef>
-              <a:spcAft>
-                <a:spcPts val="0"/>
-              </a:spcAft>
-              <a:buClr>
-                <a:srgbClr val="004381"/>
-              </a:buClr>
-              <a:buSzPts val="1000"/>
-              <a:buFont typeface="Malgun Gothic"/>
-              <a:buNone/>
-            </a:pPr>
-            <a:r>
-              <a:rPr b="1" i="0" lang="en-US" sz="1000" u="none" cap="none" strike="noStrike">
-                <a:solidFill>
-                  <a:srgbClr val="004381"/>
-                </a:solidFill>
-                <a:latin typeface="Malgun Gothic"/>
-                <a:ea typeface="Malgun Gothic"/>
-                <a:cs typeface="Malgun Gothic"/>
-                <a:sym typeface="Malgun Gothic"/>
-              </a:rPr>
-              <a:t>근거 위치</a:t>
-            </a:r>
-            <a:endParaRPr b="0" i="0" sz="1000" u="none" cap="none" strike="noStrike">
-              <a:solidFill>
-                <a:schemeClr val="dk1"/>
-              </a:solidFill>
-              <a:latin typeface="Calibri"/>
-              <a:ea typeface="Calibri"/>
-              <a:cs typeface="Calibri"/>
-              <a:sym typeface="Calibri"/>
-            </a:endParaRPr>
-          </a:p>
-        </p:txBody>
-      </p:sp>
-      <p:sp>
-        <p:nvSpPr>
-          <p:cNvPr id="338" name="Google Shape;338;p13"/>
-          <p:cNvSpPr/>
-          <p:nvPr/>
-        </p:nvSpPr>
-        <p:spPr>
-          <a:xfrm>
-            <a:off x="987552" y="4681728"/>
-            <a:ext cx="2625242" cy="731520"/>
-          </a:xfrm>
-          <a:prstGeom prst="rect">
-            <a:avLst/>
-          </a:prstGeom>
-          <a:noFill/>
-          <a:ln>
-            <a:noFill/>
-          </a:ln>
-        </p:spPr>
-        <p:txBody>
-          <a:bodyPr anchorCtr="0" anchor="ctr" bIns="0" lIns="0" spcFirstLastPara="1" rIns="0" wrap="square" tIns="0">
-            <a:noAutofit/>
-          </a:bodyPr>
-          <a:lstStyle/>
-          <a:p>
-            <a:pPr indent="-171450" lvl="0" marL="171450" marR="0" rtl="0" algn="l">
-              <a:lnSpc>
-                <a:spcPct val="100000"/>
-              </a:lnSpc>
-              <a:spcBef>
-                <a:spcPts val="0"/>
-              </a:spcBef>
-              <a:spcAft>
-                <a:spcPts val="0"/>
-              </a:spcAft>
-              <a:buClr>
-                <a:srgbClr val="172033"/>
-              </a:buClr>
-              <a:buSzPts val="1050"/>
-              <a:buFont typeface="Malgun Gothic"/>
-              <a:buChar char="•"/>
-            </a:pPr>
-            <a:r>
-              <a:rPr b="0" i="0" lang="en-US" sz="1050" u="none" cap="none" strike="noStrike">
-                <a:solidFill>
-                  <a:srgbClr val="172033"/>
-                </a:solidFill>
-                <a:latin typeface="Malgun Gothic"/>
-                <a:ea typeface="Malgun Gothic"/>
-                <a:cs typeface="Malgun Gothic"/>
-                <a:sym typeface="Malgun Gothic"/>
-              </a:rPr>
-              <a:t>설계 단계 스키마 미포함 · is_suppressed() 게이트</a:t>
-            </a:r>
-            <a:endParaRPr b="0" i="0" sz="1050" u="none" cap="none" strike="noStrike">
-              <a:solidFill>
-                <a:schemeClr val="dk1"/>
-              </a:solidFill>
-              <a:latin typeface="Calibri"/>
-              <a:ea typeface="Calibri"/>
-              <a:cs typeface="Calibri"/>
-              <a:sym typeface="Calibri"/>
-            </a:endParaRPr>
-          </a:p>
-          <a:p>
-            <a:pPr indent="-171450" lvl="0" marL="171450" marR="0" rtl="0" algn="l">
-              <a:lnSpc>
-                <a:spcPct val="100000"/>
-              </a:lnSpc>
-              <a:spcBef>
-                <a:spcPts val="200"/>
-              </a:spcBef>
-              <a:spcAft>
-                <a:spcPts val="0"/>
-              </a:spcAft>
-              <a:buClr>
-                <a:srgbClr val="172033"/>
-              </a:buClr>
-              <a:buSzPts val="1050"/>
-              <a:buFont typeface="Malgun Gothic"/>
-              <a:buChar char="•"/>
-            </a:pPr>
-            <a:r>
-              <a:rPr b="0" i="0" lang="en-US" sz="1050" u="none" cap="none" strike="noStrike">
-                <a:solidFill>
-                  <a:srgbClr val="172033"/>
-                </a:solidFill>
-                <a:latin typeface="Malgun Gothic"/>
-                <a:ea typeface="Malgun Gothic"/>
-                <a:cs typeface="Malgun Gothic"/>
-                <a:sym typeface="Malgun Gothic"/>
-              </a:rPr>
-              <a:t>catalog.MID_INTERPRETATION · access_logs 테이블</a:t>
-            </a:r>
-            <a:endParaRPr b="0" i="0" sz="1050" u="none" cap="none" strike="noStrike">
               <a:solidFill>
                 <a:schemeClr val="dk1"/>
               </a:solidFill>
@@ -5463,8 +5090,8 @@
         </p:nvSpPr>
         <p:spPr>
           <a:xfrm>
-            <a:off x="4618634" y="2103120"/>
-            <a:ext cx="2954426" cy="640080"/>
+            <a:off x="4618634" y="2139696"/>
+            <a:ext cx="2954426" cy="768096"/>
           </a:xfrm>
           <a:prstGeom prst="rect">
             <a:avLst/>
@@ -5498,7 +5125,7 @@
               <a:buNone/>
             </a:pPr>
             <a:r>
-              <a:rPr b="1" i="0" lang="en-US" sz="1350" u="none" cap="none" strike="noStrike">
+              <a:rPr b="1" i="0" lang="en-US" sz="1500" u="none" cap="none" strike="noStrike">
                 <a:solidFill>
                   <a:srgbClr val="002D5A"/>
                 </a:solidFill>
@@ -5529,8 +5156,8 @@
         </p:nvSpPr>
         <p:spPr>
           <a:xfrm>
-            <a:off x="4618634" y="2779776"/>
-            <a:ext cx="2954426" cy="219456"/>
+            <a:off x="4618634" y="3017520"/>
+            <a:ext cx="2954426" cy="256032"/>
           </a:xfrm>
           <a:prstGeom prst="rect">
             <a:avLst/>
@@ -5561,7 +5188,7 @@
               <a:buNone/>
             </a:pPr>
             <a:r>
-              <a:rPr b="1" i="0" lang="en-US" sz="1000" u="none" cap="none" strike="noStrike">
+              <a:rPr b="1" i="0" lang="en-US" sz="1100" u="none" cap="none" strike="noStrike">
                 <a:solidFill>
                   <a:srgbClr val="65708A"/>
                 </a:solidFill>
@@ -5592,8 +5219,8 @@
         </p:nvSpPr>
         <p:spPr>
           <a:xfrm>
-            <a:off x="4618634" y="3017520"/>
-            <a:ext cx="2954426" cy="1225296"/>
+            <a:off x="4618634" y="3310128"/>
+            <a:ext cx="2954426" cy="2084831"/>
           </a:xfrm>
           <a:prstGeom prst="rect">
             <a:avLst/>
@@ -5627,7 +5254,7 @@
               <a:buChar char="•"/>
             </a:pPr>
             <a:r>
-              <a:rPr b="0" i="0" lang="en-US" sz="1100" u="none" cap="none" strike="noStrike">
+              <a:rPr b="0" i="0" lang="en-US" sz="1400" u="none" cap="none" strike="noStrike">
                 <a:solidFill>
                   <a:srgbClr val="172033"/>
                 </a:solidFill>
@@ -5654,7 +5281,7 @@
                 <a:spcPct val="100000"/>
               </a:lnSpc>
               <a:spcBef>
-                <a:spcPts val="200"/>
+                <a:spcPts val="600"/>
               </a:spcBef>
               <a:spcAft>
                 <a:spcPts val="0"/>
@@ -5667,7 +5294,7 @@
               <a:buChar char="•"/>
             </a:pPr>
             <a:r>
-              <a:rPr b="0" i="0" lang="en-US" sz="1100" u="none" cap="none" strike="noStrike">
+              <a:rPr b="0" i="0" lang="en-US" sz="1400" u="none" cap="none" strike="noStrike">
                 <a:solidFill>
                   <a:srgbClr val="172033"/>
                 </a:solidFill>
@@ -5694,7 +5321,7 @@
                 <a:spcPct val="100000"/>
               </a:lnSpc>
               <a:spcBef>
-                <a:spcPts val="200"/>
+                <a:spcPts val="600"/>
               </a:spcBef>
               <a:spcAft>
                 <a:spcPts val="0"/>
@@ -5707,7 +5334,7 @@
               <a:buChar char="•"/>
             </a:pPr>
             <a:r>
-              <a:rPr b="0" i="0" lang="en-US" sz="1100" u="none" cap="none" strike="noStrike">
+              <a:rPr b="0" i="0" lang="en-US" sz="1400" u="none" cap="none" strike="noStrike">
                 <a:solidFill>
                   <a:srgbClr val="172033"/>
                 </a:solidFill>
@@ -5734,7 +5361,7 @@
                 <a:spcPct val="100000"/>
               </a:lnSpc>
               <a:spcBef>
-                <a:spcPts val="200"/>
+                <a:spcPts val="600"/>
               </a:spcBef>
               <a:spcAft>
                 <a:spcPts val="0"/>
@@ -5747,7 +5374,7 @@
               <a:buChar char="•"/>
             </a:pPr>
             <a:r>
-              <a:rPr b="0" i="0" lang="en-US" sz="1100" u="none" cap="none" strike="noStrike">
+              <a:rPr b="0" i="0" lang="en-US" sz="1400" u="none" cap="none" strike="noStrike">
                 <a:solidFill>
                   <a:srgbClr val="172033"/>
                 </a:solidFill>
@@ -5774,7 +5401,7 @@
                 <a:spcPct val="100000"/>
               </a:lnSpc>
               <a:spcBef>
-                <a:spcPts val="200"/>
+                <a:spcPts val="600"/>
               </a:spcBef>
               <a:spcAft>
                 <a:spcPts val="0"/>
@@ -5787,7 +5414,7 @@
               <a:buChar char="•"/>
             </a:pPr>
             <a:r>
-              <a:rPr b="0" i="0" lang="en-US" sz="1100" u="none" cap="none" strike="noStrike">
+              <a:rPr b="0" i="0" lang="en-US" sz="1400" u="none" cap="none" strike="noStrike">
                 <a:solidFill>
                   <a:srgbClr val="172033"/>
                 </a:solidFill>
@@ -5799,220 +5426,6 @@
               <a:t>→ 비교 대상이 부서 내부에 한정</a:t>
             </a:r>
             <a:endParaRPr b="0" i="0" sz="1100" u="none" cap="none" strike="noStrike">
-              <a:solidFill>
-                <a:schemeClr val="dk1"/>
-              </a:solidFill>
-              <a:latin typeface="Calibri"/>
-              <a:ea typeface="Calibri"/>
-              <a:cs typeface="Calibri"/>
-              <a:sym typeface="Calibri"/>
-            </a:endParaRPr>
-          </a:p>
-        </p:txBody>
-      </p:sp>
-      <p:sp>
-        <p:nvSpPr>
-          <p:cNvPr id="345" name="Google Shape;345;p13"/>
-          <p:cNvSpPr/>
-          <p:nvPr/>
-        </p:nvSpPr>
-        <p:spPr>
-          <a:xfrm>
-            <a:off x="4618634" y="4315968"/>
-            <a:ext cx="2954426" cy="1188720"/>
-          </a:xfrm>
-          <a:prstGeom prst="roundRect">
-            <a:avLst>
-              <a:gd fmla="val 4667" name="adj"/>
-            </a:avLst>
-          </a:prstGeom>
-          <a:solidFill>
-            <a:srgbClr val="E8F1F8"/>
-          </a:solidFill>
-          <a:ln>
-            <a:noFill/>
-          </a:ln>
-        </p:spPr>
-        <p:txBody>
-          <a:bodyPr anchorCtr="0" anchor="ctr" bIns="91425" lIns="91425" spcFirstLastPara="1" rIns="91425" wrap="square" tIns="91425">
-            <a:noAutofit/>
-          </a:bodyPr>
-          <a:lstStyle/>
-          <a:p>
-            <a:pPr indent="0" lvl="0" marL="0" rtl="0" algn="l">
-              <a:spcBef>
-                <a:spcPts val="0"/>
-              </a:spcBef>
-              <a:spcAft>
-                <a:spcPts val="0"/>
-              </a:spcAft>
-              <a:buNone/>
-            </a:pPr>
-            <a:r>
-              <a:t/>
-            </a:r>
-            <a:endParaRPr/>
-          </a:p>
-        </p:txBody>
-      </p:sp>
-      <p:sp>
-        <p:nvSpPr>
-          <p:cNvPr id="346" name="Google Shape;346;p13"/>
-          <p:cNvSpPr/>
-          <p:nvPr/>
-        </p:nvSpPr>
-        <p:spPr>
-          <a:xfrm>
-            <a:off x="4783226" y="4425696"/>
-            <a:ext cx="2625242" cy="219456"/>
-          </a:xfrm>
-          <a:prstGeom prst="rect">
-            <a:avLst/>
-          </a:prstGeom>
-          <a:noFill/>
-          <a:ln>
-            <a:noFill/>
-          </a:ln>
-        </p:spPr>
-        <p:txBody>
-          <a:bodyPr anchorCtr="0" anchor="ctr" bIns="0" lIns="0" spcFirstLastPara="1" rIns="0" wrap="square" tIns="0">
-            <a:noAutofit/>
-          </a:bodyPr>
-          <a:lstStyle/>
-          <a:p>
-            <a:pPr indent="0" lvl="0" marL="0" marR="0" rtl="0" algn="l">
-              <a:spcBef>
-                <a:spcPts val="0"/>
-              </a:spcBef>
-              <a:spcAft>
-                <a:spcPts val="0"/>
-              </a:spcAft>
-              <a:buClr>
-                <a:srgbClr val="004381"/>
-              </a:buClr>
-              <a:buSzPts val="1000"/>
-              <a:buFont typeface="Malgun Gothic"/>
-              <a:buNone/>
-            </a:pPr>
-            <a:r>
-              <a:rPr b="1" i="0" lang="en-US" sz="1000" u="none" cap="none" strike="noStrike">
-                <a:solidFill>
-                  <a:srgbClr val="004381"/>
-                </a:solidFill>
-                <a:latin typeface="Malgun Gothic"/>
-                <a:ea typeface="Malgun Gothic"/>
-                <a:cs typeface="Malgun Gothic"/>
-                <a:sym typeface="Malgun Gothic"/>
-              </a:rPr>
-              <a:t>비교 대상 3단 폴백</a:t>
-            </a:r>
-            <a:endParaRPr b="0" i="0" sz="1000" u="none" cap="none" strike="noStrike">
-              <a:solidFill>
-                <a:schemeClr val="dk1"/>
-              </a:solidFill>
-              <a:latin typeface="Calibri"/>
-              <a:ea typeface="Calibri"/>
-              <a:cs typeface="Calibri"/>
-              <a:sym typeface="Calibri"/>
-            </a:endParaRPr>
-          </a:p>
-        </p:txBody>
-      </p:sp>
-      <p:sp>
-        <p:nvSpPr>
-          <p:cNvPr id="347" name="Google Shape;347;p13"/>
-          <p:cNvSpPr/>
-          <p:nvPr/>
-        </p:nvSpPr>
-        <p:spPr>
-          <a:xfrm>
-            <a:off x="4783226" y="4681728"/>
-            <a:ext cx="2625242" cy="731520"/>
-          </a:xfrm>
-          <a:prstGeom prst="rect">
-            <a:avLst/>
-          </a:prstGeom>
-          <a:noFill/>
-          <a:ln>
-            <a:noFill/>
-          </a:ln>
-        </p:spPr>
-        <p:txBody>
-          <a:bodyPr anchorCtr="0" anchor="ctr" bIns="0" lIns="0" spcFirstLastPara="1" rIns="0" wrap="square" tIns="0">
-            <a:noAutofit/>
-          </a:bodyPr>
-          <a:lstStyle/>
-          <a:p>
-            <a:pPr indent="-171450" lvl="0" marL="171450" marR="0" rtl="0" algn="l">
-              <a:lnSpc>
-                <a:spcPct val="100000"/>
-              </a:lnSpc>
-              <a:spcBef>
-                <a:spcPts val="0"/>
-              </a:spcBef>
-              <a:spcAft>
-                <a:spcPts val="0"/>
-              </a:spcAft>
-              <a:buClr>
-                <a:srgbClr val="172033"/>
-              </a:buClr>
-              <a:buSzPts val="1050"/>
-              <a:buFont typeface="Malgun Gothic"/>
-              <a:buChar char="•"/>
-            </a:pPr>
-            <a:r>
-              <a:rPr b="0" i="0" lang="en-US" sz="1050" u="none" cap="none" strike="noStrike">
-                <a:solidFill>
-                  <a:srgbClr val="172033"/>
-                </a:solidFill>
-                <a:latin typeface="Malgun Gothic"/>
-                <a:ea typeface="Malgun Gothic"/>
-                <a:cs typeface="Malgun Gothic"/>
-                <a:sym typeface="Malgun Gothic"/>
-              </a:rPr>
-              <a:t>1순위 같은 중분류 내 다른 문항 · 2순위 같은 대분류 내 다른 문항</a:t>
-            </a:r>
-            <a:endParaRPr b="0" i="0" sz="1050" u="none" cap="none" strike="noStrike">
-              <a:solidFill>
-                <a:schemeClr val="dk1"/>
-              </a:solidFill>
-              <a:latin typeface="Calibri"/>
-              <a:ea typeface="Calibri"/>
-              <a:cs typeface="Calibri"/>
-              <a:sym typeface="Calibri"/>
-            </a:endParaRPr>
-          </a:p>
-          <a:p>
-            <a:pPr indent="-171450" lvl="0" marL="171450" marR="0" rtl="0" algn="l">
-              <a:lnSpc>
-                <a:spcPct val="100000"/>
-              </a:lnSpc>
-              <a:spcBef>
-                <a:spcPts val="200"/>
-              </a:spcBef>
-              <a:spcAft>
-                <a:spcPts val="0"/>
-              </a:spcAft>
-              <a:buClr>
-                <a:srgbClr val="172033"/>
-              </a:buClr>
-              <a:buSzPts val="1050"/>
-              <a:buFont typeface="Malgun Gothic"/>
-              <a:buChar char="•"/>
-            </a:pPr>
-            <a:r>
-              <a:rPr b="0" i="0" lang="en-US" sz="1050" u="none" cap="none" strike="noStrike">
-                <a:solidFill>
-                  <a:srgbClr val="172033"/>
-                </a:solidFill>
-                <a:latin typeface="Malgun Gothic"/>
-                <a:ea typeface="Malgun Gothic"/>
-                <a:cs typeface="Malgun Gothic"/>
-                <a:sym typeface="Malgun Gothic"/>
-              </a:rPr>
-              <a:t>3순위 비교 없이 분포만 서술</a:t>
-            </a:r>
-            <a:endParaRPr b="0" i="0" sz="1050" u="none" cap="none" strike="noStrike">
               <a:solidFill>
                 <a:schemeClr val="dk1"/>
               </a:solidFill>
@@ -6198,8 +5611,8 @@
         </p:nvSpPr>
         <p:spPr>
           <a:xfrm>
-            <a:off x="8414309" y="2103120"/>
-            <a:ext cx="2954426" cy="640080"/>
+            <a:off x="8414309" y="2139696"/>
+            <a:ext cx="2954426" cy="768096"/>
           </a:xfrm>
           <a:prstGeom prst="rect">
             <a:avLst/>
@@ -6233,7 +5646,7 @@
               <a:buNone/>
             </a:pPr>
             <a:r>
-              <a:rPr b="1" i="0" lang="en-US" sz="1350" u="none" cap="none" strike="noStrike">
+              <a:rPr b="1" i="0" lang="en-US" sz="1500" u="none" cap="none" strike="noStrike">
                 <a:solidFill>
                   <a:srgbClr val="002D5A"/>
                 </a:solidFill>
@@ -6264,8 +5677,8 @@
         </p:nvSpPr>
         <p:spPr>
           <a:xfrm>
-            <a:off x="8414309" y="2779776"/>
-            <a:ext cx="2954426" cy="219456"/>
+            <a:off x="8414309" y="3017520"/>
+            <a:ext cx="2954426" cy="256032"/>
           </a:xfrm>
           <a:prstGeom prst="rect">
             <a:avLst/>
@@ -6296,7 +5709,7 @@
               <a:buNone/>
             </a:pPr>
             <a:r>
-              <a:rPr b="1" i="0" lang="en-US" sz="1000" u="none" cap="none" strike="noStrike">
+              <a:rPr b="1" i="0" lang="en-US" sz="1100" u="none" cap="none" strike="noStrike">
                 <a:solidFill>
                   <a:srgbClr val="65708A"/>
                 </a:solidFill>
@@ -6327,8 +5740,8 @@
         </p:nvSpPr>
         <p:spPr>
           <a:xfrm>
-            <a:off x="8414309" y="3017520"/>
-            <a:ext cx="2954426" cy="1225296"/>
+            <a:off x="8414309" y="3310128"/>
+            <a:ext cx="2954426" cy="2084831"/>
           </a:xfrm>
           <a:prstGeom prst="rect">
             <a:avLst/>
@@ -6362,7 +5775,7 @@
               <a:buChar char="•"/>
             </a:pPr>
             <a:r>
-              <a:rPr b="0" i="0" lang="en-US" sz="1100" u="none" cap="none" strike="noStrike">
+              <a:rPr b="0" i="0" lang="en-US" sz="1400" u="none" cap="none" strike="noStrike">
                 <a:solidFill>
                   <a:srgbClr val="172033"/>
                 </a:solidFill>
@@ -6389,7 +5802,7 @@
                 <a:spcPct val="100000"/>
               </a:lnSpc>
               <a:spcBef>
-                <a:spcPts val="200"/>
+                <a:spcPts val="600"/>
               </a:spcBef>
               <a:spcAft>
                 <a:spcPts val="0"/>
@@ -6402,7 +5815,7 @@
               <a:buChar char="•"/>
             </a:pPr>
             <a:r>
-              <a:rPr b="0" i="0" lang="en-US" sz="1100" u="none" cap="none" strike="noStrike">
+              <a:rPr b="0" i="0" lang="en-US" sz="1400" u="none" cap="none" strike="noStrike">
                 <a:solidFill>
                   <a:srgbClr val="172033"/>
                 </a:solidFill>
@@ -6429,7 +5842,7 @@
                 <a:spcPct val="100000"/>
               </a:lnSpc>
               <a:spcBef>
-                <a:spcPts val="200"/>
+                <a:spcPts val="600"/>
               </a:spcBef>
               <a:spcAft>
                 <a:spcPts val="0"/>
@@ -6442,7 +5855,7 @@
               <a:buChar char="•"/>
             </a:pPr>
             <a:r>
-              <a:rPr b="0" i="0" lang="en-US" sz="1100" u="none" cap="none" strike="noStrike">
+              <a:rPr b="0" i="0" lang="en-US" sz="1400" u="none" cap="none" strike="noStrike">
                 <a:solidFill>
                   <a:srgbClr val="172033"/>
                 </a:solidFill>
@@ -6454,220 +5867,6 @@
               <a:t>2027 시트를 넣은 4개년 파일로 전 화면 자동 확장 실증</a:t>
             </a:r>
             <a:endParaRPr b="0" i="0" sz="1100" u="none" cap="none" strike="noStrike">
-              <a:solidFill>
-                <a:schemeClr val="dk1"/>
-              </a:solidFill>
-              <a:latin typeface="Calibri"/>
-              <a:ea typeface="Calibri"/>
-              <a:cs typeface="Calibri"/>
-              <a:sym typeface="Calibri"/>
-            </a:endParaRPr>
-          </a:p>
-        </p:txBody>
-      </p:sp>
-      <p:sp>
-        <p:nvSpPr>
-          <p:cNvPr id="354" name="Google Shape;354;p13"/>
-          <p:cNvSpPr/>
-          <p:nvPr/>
-        </p:nvSpPr>
-        <p:spPr>
-          <a:xfrm>
-            <a:off x="8414309" y="4315968"/>
-            <a:ext cx="2954426" cy="1188720"/>
-          </a:xfrm>
-          <a:prstGeom prst="roundRect">
-            <a:avLst>
-              <a:gd fmla="val 4667" name="adj"/>
-            </a:avLst>
-          </a:prstGeom>
-          <a:solidFill>
-            <a:srgbClr val="E8F1F8"/>
-          </a:solidFill>
-          <a:ln>
-            <a:noFill/>
-          </a:ln>
-        </p:spPr>
-        <p:txBody>
-          <a:bodyPr anchorCtr="0" anchor="ctr" bIns="91425" lIns="91425" spcFirstLastPara="1" rIns="91425" wrap="square" tIns="91425">
-            <a:noAutofit/>
-          </a:bodyPr>
-          <a:lstStyle/>
-          <a:p>
-            <a:pPr indent="0" lvl="0" marL="0" rtl="0" algn="l">
-              <a:spcBef>
-                <a:spcPts val="0"/>
-              </a:spcBef>
-              <a:spcAft>
-                <a:spcPts val="0"/>
-              </a:spcAft>
-              <a:buNone/>
-            </a:pPr>
-            <a:r>
-              <a:t/>
-            </a:r>
-            <a:endParaRPr/>
-          </a:p>
-        </p:txBody>
-      </p:sp>
-      <p:sp>
-        <p:nvSpPr>
-          <p:cNvPr id="355" name="Google Shape;355;p13"/>
-          <p:cNvSpPr/>
-          <p:nvPr/>
-        </p:nvSpPr>
-        <p:spPr>
-          <a:xfrm>
-            <a:off x="8578901" y="4425696"/>
-            <a:ext cx="2625242" cy="219456"/>
-          </a:xfrm>
-          <a:prstGeom prst="rect">
-            <a:avLst/>
-          </a:prstGeom>
-          <a:noFill/>
-          <a:ln>
-            <a:noFill/>
-          </a:ln>
-        </p:spPr>
-        <p:txBody>
-          <a:bodyPr anchorCtr="0" anchor="ctr" bIns="0" lIns="0" spcFirstLastPara="1" rIns="0" wrap="square" tIns="0">
-            <a:noAutofit/>
-          </a:bodyPr>
-          <a:lstStyle/>
-          <a:p>
-            <a:pPr indent="0" lvl="0" marL="0" marR="0" rtl="0" algn="l">
-              <a:spcBef>
-                <a:spcPts val="0"/>
-              </a:spcBef>
-              <a:spcAft>
-                <a:spcPts val="0"/>
-              </a:spcAft>
-              <a:buClr>
-                <a:srgbClr val="004381"/>
-              </a:buClr>
-              <a:buSzPts val="1000"/>
-              <a:buFont typeface="Malgun Gothic"/>
-              <a:buNone/>
-            </a:pPr>
-            <a:r>
-              <a:rPr b="1" i="0" lang="en-US" sz="1000" u="none" cap="none" strike="noStrike">
-                <a:solidFill>
-                  <a:srgbClr val="004381"/>
-                </a:solidFill>
-                <a:latin typeface="Malgun Gothic"/>
-                <a:ea typeface="Malgun Gothic"/>
-                <a:cs typeface="Malgun Gothic"/>
-                <a:sym typeface="Malgun Gothic"/>
-              </a:rPr>
-              <a:t>대화 기록 유실 조치</a:t>
-            </a:r>
-            <a:endParaRPr b="0" i="0" sz="1000" u="none" cap="none" strike="noStrike">
-              <a:solidFill>
-                <a:schemeClr val="dk1"/>
-              </a:solidFill>
-              <a:latin typeface="Calibri"/>
-              <a:ea typeface="Calibri"/>
-              <a:cs typeface="Calibri"/>
-              <a:sym typeface="Calibri"/>
-            </a:endParaRPr>
-          </a:p>
-        </p:txBody>
-      </p:sp>
-      <p:sp>
-        <p:nvSpPr>
-          <p:cNvPr id="356" name="Google Shape;356;p13"/>
-          <p:cNvSpPr/>
-          <p:nvPr/>
-        </p:nvSpPr>
-        <p:spPr>
-          <a:xfrm>
-            <a:off x="8578901" y="4681728"/>
-            <a:ext cx="2625242" cy="731520"/>
-          </a:xfrm>
-          <a:prstGeom prst="rect">
-            <a:avLst/>
-          </a:prstGeom>
-          <a:noFill/>
-          <a:ln>
-            <a:noFill/>
-          </a:ln>
-        </p:spPr>
-        <p:txBody>
-          <a:bodyPr anchorCtr="0" anchor="ctr" bIns="0" lIns="0" spcFirstLastPara="1" rIns="0" wrap="square" tIns="0">
-            <a:noAutofit/>
-          </a:bodyPr>
-          <a:lstStyle/>
-          <a:p>
-            <a:pPr indent="-171450" lvl="0" marL="171450" marR="0" rtl="0" algn="l">
-              <a:lnSpc>
-                <a:spcPct val="100000"/>
-              </a:lnSpc>
-              <a:spcBef>
-                <a:spcPts val="0"/>
-              </a:spcBef>
-              <a:spcAft>
-                <a:spcPts val="0"/>
-              </a:spcAft>
-              <a:buClr>
-                <a:srgbClr val="172033"/>
-              </a:buClr>
-              <a:buSzPts val="1050"/>
-              <a:buFont typeface="Malgun Gothic"/>
-              <a:buChar char="•"/>
-            </a:pPr>
-            <a:r>
-              <a:rPr b="0" i="0" lang="en-US" sz="1050" u="none" cap="none" strike="noStrike">
-                <a:solidFill>
-                  <a:srgbClr val="172033"/>
-                </a:solidFill>
-                <a:latin typeface="Malgun Gothic"/>
-                <a:ea typeface="Malgun Gothic"/>
-                <a:cs typeface="Malgun Gothic"/>
-                <a:sym typeface="Malgun Gothic"/>
-              </a:rPr>
-              <a:t>Starlette 세션이 전체를 쿠키에 저장해 4KB 초과</a:t>
-            </a:r>
-            <a:endParaRPr b="0" i="0" sz="1050" u="none" cap="none" strike="noStrike">
-              <a:solidFill>
-                <a:schemeClr val="dk1"/>
-              </a:solidFill>
-              <a:latin typeface="Calibri"/>
-              <a:ea typeface="Calibri"/>
-              <a:cs typeface="Calibri"/>
-              <a:sym typeface="Calibri"/>
-            </a:endParaRPr>
-          </a:p>
-          <a:p>
-            <a:pPr indent="-171450" lvl="0" marL="171450" marR="0" rtl="0" algn="l">
-              <a:lnSpc>
-                <a:spcPct val="100000"/>
-              </a:lnSpc>
-              <a:spcBef>
-                <a:spcPts val="200"/>
-              </a:spcBef>
-              <a:spcAft>
-                <a:spcPts val="0"/>
-              </a:spcAft>
-              <a:buClr>
-                <a:srgbClr val="172033"/>
-              </a:buClr>
-              <a:buSzPts val="1050"/>
-              <a:buFont typeface="Malgun Gothic"/>
-              <a:buChar char="•"/>
-            </a:pPr>
-            <a:r>
-              <a:rPr b="0" i="0" lang="en-US" sz="1050" u="none" cap="none" strike="noStrike">
-                <a:solidFill>
-                  <a:srgbClr val="172033"/>
-                </a:solidFill>
-                <a:latin typeface="Malgun Gothic"/>
-                <a:ea typeface="Malgun Gothic"/>
-                <a:cs typeface="Malgun Gothic"/>
-                <a:sym typeface="Malgun Gothic"/>
-              </a:rPr>
-              <a:t>→ chat_messages 테이블로 이전, 쿠키엔 토큰만</a:t>
-            </a:r>
-            <a:endParaRPr b="0" i="0" sz="1050" u="none" cap="none" strike="noStrike">
               <a:solidFill>
                 <a:schemeClr val="dk1"/>
               </a:solidFill>
@@ -7007,7 +6206,7 @@
                 <a:cs typeface="Malgun Gothic"/>
                 <a:sym typeface="Malgun Gothic"/>
               </a:rPr>
-              <a:t>9</a:t>
+              <a:t>8</a:t>
             </a:r>
             <a:endParaRPr b="0" i="0" sz="1000" u="none" cap="none" strike="noStrike">
               <a:solidFill>
@@ -7030,7 +6229,7 @@
         <p:spPr>
           <a:xfrm>
             <a:off x="566928" y="1408176"/>
-            <a:ext cx="3466490" cy="3200400"/>
+            <a:ext cx="3466490" cy="4480560"/>
           </a:xfrm>
           <a:prstGeom prst="roundRect">
             <a:avLst>
@@ -7087,8 +6286,8 @@
         </p:nvSpPr>
         <p:spPr>
           <a:xfrm>
-            <a:off x="841248" y="1645920"/>
-            <a:ext cx="2917850" cy="237744"/>
+            <a:off x="841248" y="1737360"/>
+            <a:ext cx="2917850" cy="274320"/>
           </a:xfrm>
           <a:prstGeom prst="rect">
             <a:avLst/>
@@ -7119,7 +6318,7 @@
               <a:buNone/>
             </a:pPr>
             <a:r>
-              <a:rPr b="1" i="0" lang="en-US" sz="1000" u="none" cap="none" strike="noStrike">
+              <a:rPr b="1" i="0" lang="en-US" sz="1100" u="none" cap="none" strike="noStrike">
                 <a:solidFill>
                   <a:srgbClr val="65708A"/>
                 </a:solidFill>
@@ -7150,8 +6349,8 @@
         </p:nvSpPr>
         <p:spPr>
           <a:xfrm>
-            <a:off x="841248" y="1901952"/>
-            <a:ext cx="2917850" cy="365760"/>
+            <a:off x="841248" y="2084831"/>
+            <a:ext cx="2917850" cy="548640"/>
           </a:xfrm>
           <a:prstGeom prst="rect">
             <a:avLst/>
@@ -7182,7 +6381,7 @@
               <a:buNone/>
             </a:pPr>
             <a:r>
-              <a:rPr b="1" i="0" lang="en-US" sz="1800" u="none" cap="none" strike="noStrike">
+              <a:rPr b="1" i="0" lang="en-US" sz="2200" u="none" cap="none" strike="noStrike">
                 <a:solidFill>
                   <a:srgbClr val="002D5A"/>
                 </a:solidFill>
@@ -7213,8 +6412,8 @@
         </p:nvSpPr>
         <p:spPr>
           <a:xfrm>
-            <a:off x="841248" y="2377440"/>
-            <a:ext cx="2917850" cy="2011680"/>
+            <a:off x="841248" y="2788920"/>
+            <a:ext cx="2917850" cy="2926080"/>
           </a:xfrm>
           <a:prstGeom prst="rect">
             <a:avLst/>
@@ -7231,6 +6430,9 @@
           <a:lstStyle/>
           <a:p>
             <a:pPr indent="-342900" lvl="0" marL="342900" marR="0" rtl="0" algn="l">
+              <a:lnSpc>
+                <a:spcPct val="145000"/>
+              </a:lnSpc>
               <a:spcBef>
                 <a:spcPts val="0"/>
               </a:spcBef>
@@ -7245,7 +6447,7 @@
               <a:buChar char="•"/>
             </a:pPr>
             <a:r>
-              <a:rPr b="0" i="0" lang="en-US" sz="1100" u="none" cap="none" strike="noStrike">
+              <a:rPr b="0" i="0" lang="en-US" sz="1400" u="none" cap="none" strike="noStrike">
                 <a:solidFill>
                   <a:srgbClr val="172033"/>
                 </a:solidFill>
@@ -7268,6 +6470,9 @@
           </a:p>
           <a:p>
             <a:pPr indent="-342900" lvl="0" marL="342900" marR="0" rtl="0" algn="l">
+              <a:lnSpc>
+                <a:spcPct val="145000"/>
+              </a:lnSpc>
               <a:spcBef>
                 <a:spcPts val="800"/>
               </a:spcBef>
@@ -7282,7 +6487,7 @@
               <a:buChar char="•"/>
             </a:pPr>
             <a:r>
-              <a:rPr b="0" i="0" lang="en-US" sz="1100" u="none" cap="none" strike="noStrike">
+              <a:rPr b="0" i="0" lang="en-US" sz="1400" u="none" cap="none" strike="noStrike">
                 <a:solidFill>
                   <a:srgbClr val="172033"/>
                 </a:solidFill>
@@ -7305,6 +6510,9 @@
           </a:p>
           <a:p>
             <a:pPr indent="-342900" lvl="0" marL="342900" marR="0" rtl="0" algn="l">
+              <a:lnSpc>
+                <a:spcPct val="145000"/>
+              </a:lnSpc>
               <a:spcBef>
                 <a:spcPts val="800"/>
               </a:spcBef>
@@ -7319,7 +6527,7 @@
               <a:buChar char="•"/>
             </a:pPr>
             <a:r>
-              <a:rPr b="0" i="0" lang="en-US" sz="1100" u="none" cap="none" strike="noStrike">
+              <a:rPr b="0" i="0" lang="en-US" sz="1400" u="none" cap="none" strike="noStrike">
                 <a:solidFill>
                   <a:srgbClr val="172033"/>
                 </a:solidFill>
@@ -7342,6 +6550,9 @@
           </a:p>
           <a:p>
             <a:pPr indent="0" lvl="0" marL="0" marR="0" rtl="0" algn="l">
+              <a:lnSpc>
+                <a:spcPct val="145000"/>
+              </a:lnSpc>
               <a:spcBef>
                 <a:spcPts val="800"/>
               </a:spcBef>
@@ -7356,7 +6567,7 @@
               <a:buNone/>
             </a:pPr>
             <a:r>
-              <a:rPr b="0" i="0" lang="en-US" sz="1100" u="none" cap="none" strike="noStrike">
+              <a:rPr b="0" i="0" lang="en-US" sz="1400" u="none" cap="none" strike="noStrike">
                 <a:solidFill>
                   <a:srgbClr val="172033"/>
                 </a:solidFill>
@@ -7388,7 +6599,7 @@
         <p:spPr>
           <a:xfrm>
             <a:off x="4362602" y="1408176"/>
-            <a:ext cx="3466490" cy="3200400"/>
+            <a:ext cx="3466490" cy="4480560"/>
           </a:xfrm>
           <a:prstGeom prst="roundRect">
             <a:avLst>
@@ -7445,8 +6656,8 @@
         </p:nvSpPr>
         <p:spPr>
           <a:xfrm>
-            <a:off x="4636922" y="1645920"/>
-            <a:ext cx="2917850" cy="237744"/>
+            <a:off x="4636922" y="1737360"/>
+            <a:ext cx="2917850" cy="274320"/>
           </a:xfrm>
           <a:prstGeom prst="rect">
             <a:avLst/>
@@ -7477,7 +6688,7 @@
               <a:buNone/>
             </a:pPr>
             <a:r>
-              <a:rPr b="1" i="0" lang="en-US" sz="1000" u="none" cap="none" strike="noStrike">
+              <a:rPr b="1" i="0" lang="en-US" sz="1100" u="none" cap="none" strike="noStrike">
                 <a:solidFill>
                   <a:srgbClr val="004381"/>
                 </a:solidFill>
@@ -7508,8 +6719,8 @@
         </p:nvSpPr>
         <p:spPr>
           <a:xfrm>
-            <a:off x="4636922" y="1901952"/>
-            <a:ext cx="2917850" cy="365760"/>
+            <a:off x="4636922" y="2084831"/>
+            <a:ext cx="2917850" cy="548640"/>
           </a:xfrm>
           <a:prstGeom prst="rect">
             <a:avLst/>
@@ -7540,7 +6751,7 @@
               <a:buNone/>
             </a:pPr>
             <a:r>
-              <a:rPr b="1" i="0" lang="en-US" sz="1800" u="none" cap="none" strike="noStrike">
+              <a:rPr b="1" i="0" lang="en-US" sz="2200" u="none" cap="none" strike="noStrike">
                 <a:solidFill>
                   <a:srgbClr val="002D5A"/>
                 </a:solidFill>
@@ -7571,8 +6782,8 @@
         </p:nvSpPr>
         <p:spPr>
           <a:xfrm>
-            <a:off x="4636922" y="2377440"/>
-            <a:ext cx="2917850" cy="2011680"/>
+            <a:off x="4636922" y="2788920"/>
+            <a:ext cx="2917850" cy="2926080"/>
           </a:xfrm>
           <a:prstGeom prst="rect">
             <a:avLst/>
@@ -7589,6 +6800,9 @@
           <a:lstStyle/>
           <a:p>
             <a:pPr indent="-342900" lvl="0" marL="342900" marR="0" rtl="0" algn="l">
+              <a:lnSpc>
+                <a:spcPct val="145000"/>
+              </a:lnSpc>
               <a:spcBef>
                 <a:spcPts val="0"/>
               </a:spcBef>
@@ -7603,7 +6817,7 @@
               <a:buChar char="•"/>
             </a:pPr>
             <a:r>
-              <a:rPr b="0" i="0" lang="en-US" sz="1100" u="none" cap="none" strike="noStrike">
+              <a:rPr b="0" i="0" lang="en-US" sz="1400" u="none" cap="none" strike="noStrike">
                 <a:solidFill>
                   <a:srgbClr val="172033"/>
                 </a:solidFill>
@@ -7626,6 +6840,9 @@
           </a:p>
           <a:p>
             <a:pPr indent="-342900" lvl="0" marL="342900" marR="0" rtl="0" algn="l">
+              <a:lnSpc>
+                <a:spcPct val="145000"/>
+              </a:lnSpc>
               <a:spcBef>
                 <a:spcPts val="800"/>
               </a:spcBef>
@@ -7640,7 +6857,7 @@
               <a:buChar char="•"/>
             </a:pPr>
             <a:r>
-              <a:rPr b="0" i="0" lang="en-US" sz="1100" u="none" cap="none" strike="noStrike">
+              <a:rPr b="0" i="0" lang="en-US" sz="1400" u="none" cap="none" strike="noStrike">
                 <a:solidFill>
                   <a:srgbClr val="172033"/>
                 </a:solidFill>
@@ -7663,6 +6880,9 @@
           </a:p>
           <a:p>
             <a:pPr indent="-342900" lvl="0" marL="342900" marR="0" rtl="0" algn="l">
+              <a:lnSpc>
+                <a:spcPct val="145000"/>
+              </a:lnSpc>
               <a:spcBef>
                 <a:spcPts val="800"/>
               </a:spcBef>
@@ -7677,7 +6897,7 @@
               <a:buChar char="•"/>
             </a:pPr>
             <a:r>
-              <a:rPr b="0" i="0" lang="en-US" sz="1100" u="none" cap="none" strike="noStrike">
+              <a:rPr b="0" i="0" lang="en-US" sz="1400" u="none" cap="none" strike="noStrike">
                 <a:solidFill>
                   <a:srgbClr val="172033"/>
                 </a:solidFill>
@@ -7700,6 +6920,9 @@
           </a:p>
           <a:p>
             <a:pPr indent="0" lvl="0" marL="0" marR="0" rtl="0" algn="l">
+              <a:lnSpc>
+                <a:spcPct val="145000"/>
+              </a:lnSpc>
               <a:spcBef>
                 <a:spcPts val="800"/>
               </a:spcBef>
@@ -7714,7 +6937,7 @@
               <a:buNone/>
             </a:pPr>
             <a:r>
-              <a:rPr b="0" i="0" lang="en-US" sz="1100" u="none" cap="none" strike="noStrike">
+              <a:rPr b="0" i="0" lang="en-US" sz="1400" u="none" cap="none" strike="noStrike">
                 <a:solidFill>
                   <a:srgbClr val="172033"/>
                 </a:solidFill>
@@ -7746,7 +6969,7 @@
         <p:spPr>
           <a:xfrm>
             <a:off x="8158277" y="1408176"/>
-            <a:ext cx="3466490" cy="3200400"/>
+            <a:ext cx="3466490" cy="4480560"/>
           </a:xfrm>
           <a:prstGeom prst="roundRect">
             <a:avLst>
@@ -7803,8 +7026,8 @@
         </p:nvSpPr>
         <p:spPr>
           <a:xfrm>
-            <a:off x="8432597" y="1645920"/>
-            <a:ext cx="2917850" cy="237744"/>
+            <a:off x="8432597" y="1737360"/>
+            <a:ext cx="2917850" cy="274320"/>
           </a:xfrm>
           <a:prstGeom prst="rect">
             <a:avLst/>
@@ -7835,7 +7058,7 @@
               <a:buNone/>
             </a:pPr>
             <a:r>
-              <a:rPr b="1" i="0" lang="en-US" sz="1000" u="none" cap="none" strike="noStrike">
+              <a:rPr b="1" i="0" lang="en-US" sz="1100" u="none" cap="none" strike="noStrike">
                 <a:solidFill>
                   <a:srgbClr val="0098D9"/>
                 </a:solidFill>
@@ -7866,8 +7089,8 @@
         </p:nvSpPr>
         <p:spPr>
           <a:xfrm>
-            <a:off x="8432597" y="1901952"/>
-            <a:ext cx="2917850" cy="365760"/>
+            <a:off x="8432597" y="2084831"/>
+            <a:ext cx="2917850" cy="548640"/>
           </a:xfrm>
           <a:prstGeom prst="rect">
             <a:avLst/>
@@ -7898,7 +7121,7 @@
               <a:buNone/>
             </a:pPr>
             <a:r>
-              <a:rPr b="1" i="0" lang="en-US" sz="1800" u="none" cap="none" strike="noStrike">
+              <a:rPr b="1" i="0" lang="en-US" sz="2200" u="none" cap="none" strike="noStrike">
                 <a:solidFill>
                   <a:srgbClr val="002D5A"/>
                 </a:solidFill>
@@ -7929,8 +7152,8 @@
         </p:nvSpPr>
         <p:spPr>
           <a:xfrm>
-            <a:off x="8432597" y="2377440"/>
-            <a:ext cx="2917850" cy="2011680"/>
+            <a:off x="8432597" y="2788920"/>
+            <a:ext cx="2917850" cy="2926080"/>
           </a:xfrm>
           <a:prstGeom prst="rect">
             <a:avLst/>
@@ -7947,6 +7170,9 @@
           <a:lstStyle/>
           <a:p>
             <a:pPr indent="-342900" lvl="0" marL="342900" marR="0" rtl="0" algn="l">
+              <a:lnSpc>
+                <a:spcPct val="145000"/>
+              </a:lnSpc>
               <a:spcBef>
                 <a:spcPts val="0"/>
               </a:spcBef>
@@ -7961,7 +7187,7 @@
               <a:buChar char="•"/>
             </a:pPr>
             <a:r>
-              <a:rPr b="0" i="0" lang="en-US" sz="1100" u="none" cap="none" strike="noStrike">
+              <a:rPr b="0" i="0" lang="en-US" sz="1400" u="none" cap="none" strike="noStrike">
                 <a:solidFill>
                   <a:srgbClr val="172033"/>
                 </a:solidFill>
@@ -7984,6 +7210,9 @@
           </a:p>
           <a:p>
             <a:pPr indent="-342900" lvl="0" marL="342900" marR="0" rtl="0" algn="l">
+              <a:lnSpc>
+                <a:spcPct val="145000"/>
+              </a:lnSpc>
               <a:spcBef>
                 <a:spcPts val="800"/>
               </a:spcBef>
@@ -7998,7 +7227,7 @@
               <a:buChar char="•"/>
             </a:pPr>
             <a:r>
-              <a:rPr b="0" i="0" lang="en-US" sz="1100" u="none" cap="none" strike="noStrike">
+              <a:rPr b="0" i="0" lang="en-US" sz="1400" u="none" cap="none" strike="noStrike">
                 <a:solidFill>
                   <a:srgbClr val="172033"/>
                 </a:solidFill>
@@ -8021,6 +7250,9 @@
           </a:p>
           <a:p>
             <a:pPr indent="-342900" lvl="0" marL="342900" marR="0" rtl="0" algn="l">
+              <a:lnSpc>
+                <a:spcPct val="145000"/>
+              </a:lnSpc>
               <a:spcBef>
                 <a:spcPts val="800"/>
               </a:spcBef>
@@ -8035,7 +7267,7 @@
               <a:buChar char="•"/>
             </a:pPr>
             <a:r>
-              <a:rPr b="0" i="0" lang="en-US" sz="1100" u="none" cap="none" strike="noStrike">
+              <a:rPr b="0" i="0" lang="en-US" sz="1400" u="none" cap="none" strike="noStrike">
                 <a:solidFill>
                   <a:srgbClr val="172033"/>
                 </a:solidFill>
@@ -8058,6 +7290,9 @@
           </a:p>
           <a:p>
             <a:pPr indent="0" lvl="0" marL="0" marR="0" rtl="0" algn="l">
+              <a:lnSpc>
+                <a:spcPct val="145000"/>
+              </a:lnSpc>
               <a:spcBef>
                 <a:spcPts val="800"/>
               </a:spcBef>
@@ -8072,7 +7307,7 @@
               <a:buNone/>
             </a:pPr>
             <a:r>
-              <a:rPr b="0" i="0" lang="en-US" sz="1100" u="none" cap="none" strike="noStrike">
+              <a:rPr b="0" i="0" lang="en-US" sz="1400" u="none" cap="none" strike="noStrike">
                 <a:solidFill>
                   <a:srgbClr val="172033"/>
                 </a:solidFill>
@@ -8084,742 +7319,6 @@
               <a:t>→ 키가 없으면 규칙 기반으로 자동 폴백</a:t>
             </a:r>
             <a:endParaRPr b="0" i="0" sz="1100" u="none" cap="none" strike="noStrike">
-              <a:solidFill>
-                <a:schemeClr val="dk1"/>
-              </a:solidFill>
-              <a:latin typeface="Calibri"/>
-              <a:ea typeface="Calibri"/>
-              <a:cs typeface="Calibri"/>
-              <a:sym typeface="Calibri"/>
-            </a:endParaRPr>
-          </a:p>
-        </p:txBody>
-      </p:sp>
-      <p:sp>
-        <p:nvSpPr>
-          <p:cNvPr id="445" name="Google Shape;445;p16"/>
-          <p:cNvSpPr/>
-          <p:nvPr/>
-        </p:nvSpPr>
-        <p:spPr>
-          <a:xfrm>
-            <a:off x="566928" y="4791456"/>
-            <a:ext cx="2558720" cy="1097280"/>
-          </a:xfrm>
-          <a:prstGeom prst="roundRect">
-            <a:avLst>
-              <a:gd fmla="val 6667" name="adj"/>
-            </a:avLst>
-          </a:prstGeom>
-          <a:solidFill>
-            <a:srgbClr val="E8F1F8"/>
-          </a:solidFill>
-          <a:ln cap="flat" cmpd="sng" w="12700">
-            <a:solidFill>
-              <a:srgbClr val="DFE5EF"/>
-            </a:solidFill>
-            <a:prstDash val="solid"/>
-            <a:round/>
-            <a:headEnd len="sm" w="sm" type="none"/>
-            <a:tailEnd len="sm" w="sm" type="none"/>
-          </a:ln>
-          <a:effectLst>
-            <a:outerShdw blurRad="127000" rotWithShape="0" algn="bl" dir="5400000" dist="25400">
-              <a:srgbClr val="8894A8">
-                <a:alpha val="18039"/>
-              </a:srgbClr>
-            </a:outerShdw>
-          </a:effectLst>
-        </p:spPr>
-        <p:txBody>
-          <a:bodyPr anchorCtr="0" anchor="ctr" bIns="91425" lIns="91425" spcFirstLastPara="1" rIns="91425" wrap="square" tIns="91425">
-            <a:noAutofit/>
-          </a:bodyPr>
-          <a:lstStyle/>
-          <a:p>
-            <a:pPr indent="0" lvl="0" marL="0" rtl="0" algn="l">
-              <a:spcBef>
-                <a:spcPts val="0"/>
-              </a:spcBef>
-              <a:spcAft>
-                <a:spcPts val="0"/>
-              </a:spcAft>
-              <a:buNone/>
-            </a:pPr>
-            <a:r>
-              <a:t/>
-            </a:r>
-            <a:endParaRPr/>
-          </a:p>
-        </p:txBody>
-      </p:sp>
-      <p:sp>
-        <p:nvSpPr>
-          <p:cNvPr id="446" name="Google Shape;446;p16"/>
-          <p:cNvSpPr/>
-          <p:nvPr/>
-        </p:nvSpPr>
-        <p:spPr>
-          <a:xfrm>
-            <a:off x="804672" y="4956048"/>
-            <a:ext cx="2101520" cy="457200"/>
-          </a:xfrm>
-          <a:prstGeom prst="rect">
-            <a:avLst/>
-          </a:prstGeom>
-          <a:noFill/>
-          <a:ln>
-            <a:noFill/>
-          </a:ln>
-        </p:spPr>
-        <p:txBody>
-          <a:bodyPr anchorCtr="0" anchor="ctr" bIns="0" lIns="0" spcFirstLastPara="1" rIns="0" wrap="square" tIns="0">
-            <a:noAutofit/>
-          </a:bodyPr>
-          <a:lstStyle/>
-          <a:p>
-            <a:pPr indent="0" lvl="0" marL="0" marR="0" rtl="0" algn="l">
-              <a:spcBef>
-                <a:spcPts val="0"/>
-              </a:spcBef>
-              <a:spcAft>
-                <a:spcPts val="0"/>
-              </a:spcAft>
-              <a:buClr>
-                <a:srgbClr val="004381"/>
-              </a:buClr>
-              <a:buSzPts val="2400"/>
-              <a:buFont typeface="Malgun Gothic"/>
-              <a:buNone/>
-            </a:pPr>
-            <a:r>
-              <a:rPr b="1" i="0" lang="en-US" sz="2400" u="none" cap="none" strike="noStrike">
-                <a:solidFill>
-                  <a:srgbClr val="004381"/>
-                </a:solidFill>
-                <a:latin typeface="Malgun Gothic"/>
-                <a:ea typeface="Malgun Gothic"/>
-                <a:cs typeface="Malgun Gothic"/>
-                <a:sym typeface="Malgun Gothic"/>
-              </a:rPr>
-              <a:t>5,033</a:t>
-            </a:r>
-            <a:endParaRPr b="0" i="0" sz="2400" u="none" cap="none" strike="noStrike">
-              <a:solidFill>
-                <a:schemeClr val="dk1"/>
-              </a:solidFill>
-              <a:latin typeface="Calibri"/>
-              <a:ea typeface="Calibri"/>
-              <a:cs typeface="Calibri"/>
-              <a:sym typeface="Calibri"/>
-            </a:endParaRPr>
-          </a:p>
-        </p:txBody>
-      </p:sp>
-      <p:sp>
-        <p:nvSpPr>
-          <p:cNvPr id="447" name="Google Shape;447;p16"/>
-          <p:cNvSpPr/>
-          <p:nvPr/>
-        </p:nvSpPr>
-        <p:spPr>
-          <a:xfrm>
-            <a:off x="804672" y="5431536"/>
-            <a:ext cx="2101520" cy="256032"/>
-          </a:xfrm>
-          <a:prstGeom prst="rect">
-            <a:avLst/>
-          </a:prstGeom>
-          <a:noFill/>
-          <a:ln>
-            <a:noFill/>
-          </a:ln>
-        </p:spPr>
-        <p:txBody>
-          <a:bodyPr anchorCtr="0" anchor="ctr" bIns="0" lIns="0" spcFirstLastPara="1" rIns="0" wrap="square" tIns="0">
-            <a:noAutofit/>
-          </a:bodyPr>
-          <a:lstStyle/>
-          <a:p>
-            <a:pPr indent="0" lvl="0" marL="0" marR="0" rtl="0" algn="l">
-              <a:spcBef>
-                <a:spcPts val="0"/>
-              </a:spcBef>
-              <a:spcAft>
-                <a:spcPts val="0"/>
-              </a:spcAft>
-              <a:buClr>
-                <a:srgbClr val="65708A"/>
-              </a:buClr>
-              <a:buSzPts val="1050"/>
-              <a:buFont typeface="Malgun Gothic"/>
-              <a:buNone/>
-            </a:pPr>
-            <a:r>
-              <a:rPr b="0" i="0" lang="en-US" sz="1050" u="none" cap="none" strike="noStrike">
-                <a:solidFill>
-                  <a:srgbClr val="65708A"/>
-                </a:solidFill>
-                <a:latin typeface="Malgun Gothic"/>
-                <a:ea typeface="Malgun Gothic"/>
-                <a:cs typeface="Malgun Gothic"/>
-                <a:sym typeface="Malgun Gothic"/>
-              </a:rPr>
-              <a:t>라인 (앱 코드)</a:t>
-            </a:r>
-            <a:endParaRPr b="0" i="0" sz="1050" u="none" cap="none" strike="noStrike">
-              <a:solidFill>
-                <a:schemeClr val="dk1"/>
-              </a:solidFill>
-              <a:latin typeface="Calibri"/>
-              <a:ea typeface="Calibri"/>
-              <a:cs typeface="Calibri"/>
-              <a:sym typeface="Calibri"/>
-            </a:endParaRPr>
-          </a:p>
-        </p:txBody>
-      </p:sp>
-      <p:sp>
-        <p:nvSpPr>
-          <p:cNvPr id="448" name="Google Shape;448;p16"/>
-          <p:cNvSpPr/>
-          <p:nvPr/>
-        </p:nvSpPr>
-        <p:spPr>
-          <a:xfrm>
-            <a:off x="3399968" y="4791456"/>
-            <a:ext cx="2558720" cy="1097280"/>
-          </a:xfrm>
-          <a:prstGeom prst="roundRect">
-            <a:avLst>
-              <a:gd fmla="val 6667" name="adj"/>
-            </a:avLst>
-          </a:prstGeom>
-          <a:solidFill>
-            <a:srgbClr val="E8F1F8"/>
-          </a:solidFill>
-          <a:ln cap="flat" cmpd="sng" w="12700">
-            <a:solidFill>
-              <a:srgbClr val="DFE5EF"/>
-            </a:solidFill>
-            <a:prstDash val="solid"/>
-            <a:round/>
-            <a:headEnd len="sm" w="sm" type="none"/>
-            <a:tailEnd len="sm" w="sm" type="none"/>
-          </a:ln>
-          <a:effectLst>
-            <a:outerShdw blurRad="127000" rotWithShape="0" algn="bl" dir="5400000" dist="25400">
-              <a:srgbClr val="8894A8">
-                <a:alpha val="18039"/>
-              </a:srgbClr>
-            </a:outerShdw>
-          </a:effectLst>
-        </p:spPr>
-        <p:txBody>
-          <a:bodyPr anchorCtr="0" anchor="ctr" bIns="91425" lIns="91425" spcFirstLastPara="1" rIns="91425" wrap="square" tIns="91425">
-            <a:noAutofit/>
-          </a:bodyPr>
-          <a:lstStyle/>
-          <a:p>
-            <a:pPr indent="0" lvl="0" marL="0" rtl="0" algn="l">
-              <a:spcBef>
-                <a:spcPts val="0"/>
-              </a:spcBef>
-              <a:spcAft>
-                <a:spcPts val="0"/>
-              </a:spcAft>
-              <a:buNone/>
-            </a:pPr>
-            <a:r>
-              <a:t/>
-            </a:r>
-            <a:endParaRPr/>
-          </a:p>
-        </p:txBody>
-      </p:sp>
-      <p:sp>
-        <p:nvSpPr>
-          <p:cNvPr id="449" name="Google Shape;449;p16"/>
-          <p:cNvSpPr/>
-          <p:nvPr/>
-        </p:nvSpPr>
-        <p:spPr>
-          <a:xfrm>
-            <a:off x="3637712" y="4956048"/>
-            <a:ext cx="2101520" cy="457200"/>
-          </a:xfrm>
-          <a:prstGeom prst="rect">
-            <a:avLst/>
-          </a:prstGeom>
-          <a:noFill/>
-          <a:ln>
-            <a:noFill/>
-          </a:ln>
-        </p:spPr>
-        <p:txBody>
-          <a:bodyPr anchorCtr="0" anchor="ctr" bIns="0" lIns="0" spcFirstLastPara="1" rIns="0" wrap="square" tIns="0">
-            <a:noAutofit/>
-          </a:bodyPr>
-          <a:lstStyle/>
-          <a:p>
-            <a:pPr indent="0" lvl="0" marL="0" marR="0" rtl="0" algn="l">
-              <a:spcBef>
-                <a:spcPts val="0"/>
-              </a:spcBef>
-              <a:spcAft>
-                <a:spcPts val="0"/>
-              </a:spcAft>
-              <a:buClr>
-                <a:srgbClr val="004381"/>
-              </a:buClr>
-              <a:buSzPts val="2400"/>
-              <a:buFont typeface="Malgun Gothic"/>
-              <a:buNone/>
-            </a:pPr>
-            <a:r>
-              <a:rPr b="1" i="0" lang="en-US" sz="2400" u="none" cap="none" strike="noStrike">
-                <a:solidFill>
-                  <a:srgbClr val="004381"/>
-                </a:solidFill>
-                <a:latin typeface="Malgun Gothic"/>
-                <a:ea typeface="Malgun Gothic"/>
-                <a:cs typeface="Malgun Gothic"/>
-                <a:sym typeface="Malgun Gothic"/>
-              </a:rPr>
-              <a:t>13</a:t>
-            </a:r>
-            <a:endParaRPr b="0" i="0" sz="2400" u="none" cap="none" strike="noStrike">
-              <a:solidFill>
-                <a:schemeClr val="dk1"/>
-              </a:solidFill>
-              <a:latin typeface="Calibri"/>
-              <a:ea typeface="Calibri"/>
-              <a:cs typeface="Calibri"/>
-              <a:sym typeface="Calibri"/>
-            </a:endParaRPr>
-          </a:p>
-        </p:txBody>
-      </p:sp>
-      <p:sp>
-        <p:nvSpPr>
-          <p:cNvPr id="450" name="Google Shape;450;p16"/>
-          <p:cNvSpPr/>
-          <p:nvPr/>
-        </p:nvSpPr>
-        <p:spPr>
-          <a:xfrm>
-            <a:off x="3637712" y="5431536"/>
-            <a:ext cx="2101520" cy="256032"/>
-          </a:xfrm>
-          <a:prstGeom prst="rect">
-            <a:avLst/>
-          </a:prstGeom>
-          <a:noFill/>
-          <a:ln>
-            <a:noFill/>
-          </a:ln>
-        </p:spPr>
-        <p:txBody>
-          <a:bodyPr anchorCtr="0" anchor="ctr" bIns="0" lIns="0" spcFirstLastPara="1" rIns="0" wrap="square" tIns="0">
-            <a:noAutofit/>
-          </a:bodyPr>
-          <a:lstStyle/>
-          <a:p>
-            <a:pPr indent="0" lvl="0" marL="0" marR="0" rtl="0" algn="l">
-              <a:spcBef>
-                <a:spcPts val="0"/>
-              </a:spcBef>
-              <a:spcAft>
-                <a:spcPts val="0"/>
-              </a:spcAft>
-              <a:buClr>
-                <a:srgbClr val="65708A"/>
-              </a:buClr>
-              <a:buSzPts val="1050"/>
-              <a:buFont typeface="Malgun Gothic"/>
-              <a:buNone/>
-            </a:pPr>
-            <a:r>
-              <a:rPr b="0" i="0" lang="en-US" sz="1050" u="none" cap="none" strike="noStrike">
-                <a:solidFill>
-                  <a:srgbClr val="65708A"/>
-                </a:solidFill>
-                <a:latin typeface="Malgun Gothic"/>
-                <a:ea typeface="Malgun Gothic"/>
-                <a:cs typeface="Malgun Gothic"/>
-                <a:sym typeface="Malgun Gothic"/>
-              </a:rPr>
-              <a:t>커밋</a:t>
-            </a:r>
-            <a:endParaRPr b="0" i="0" sz="1050" u="none" cap="none" strike="noStrike">
-              <a:solidFill>
-                <a:schemeClr val="dk1"/>
-              </a:solidFill>
-              <a:latin typeface="Calibri"/>
-              <a:ea typeface="Calibri"/>
-              <a:cs typeface="Calibri"/>
-              <a:sym typeface="Calibri"/>
-            </a:endParaRPr>
-          </a:p>
-        </p:txBody>
-      </p:sp>
-      <p:sp>
-        <p:nvSpPr>
-          <p:cNvPr id="451" name="Google Shape;451;p16"/>
-          <p:cNvSpPr/>
-          <p:nvPr/>
-        </p:nvSpPr>
-        <p:spPr>
-          <a:xfrm>
-            <a:off x="6233008" y="4791456"/>
-            <a:ext cx="2558720" cy="1097280"/>
-          </a:xfrm>
-          <a:prstGeom prst="roundRect">
-            <a:avLst>
-              <a:gd fmla="val 6667" name="adj"/>
-            </a:avLst>
-          </a:prstGeom>
-          <a:solidFill>
-            <a:srgbClr val="E8F1F8"/>
-          </a:solidFill>
-          <a:ln cap="flat" cmpd="sng" w="12700">
-            <a:solidFill>
-              <a:srgbClr val="DFE5EF"/>
-            </a:solidFill>
-            <a:prstDash val="solid"/>
-            <a:round/>
-            <a:headEnd len="sm" w="sm" type="none"/>
-            <a:tailEnd len="sm" w="sm" type="none"/>
-          </a:ln>
-          <a:effectLst>
-            <a:outerShdw blurRad="127000" rotWithShape="0" algn="bl" dir="5400000" dist="25400">
-              <a:srgbClr val="8894A8">
-                <a:alpha val="18039"/>
-              </a:srgbClr>
-            </a:outerShdw>
-          </a:effectLst>
-        </p:spPr>
-        <p:txBody>
-          <a:bodyPr anchorCtr="0" anchor="ctr" bIns="91425" lIns="91425" spcFirstLastPara="1" rIns="91425" wrap="square" tIns="91425">
-            <a:noAutofit/>
-          </a:bodyPr>
-          <a:lstStyle/>
-          <a:p>
-            <a:pPr indent="0" lvl="0" marL="0" rtl="0" algn="l">
-              <a:spcBef>
-                <a:spcPts val="0"/>
-              </a:spcBef>
-              <a:spcAft>
-                <a:spcPts val="0"/>
-              </a:spcAft>
-              <a:buNone/>
-            </a:pPr>
-            <a:r>
-              <a:t/>
-            </a:r>
-            <a:endParaRPr/>
-          </a:p>
-        </p:txBody>
-      </p:sp>
-      <p:sp>
-        <p:nvSpPr>
-          <p:cNvPr id="452" name="Google Shape;452;p16"/>
-          <p:cNvSpPr/>
-          <p:nvPr/>
-        </p:nvSpPr>
-        <p:spPr>
-          <a:xfrm>
-            <a:off x="6470752" y="4956048"/>
-            <a:ext cx="2101520" cy="457200"/>
-          </a:xfrm>
-          <a:prstGeom prst="rect">
-            <a:avLst/>
-          </a:prstGeom>
-          <a:noFill/>
-          <a:ln>
-            <a:noFill/>
-          </a:ln>
-        </p:spPr>
-        <p:txBody>
-          <a:bodyPr anchorCtr="0" anchor="ctr" bIns="0" lIns="0" spcFirstLastPara="1" rIns="0" wrap="square" tIns="0">
-            <a:noAutofit/>
-          </a:bodyPr>
-          <a:lstStyle/>
-          <a:p>
-            <a:pPr indent="0" lvl="0" marL="0" marR="0" rtl="0" algn="l">
-              <a:spcBef>
-                <a:spcPts val="0"/>
-              </a:spcBef>
-              <a:spcAft>
-                <a:spcPts val="0"/>
-              </a:spcAft>
-              <a:buClr>
-                <a:srgbClr val="004381"/>
-              </a:buClr>
-              <a:buSzPts val="2400"/>
-              <a:buFont typeface="Malgun Gothic"/>
-              <a:buNone/>
-            </a:pPr>
-            <a:r>
-              <a:rPr b="1" i="0" lang="en-US" sz="2400" u="none" cap="none" strike="noStrike">
-                <a:solidFill>
-                  <a:srgbClr val="004381"/>
-                </a:solidFill>
-                <a:latin typeface="Malgun Gothic"/>
-                <a:ea typeface="Malgun Gothic"/>
-                <a:cs typeface="Malgun Gothic"/>
-                <a:sym typeface="Malgun Gothic"/>
-              </a:rPr>
-              <a:t>9</a:t>
-            </a:r>
-            <a:endParaRPr b="0" i="0" sz="2400" u="none" cap="none" strike="noStrike">
-              <a:solidFill>
-                <a:schemeClr val="dk1"/>
-              </a:solidFill>
-              <a:latin typeface="Calibri"/>
-              <a:ea typeface="Calibri"/>
-              <a:cs typeface="Calibri"/>
-              <a:sym typeface="Calibri"/>
-            </a:endParaRPr>
-          </a:p>
-        </p:txBody>
-      </p:sp>
-      <p:sp>
-        <p:nvSpPr>
-          <p:cNvPr id="453" name="Google Shape;453;p16"/>
-          <p:cNvSpPr/>
-          <p:nvPr/>
-        </p:nvSpPr>
-        <p:spPr>
-          <a:xfrm>
-            <a:off x="6470752" y="5431536"/>
-            <a:ext cx="2101520" cy="256032"/>
-          </a:xfrm>
-          <a:prstGeom prst="rect">
-            <a:avLst/>
-          </a:prstGeom>
-          <a:noFill/>
-          <a:ln>
-            <a:noFill/>
-          </a:ln>
-        </p:spPr>
-        <p:txBody>
-          <a:bodyPr anchorCtr="0" anchor="ctr" bIns="0" lIns="0" spcFirstLastPara="1" rIns="0" wrap="square" tIns="0">
-            <a:noAutofit/>
-          </a:bodyPr>
-          <a:lstStyle/>
-          <a:p>
-            <a:pPr indent="0" lvl="0" marL="0" marR="0" rtl="0" algn="l">
-              <a:spcBef>
-                <a:spcPts val="0"/>
-              </a:spcBef>
-              <a:spcAft>
-                <a:spcPts val="0"/>
-              </a:spcAft>
-              <a:buClr>
-                <a:srgbClr val="65708A"/>
-              </a:buClr>
-              <a:buSzPts val="1050"/>
-              <a:buFont typeface="Malgun Gothic"/>
-              <a:buNone/>
-            </a:pPr>
-            <a:r>
-              <a:rPr b="0" i="0" lang="en-US" sz="1050" u="none" cap="none" strike="noStrike">
-                <a:solidFill>
-                  <a:srgbClr val="65708A"/>
-                </a:solidFill>
-                <a:latin typeface="Malgun Gothic"/>
-                <a:ea typeface="Malgun Gothic"/>
-                <a:cs typeface="Malgun Gothic"/>
-                <a:sym typeface="Malgun Gothic"/>
-              </a:rPr>
-              <a:t>화면·기능 문서</a:t>
-            </a:r>
-            <a:endParaRPr b="0" i="0" sz="1050" u="none" cap="none" strike="noStrike">
-              <a:solidFill>
-                <a:schemeClr val="dk1"/>
-              </a:solidFill>
-              <a:latin typeface="Calibri"/>
-              <a:ea typeface="Calibri"/>
-              <a:cs typeface="Calibri"/>
-              <a:sym typeface="Calibri"/>
-            </a:endParaRPr>
-          </a:p>
-        </p:txBody>
-      </p:sp>
-      <p:sp>
-        <p:nvSpPr>
-          <p:cNvPr id="454" name="Google Shape;454;p16"/>
-          <p:cNvSpPr/>
-          <p:nvPr/>
-        </p:nvSpPr>
-        <p:spPr>
-          <a:xfrm>
-            <a:off x="9066047" y="4791456"/>
-            <a:ext cx="2558720" cy="1097280"/>
-          </a:xfrm>
-          <a:prstGeom prst="roundRect">
-            <a:avLst>
-              <a:gd fmla="val 6667" name="adj"/>
-            </a:avLst>
-          </a:prstGeom>
-          <a:solidFill>
-            <a:srgbClr val="E8F1F8"/>
-          </a:solidFill>
-          <a:ln cap="flat" cmpd="sng" w="12700">
-            <a:solidFill>
-              <a:srgbClr val="DFE5EF"/>
-            </a:solidFill>
-            <a:prstDash val="solid"/>
-            <a:round/>
-            <a:headEnd len="sm" w="sm" type="none"/>
-            <a:tailEnd len="sm" w="sm" type="none"/>
-          </a:ln>
-          <a:effectLst>
-            <a:outerShdw blurRad="127000" rotWithShape="0" algn="bl" dir="5400000" dist="25400">
-              <a:srgbClr val="8894A8">
-                <a:alpha val="18039"/>
-              </a:srgbClr>
-            </a:outerShdw>
-          </a:effectLst>
-        </p:spPr>
-        <p:txBody>
-          <a:bodyPr anchorCtr="0" anchor="ctr" bIns="91425" lIns="91425" spcFirstLastPara="1" rIns="91425" wrap="square" tIns="91425">
-            <a:noAutofit/>
-          </a:bodyPr>
-          <a:lstStyle/>
-          <a:p>
-            <a:pPr indent="0" lvl="0" marL="0" rtl="0" algn="l">
-              <a:spcBef>
-                <a:spcPts val="0"/>
-              </a:spcBef>
-              <a:spcAft>
-                <a:spcPts val="0"/>
-              </a:spcAft>
-              <a:buNone/>
-            </a:pPr>
-            <a:r>
-              <a:t/>
-            </a:r>
-            <a:endParaRPr/>
-          </a:p>
-        </p:txBody>
-      </p:sp>
-      <p:sp>
-        <p:nvSpPr>
-          <p:cNvPr id="455" name="Google Shape;455;p16"/>
-          <p:cNvSpPr/>
-          <p:nvPr/>
-        </p:nvSpPr>
-        <p:spPr>
-          <a:xfrm>
-            <a:off x="9303791" y="4956048"/>
-            <a:ext cx="2101520" cy="457200"/>
-          </a:xfrm>
-          <a:prstGeom prst="rect">
-            <a:avLst/>
-          </a:prstGeom>
-          <a:noFill/>
-          <a:ln>
-            <a:noFill/>
-          </a:ln>
-        </p:spPr>
-        <p:txBody>
-          <a:bodyPr anchorCtr="0" anchor="ctr" bIns="0" lIns="0" spcFirstLastPara="1" rIns="0" wrap="square" tIns="0">
-            <a:noAutofit/>
-          </a:bodyPr>
-          <a:lstStyle/>
-          <a:p>
-            <a:pPr indent="0" lvl="0" marL="0" marR="0" rtl="0" algn="l">
-              <a:spcBef>
-                <a:spcPts val="0"/>
-              </a:spcBef>
-              <a:spcAft>
-                <a:spcPts val="0"/>
-              </a:spcAft>
-              <a:buClr>
-                <a:srgbClr val="004381"/>
-              </a:buClr>
-              <a:buSzPts val="2400"/>
-              <a:buFont typeface="Malgun Gothic"/>
-              <a:buNone/>
-            </a:pPr>
-            <a:r>
-              <a:rPr b="1" i="0" lang="en-US" sz="2400" u="none" cap="none" strike="noStrike">
-                <a:solidFill>
-                  <a:srgbClr val="004381"/>
-                </a:solidFill>
-                <a:latin typeface="Malgun Gothic"/>
-                <a:ea typeface="Malgun Gothic"/>
-                <a:cs typeface="Malgun Gothic"/>
-                <a:sym typeface="Malgun Gothic"/>
-              </a:rPr>
-              <a:t>37,248</a:t>
-            </a:r>
-            <a:endParaRPr b="0" i="0" sz="2400" u="none" cap="none" strike="noStrike">
-              <a:solidFill>
-                <a:schemeClr val="dk1"/>
-              </a:solidFill>
-              <a:latin typeface="Calibri"/>
-              <a:ea typeface="Calibri"/>
-              <a:cs typeface="Calibri"/>
-              <a:sym typeface="Calibri"/>
-            </a:endParaRPr>
-          </a:p>
-        </p:txBody>
-      </p:sp>
-      <p:sp>
-        <p:nvSpPr>
-          <p:cNvPr id="456" name="Google Shape;456;p16"/>
-          <p:cNvSpPr/>
-          <p:nvPr/>
-        </p:nvSpPr>
-        <p:spPr>
-          <a:xfrm>
-            <a:off x="9303791" y="5431536"/>
-            <a:ext cx="2101520" cy="256032"/>
-          </a:xfrm>
-          <a:prstGeom prst="rect">
-            <a:avLst/>
-          </a:prstGeom>
-          <a:noFill/>
-          <a:ln>
-            <a:noFill/>
-          </a:ln>
-        </p:spPr>
-        <p:txBody>
-          <a:bodyPr anchorCtr="0" anchor="ctr" bIns="0" lIns="0" spcFirstLastPara="1" rIns="0" wrap="square" tIns="0">
-            <a:noAutofit/>
-          </a:bodyPr>
-          <a:lstStyle/>
-          <a:p>
-            <a:pPr indent="0" lvl="0" marL="0" marR="0" rtl="0" algn="l">
-              <a:spcBef>
-                <a:spcPts val="0"/>
-              </a:spcBef>
-              <a:spcAft>
-                <a:spcPts val="0"/>
-              </a:spcAft>
-              <a:buClr>
-                <a:srgbClr val="65708A"/>
-              </a:buClr>
-              <a:buSzPts val="1050"/>
-              <a:buFont typeface="Malgun Gothic"/>
-              <a:buNone/>
-            </a:pPr>
-            <a:r>
-              <a:rPr b="0" i="0" lang="en-US" sz="1050" u="none" cap="none" strike="noStrike">
-                <a:solidFill>
-                  <a:srgbClr val="65708A"/>
-                </a:solidFill>
-                <a:latin typeface="Malgun Gothic"/>
-                <a:ea typeface="Malgun Gothic"/>
-                <a:cs typeface="Malgun Gothic"/>
-                <a:sym typeface="Malgun Gothic"/>
-              </a:rPr>
-              <a:t>적재 응답 레코드</a:t>
-            </a:r>
-            <a:endParaRPr b="0" i="0" sz="1050" u="none" cap="none" strike="noStrike">
               <a:solidFill>
                 <a:schemeClr val="dk1"/>
               </a:solidFill>
@@ -9038,7 +7537,7 @@
                 <a:cs typeface="Malgun Gothic"/>
                 <a:sym typeface="Malgun Gothic"/>
               </a:rPr>
-              <a:t>10</a:t>
+              <a:t>9</a:t>
             </a:r>
             <a:endParaRPr b="0" i="0" sz="1000" u="none" cap="none" strike="noStrike">
               <a:solidFill>
@@ -9285,7 +7784,7 @@
                 <a:cs typeface="Malgun Gothic"/>
                 <a:sym typeface="Malgun Gothic"/>
               </a:rPr>
-              <a:t>인증</a:t>
+              <a:t>로그인</a:t>
             </a:r>
             <a:endParaRPr b="0" i="0" sz="1300" u="none" cap="none" strike="noStrike">
               <a:solidFill>
@@ -9348,7 +7847,7 @@
                 <a:cs typeface="Malgun Gothic"/>
                 <a:sym typeface="Malgun Gothic"/>
               </a:rPr>
-              <a:t>조직 선택 + 생년월일 6자리</a:t>
+              <a:t>조직 선택 후 생년월일 입력</a:t>
             </a:r>
             <a:endParaRPr b="0" i="0" sz="1100" u="none" cap="none" strike="noStrike">
               <a:solidFill>
@@ -9457,7 +7956,7 @@
                 <a:cs typeface="Malgun Gothic"/>
                 <a:sym typeface="Malgun Gothic"/>
               </a:rPr>
-              <a:t>사내 SSO 연동 및 권한 매핑</a:t>
+              <a:t>사내 시스템 계정으로 바로 로그인</a:t>
             </a:r>
             <a:endParaRPr b="0" i="0" sz="1100" u="none" cap="none" strike="noStrike">
               <a:solidFill>
@@ -9578,7 +8077,7 @@
                 <a:cs typeface="Malgun Gothic"/>
                 <a:sym typeface="Malgun Gothic"/>
               </a:rPr>
-              <a:t>데이터</a:t>
+              <a:t>진단 데이터</a:t>
             </a:r>
             <a:endParaRPr b="0" i="0" sz="1300" u="none" cap="none" strike="noStrike">
               <a:solidFill>
@@ -9641,7 +8140,7 @@
                 <a:cs typeface="Malgun Gothic"/>
                 <a:sym typeface="Malgun Gothic"/>
               </a:rPr>
-              <a:t>합성 더미 데이터 6개 부서</a:t>
+              <a:t>시연용 가상 데이터 6개 부서</a:t>
             </a:r>
             <a:endParaRPr b="0" i="0" sz="1100" u="none" cap="none" strike="noStrike">
               <a:solidFill>
@@ -9750,7 +8249,7 @@
                 <a:cs typeface="Malgun Gothic"/>
                 <a:sym typeface="Malgun Gothic"/>
               </a:rPr>
-              <a:t>실제 설문 결과 연동 및 조직 마스터 동기화</a:t>
+              <a:t>실제 설문 결과 자동 연동 · 조직 개편 반영</a:t>
             </a:r>
             <a:endParaRPr b="0" i="0" sz="1100" u="none" cap="none" strike="noStrike">
               <a:solidFill>
@@ -9871,7 +8370,7 @@
                 <a:cs typeface="Malgun Gothic"/>
                 <a:sym typeface="Malgun Gothic"/>
               </a:rPr>
-              <a:t>보안</a:t>
+              <a:t>정보 보호</a:t>
             </a:r>
             <a:endParaRPr b="0" i="0" sz="1300" u="none" cap="none" strike="noStrike">
               <a:solidFill>
@@ -9934,7 +8433,7 @@
                 <a:cs typeface="Malgun Gothic"/>
                 <a:sym typeface="Malgun Gothic"/>
               </a:rPr>
-              <a:t>SHA-256 해시 · 로컬 세션</a:t>
+              <a:t>시연 수준의 기본 보호</a:t>
             </a:r>
             <a:endParaRPr b="0" i="0" sz="1100" u="none" cap="none" strike="noStrike">
               <a:solidFill>
@@ -10043,7 +8542,7 @@
                 <a:cs typeface="Malgun Gothic"/>
                 <a:sym typeface="Malgun Gothic"/>
               </a:rPr>
-              <a:t>bcrypt/argon2 · 서버 세션 스토어 · 전송 암호화</a:t>
+              <a:t>전사 보안 기준 적용 · 열람 권한 세분화</a:t>
             </a:r>
             <a:endParaRPr b="0" i="0" sz="1100" u="none" cap="none" strike="noStrike">
               <a:solidFill>
@@ -10164,7 +8663,7 @@
                 <a:cs typeface="Malgun Gothic"/>
                 <a:sym typeface="Malgun Gothic"/>
               </a:rPr>
-              <a:t>AI 비용</a:t>
+              <a:t>AI 이용</a:t>
             </a:r>
             <a:endParaRPr b="0" i="0" sz="1300" u="none" cap="none" strike="noStrike">
               <a:solidFill>
@@ -10227,7 +8726,7 @@
                 <a:cs typeface="Malgun Gothic"/>
                 <a:sym typeface="Malgun Gothic"/>
               </a:rPr>
-              <a:t>질문마다 외부 API 호출</a:t>
+              <a:t>질문할 때마다 외부 AI 호출</a:t>
             </a:r>
             <a:endParaRPr b="0" i="0" sz="1100" u="none" cap="none" strike="noStrike">
               <a:solidFill>
@@ -10336,7 +8835,7 @@
                 <a:cs typeface="Malgun Gothic"/>
                 <a:sym typeface="Malgun Gothic"/>
               </a:rPr>
-              <a:t>응답 캐싱 및 호출량 상한 정책</a:t>
+              <a:t>자주 나오는 답변 재사용으로 비용 관리</a:t>
             </a:r>
             <a:endParaRPr b="0" i="0" sz="1100" u="none" cap="none" strike="noStrike">
               <a:solidFill>
@@ -10457,7 +8956,7 @@
                 <a:cs typeface="Malgun Gothic"/>
                 <a:sym typeface="Malgun Gothic"/>
               </a:rPr>
-              <a:t>운영</a:t>
+              <a:t>동시 사용</a:t>
             </a:r>
             <a:endParaRPr b="0" i="0" sz="1300" u="none" cap="none" strike="noStrike">
               <a:solidFill>
@@ -10520,7 +9019,7 @@
                 <a:cs typeface="Malgun Gothic"/>
                 <a:sym typeface="Malgun Gothic"/>
               </a:rPr>
-              <a:t>단일 프로세스 로컬 구동</a:t>
+              <a:t>1대에서 시연용으로 구동</a:t>
             </a:r>
             <a:endParaRPr b="0" i="0" sz="1100" u="none" cap="none" strike="noStrike">
               <a:solidFill>
@@ -10629,7 +9128,7 @@
                 <a:cs typeface="Malgun Gothic"/>
                 <a:sym typeface="Malgun Gothic"/>
               </a:rPr>
-              <a:t>다중 워커 구성 및 DB 이관(PostgreSQL 등)</a:t>
+              <a:t>전 부서가 동시에 접속하는 운영 환경</a:t>
             </a:r>
             <a:endParaRPr b="0" i="0" sz="1100" u="none" cap="none" strike="noStrike">
               <a:solidFill>
@@ -16476,2345 +14975,6 @@
 </p:sld>
 </file>
 
-<file path=ppt/slides/slide5.xml><?xml version="1.0" encoding="utf-8"?>
-<p:sld xmlns:a="http://schemas.openxmlformats.org/drawingml/2006/main" xmlns:r="http://schemas.openxmlformats.org/officeDocument/2006/relationships" xmlns:mc="http://schemas.openxmlformats.org/markup-compatibility/2006" xmlns:mv="urn:schemas-microsoft-com:mac:vml" xmlns:p="http://schemas.openxmlformats.org/presentationml/2006/main" xmlns:c="http://schemas.openxmlformats.org/drawingml/2006/chart" xmlns:dgm="http://schemas.openxmlformats.org/drawingml/2006/diagram" xmlns:o="urn:schemas-microsoft-com:office:office" xmlns:v="urn:schemas-microsoft-com:vml" xmlns:pvml="urn:schemas-microsoft-com:office:powerpoint" xmlns:com="http://schemas.openxmlformats.org/drawingml/2006/compatibility" xmlns:p14="http://schemas.microsoft.com/office/powerpoint/2010/main" xmlns:p15="http://schemas.microsoft.com/office/powerpoint/2012/main" xmlns:ahyp="http://schemas.microsoft.com/office/drawing/2018/hyperlinkcolor">
-  <p:cSld>
-    <p:bg>
-      <p:bgPr>
-        <a:solidFill>
-          <a:srgbClr val="F5F7FB"/>
-        </a:solidFill>
-      </p:bgPr>
-    </p:bg>
-    <p:spTree>
-      <p:nvGrpSpPr>
-        <p:cNvPr id="121" name="Shape 121"/>
-        <p:cNvGrpSpPr/>
-        <p:nvPr/>
-      </p:nvGrpSpPr>
-      <p:grpSpPr>
-        <a:xfrm>
-          <a:off x="0" y="0"/>
-          <a:ext cx="0" cy="0"/>
-          <a:chOff x="0" y="0"/>
-          <a:chExt cx="0" cy="0"/>
-        </a:xfrm>
-      </p:grpSpPr>
-      <p:sp>
-        <p:nvSpPr>
-          <p:cNvPr id="122" name="Google Shape;122;p7"/>
-          <p:cNvSpPr/>
-          <p:nvPr/>
-        </p:nvSpPr>
-        <p:spPr>
-          <a:xfrm>
-            <a:off x="566928" y="365760"/>
-            <a:ext cx="11057839" cy="219456"/>
-          </a:xfrm>
-          <a:prstGeom prst="rect">
-            <a:avLst/>
-          </a:prstGeom>
-          <a:noFill/>
-          <a:ln>
-            <a:noFill/>
-          </a:ln>
-        </p:spPr>
-        <p:txBody>
-          <a:bodyPr anchorCtr="0" anchor="ctr" bIns="0" lIns="0" spcFirstLastPara="1" rIns="0" wrap="square" tIns="0">
-            <a:noAutofit/>
-          </a:bodyPr>
-          <a:lstStyle/>
-          <a:p>
-            <a:pPr indent="0" lvl="0" marL="0" marR="0" rtl="0" algn="l">
-              <a:spcBef>
-                <a:spcPts val="0"/>
-              </a:spcBef>
-              <a:spcAft>
-                <a:spcPts val="0"/>
-              </a:spcAft>
-              <a:buClr>
-                <a:srgbClr val="0098D9"/>
-              </a:buClr>
-              <a:buSzPts val="1100"/>
-              <a:buFont typeface="Malgun Gothic"/>
-              <a:buNone/>
-            </a:pPr>
-            <a:r>
-              <a:rPr b="1" i="0" lang="en-US" sz="1100" u="none" cap="none" strike="noStrike">
-                <a:solidFill>
-                  <a:srgbClr val="0098D9"/>
-                </a:solidFill>
-                <a:latin typeface="Malgun Gothic"/>
-                <a:ea typeface="Malgun Gothic"/>
-                <a:cs typeface="Malgun Gothic"/>
-                <a:sym typeface="Malgun Gothic"/>
-              </a:rPr>
-              <a:t>ARCHITECTURE</a:t>
-            </a:r>
-            <a:endParaRPr b="0" i="0" sz="1100" u="none" cap="none" strike="noStrike">
-              <a:solidFill>
-                <a:schemeClr val="dk1"/>
-              </a:solidFill>
-              <a:latin typeface="Calibri"/>
-              <a:ea typeface="Calibri"/>
-              <a:cs typeface="Calibri"/>
-              <a:sym typeface="Calibri"/>
-            </a:endParaRPr>
-          </a:p>
-        </p:txBody>
-      </p:sp>
-      <p:sp>
-        <p:nvSpPr>
-          <p:cNvPr id="123" name="Google Shape;123;p7"/>
-          <p:cNvSpPr/>
-          <p:nvPr/>
-        </p:nvSpPr>
-        <p:spPr>
-          <a:xfrm>
-            <a:off x="566928" y="603504"/>
-            <a:ext cx="11057839" cy="566928"/>
-          </a:xfrm>
-          <a:prstGeom prst="rect">
-            <a:avLst/>
-          </a:prstGeom>
-          <a:noFill/>
-          <a:ln>
-            <a:noFill/>
-          </a:ln>
-        </p:spPr>
-        <p:txBody>
-          <a:bodyPr anchorCtr="0" anchor="ctr" bIns="0" lIns="0" spcFirstLastPara="1" rIns="0" wrap="square" tIns="0">
-            <a:noAutofit/>
-          </a:bodyPr>
-          <a:lstStyle/>
-          <a:p>
-            <a:pPr indent="0" lvl="0" marL="0" marR="0" rtl="0" algn="l">
-              <a:spcBef>
-                <a:spcPts val="0"/>
-              </a:spcBef>
-              <a:spcAft>
-                <a:spcPts val="0"/>
-              </a:spcAft>
-              <a:buClr>
-                <a:srgbClr val="002D5A"/>
-              </a:buClr>
-              <a:buSzPts val="3000"/>
-              <a:buFont typeface="Malgun Gothic"/>
-              <a:buNone/>
-            </a:pPr>
-            <a:r>
-              <a:rPr b="1" i="0" lang="en-US" sz="3000" u="none" cap="none" strike="noStrike">
-                <a:solidFill>
-                  <a:srgbClr val="002D5A"/>
-                </a:solidFill>
-                <a:latin typeface="Malgun Gothic"/>
-                <a:ea typeface="Malgun Gothic"/>
-                <a:cs typeface="Malgun Gothic"/>
-                <a:sym typeface="Malgun Gothic"/>
-              </a:rPr>
-              <a:t>역할을 나눠 해석 로직을 한 곳에 집약</a:t>
-            </a:r>
-            <a:endParaRPr b="0" i="0" sz="3000" u="none" cap="none" strike="noStrike">
-              <a:solidFill>
-                <a:schemeClr val="dk1"/>
-              </a:solidFill>
-              <a:latin typeface="Calibri"/>
-              <a:ea typeface="Calibri"/>
-              <a:cs typeface="Calibri"/>
-              <a:sym typeface="Calibri"/>
-            </a:endParaRPr>
-          </a:p>
-        </p:txBody>
-      </p:sp>
-      <p:sp>
-        <p:nvSpPr>
-          <p:cNvPr id="124" name="Google Shape;124;p7"/>
-          <p:cNvSpPr/>
-          <p:nvPr/>
-        </p:nvSpPr>
-        <p:spPr>
-          <a:xfrm>
-            <a:off x="11076127" y="6355080"/>
-            <a:ext cx="548640" cy="256032"/>
-          </a:xfrm>
-          <a:prstGeom prst="rect">
-            <a:avLst/>
-          </a:prstGeom>
-          <a:noFill/>
-          <a:ln>
-            <a:noFill/>
-          </a:ln>
-        </p:spPr>
-        <p:txBody>
-          <a:bodyPr anchorCtr="0" anchor="ctr" bIns="0" lIns="0" spcFirstLastPara="1" rIns="0" wrap="square" tIns="0">
-            <a:noAutofit/>
-          </a:bodyPr>
-          <a:lstStyle/>
-          <a:p>
-            <a:pPr indent="0" lvl="0" marL="0" marR="0" rtl="0" algn="r">
-              <a:spcBef>
-                <a:spcPts val="0"/>
-              </a:spcBef>
-              <a:spcAft>
-                <a:spcPts val="0"/>
-              </a:spcAft>
-              <a:buClr>
-                <a:srgbClr val="65708A"/>
-              </a:buClr>
-              <a:buSzPts val="1000"/>
-              <a:buFont typeface="Malgun Gothic"/>
-              <a:buNone/>
-            </a:pPr>
-            <a:r>
-              <a:rPr b="0" i="0" lang="en-US" sz="1000" u="none" cap="none" strike="noStrike">
-                <a:solidFill>
-                  <a:srgbClr val="65708A"/>
-                </a:solidFill>
-                <a:latin typeface="Malgun Gothic"/>
-                <a:ea typeface="Malgun Gothic"/>
-                <a:cs typeface="Malgun Gothic"/>
-                <a:sym typeface="Malgun Gothic"/>
-              </a:rPr>
-              <a:t>4</a:t>
-            </a:r>
-            <a:endParaRPr b="0" i="0" sz="1000" u="none" cap="none" strike="noStrike">
-              <a:solidFill>
-                <a:schemeClr val="dk1"/>
-              </a:solidFill>
-              <a:latin typeface="Calibri"/>
-              <a:ea typeface="Calibri"/>
-              <a:cs typeface="Calibri"/>
-              <a:sym typeface="Calibri"/>
-            </a:endParaRPr>
-          </a:p>
-        </p:txBody>
-      </p:sp>
-      <p:sp>
-        <p:nvSpPr>
-          <p:cNvPr id="125" name="Google Shape;125;p7"/>
-          <p:cNvSpPr/>
-          <p:nvPr/>
-        </p:nvSpPr>
-        <p:spPr>
-          <a:xfrm>
-            <a:off x="566928" y="1426464"/>
-            <a:ext cx="11057839" cy="1481328"/>
-          </a:xfrm>
-          <a:prstGeom prst="roundRect">
-            <a:avLst>
-              <a:gd fmla="val 4938" name="adj"/>
-            </a:avLst>
-          </a:prstGeom>
-          <a:solidFill>
-            <a:srgbClr val="FFFFFF"/>
-          </a:solidFill>
-          <a:ln cap="flat" cmpd="sng" w="12700">
-            <a:solidFill>
-              <a:srgbClr val="DFE5EF"/>
-            </a:solidFill>
-            <a:prstDash val="solid"/>
-            <a:round/>
-            <a:headEnd len="sm" w="sm" type="none"/>
-            <a:tailEnd len="sm" w="sm" type="none"/>
-          </a:ln>
-          <a:effectLst>
-            <a:outerShdw blurRad="127000" rotWithShape="0" algn="bl" dir="5400000" dist="25400">
-              <a:srgbClr val="8894A8">
-                <a:alpha val="18039"/>
-              </a:srgbClr>
-            </a:outerShdw>
-          </a:effectLst>
-        </p:spPr>
-        <p:txBody>
-          <a:bodyPr anchorCtr="0" anchor="ctr" bIns="91425" lIns="91425" spcFirstLastPara="1" rIns="91425" wrap="square" tIns="91425">
-            <a:noAutofit/>
-          </a:bodyPr>
-          <a:lstStyle/>
-          <a:p>
-            <a:pPr indent="0" lvl="0" marL="0" rtl="0" algn="l">
-              <a:spcBef>
-                <a:spcPts val="0"/>
-              </a:spcBef>
-              <a:spcAft>
-                <a:spcPts val="0"/>
-              </a:spcAft>
-              <a:buNone/>
-            </a:pPr>
-            <a:r>
-              <a:t/>
-            </a:r>
-            <a:endParaRPr/>
-          </a:p>
-        </p:txBody>
-      </p:sp>
-      <p:sp>
-        <p:nvSpPr>
-          <p:cNvPr id="126" name="Google Shape;126;p7"/>
-          <p:cNvSpPr/>
-          <p:nvPr/>
-        </p:nvSpPr>
-        <p:spPr>
-          <a:xfrm>
-            <a:off x="804672" y="1664208"/>
-            <a:ext cx="1572768" cy="420624"/>
-          </a:xfrm>
-          <a:prstGeom prst="roundRect">
-            <a:avLst>
-              <a:gd fmla="val 19565" name="adj"/>
-            </a:avLst>
-          </a:prstGeom>
-          <a:solidFill>
-            <a:srgbClr val="004381"/>
-          </a:solidFill>
-          <a:ln>
-            <a:noFill/>
-          </a:ln>
-        </p:spPr>
-        <p:txBody>
-          <a:bodyPr anchorCtr="0" anchor="ctr" bIns="91425" lIns="91425" spcFirstLastPara="1" rIns="91425" wrap="square" tIns="91425">
-            <a:noAutofit/>
-          </a:bodyPr>
-          <a:lstStyle/>
-          <a:p>
-            <a:pPr indent="0" lvl="0" marL="0" rtl="0" algn="l">
-              <a:spcBef>
-                <a:spcPts val="0"/>
-              </a:spcBef>
-              <a:spcAft>
-                <a:spcPts val="0"/>
-              </a:spcAft>
-              <a:buNone/>
-            </a:pPr>
-            <a:r>
-              <a:t/>
-            </a:r>
-            <a:endParaRPr/>
-          </a:p>
-        </p:txBody>
-      </p:sp>
-      <p:sp>
-        <p:nvSpPr>
-          <p:cNvPr id="127" name="Google Shape;127;p7"/>
-          <p:cNvSpPr/>
-          <p:nvPr/>
-        </p:nvSpPr>
-        <p:spPr>
-          <a:xfrm>
-            <a:off x="804672" y="1664208"/>
-            <a:ext cx="1572768" cy="420624"/>
-          </a:xfrm>
-          <a:prstGeom prst="rect">
-            <a:avLst/>
-          </a:prstGeom>
-          <a:noFill/>
-          <a:ln>
-            <a:noFill/>
-          </a:ln>
-        </p:spPr>
-        <p:txBody>
-          <a:bodyPr anchorCtr="0" anchor="ctr" bIns="0" lIns="0" spcFirstLastPara="1" rIns="0" wrap="square" tIns="0">
-            <a:noAutofit/>
-          </a:bodyPr>
-          <a:lstStyle/>
-          <a:p>
-            <a:pPr indent="0" lvl="0" marL="0" marR="0" rtl="0" algn="ctr">
-              <a:spcBef>
-                <a:spcPts val="0"/>
-              </a:spcBef>
-              <a:spcAft>
-                <a:spcPts val="0"/>
-              </a:spcAft>
-              <a:buClr>
-                <a:srgbClr val="FFFFFF"/>
-              </a:buClr>
-              <a:buSzPts val="1150"/>
-              <a:buFont typeface="Malgun Gothic"/>
-              <a:buNone/>
-            </a:pPr>
-            <a:r>
-              <a:rPr b="1" i="0" lang="en-US" sz="1150" u="none" cap="none" strike="noStrike">
-                <a:solidFill>
-                  <a:srgbClr val="FFFFFF"/>
-                </a:solidFill>
-                <a:latin typeface="Malgun Gothic"/>
-                <a:ea typeface="Malgun Gothic"/>
-                <a:cs typeface="Malgun Gothic"/>
-                <a:sym typeface="Malgun Gothic"/>
-              </a:rPr>
-              <a:t>Presentation</a:t>
-            </a:r>
-            <a:endParaRPr b="0" i="0" sz="1150" u="none" cap="none" strike="noStrike">
-              <a:solidFill>
-                <a:schemeClr val="dk1"/>
-              </a:solidFill>
-              <a:latin typeface="Calibri"/>
-              <a:ea typeface="Calibri"/>
-              <a:cs typeface="Calibri"/>
-              <a:sym typeface="Calibri"/>
-            </a:endParaRPr>
-          </a:p>
-        </p:txBody>
-      </p:sp>
-      <p:sp>
-        <p:nvSpPr>
-          <p:cNvPr id="128" name="Google Shape;128;p7"/>
-          <p:cNvSpPr/>
-          <p:nvPr/>
-        </p:nvSpPr>
-        <p:spPr>
-          <a:xfrm>
-            <a:off x="2596896" y="1609344"/>
-            <a:ext cx="2753258" cy="1097280"/>
-          </a:xfrm>
-          <a:prstGeom prst="roundRect">
-            <a:avLst>
-              <a:gd fmla="val 5833" name="adj"/>
-            </a:avLst>
-          </a:prstGeom>
-          <a:solidFill>
-            <a:srgbClr val="F5F7FB"/>
-          </a:solidFill>
-          <a:ln cap="flat" cmpd="sng" w="12700">
-            <a:solidFill>
-              <a:srgbClr val="DFE5EF"/>
-            </a:solidFill>
-            <a:prstDash val="solid"/>
-            <a:round/>
-            <a:headEnd len="sm" w="sm" type="none"/>
-            <a:tailEnd len="sm" w="sm" type="none"/>
-          </a:ln>
-        </p:spPr>
-        <p:txBody>
-          <a:bodyPr anchorCtr="0" anchor="ctr" bIns="91425" lIns="91425" spcFirstLastPara="1" rIns="91425" wrap="square" tIns="91425">
-            <a:noAutofit/>
-          </a:bodyPr>
-          <a:lstStyle/>
-          <a:p>
-            <a:pPr indent="0" lvl="0" marL="0" rtl="0" algn="l">
-              <a:spcBef>
-                <a:spcPts val="0"/>
-              </a:spcBef>
-              <a:spcAft>
-                <a:spcPts val="0"/>
-              </a:spcAft>
-              <a:buNone/>
-            </a:pPr>
-            <a:r>
-              <a:t/>
-            </a:r>
-            <a:endParaRPr/>
-          </a:p>
-        </p:txBody>
-      </p:sp>
-      <p:sp>
-        <p:nvSpPr>
-          <p:cNvPr id="129" name="Google Shape;129;p7"/>
-          <p:cNvSpPr/>
-          <p:nvPr/>
-        </p:nvSpPr>
-        <p:spPr>
-          <a:xfrm>
-            <a:off x="2779776" y="1755648"/>
-            <a:ext cx="2387498" cy="274320"/>
-          </a:xfrm>
-          <a:prstGeom prst="rect">
-            <a:avLst/>
-          </a:prstGeom>
-          <a:noFill/>
-          <a:ln>
-            <a:noFill/>
-          </a:ln>
-        </p:spPr>
-        <p:txBody>
-          <a:bodyPr anchorCtr="0" anchor="ctr" bIns="0" lIns="0" spcFirstLastPara="1" rIns="0" wrap="square" tIns="0">
-            <a:noAutofit/>
-          </a:bodyPr>
-          <a:lstStyle/>
-          <a:p>
-            <a:pPr indent="0" lvl="0" marL="0" marR="0" rtl="0" algn="l">
-              <a:spcBef>
-                <a:spcPts val="0"/>
-              </a:spcBef>
-              <a:spcAft>
-                <a:spcPts val="0"/>
-              </a:spcAft>
-              <a:buClr>
-                <a:srgbClr val="002D5A"/>
-              </a:buClr>
-              <a:buSzPts val="1200"/>
-              <a:buFont typeface="Malgun Gothic"/>
-              <a:buNone/>
-            </a:pPr>
-            <a:r>
-              <a:rPr b="1" i="0" lang="en-US" sz="1200" u="none" cap="none" strike="noStrike">
-                <a:solidFill>
-                  <a:srgbClr val="002D5A"/>
-                </a:solidFill>
-                <a:latin typeface="Malgun Gothic"/>
-                <a:ea typeface="Malgun Gothic"/>
-                <a:cs typeface="Malgun Gothic"/>
-                <a:sym typeface="Malgun Gothic"/>
-              </a:rPr>
-              <a:t>FastAPI + Jinja2</a:t>
-            </a:r>
-            <a:endParaRPr b="0" i="0" sz="1200" u="none" cap="none" strike="noStrike">
-              <a:solidFill>
-                <a:schemeClr val="dk1"/>
-              </a:solidFill>
-              <a:latin typeface="Calibri"/>
-              <a:ea typeface="Calibri"/>
-              <a:cs typeface="Calibri"/>
-              <a:sym typeface="Calibri"/>
-            </a:endParaRPr>
-          </a:p>
-        </p:txBody>
-      </p:sp>
-      <p:sp>
-        <p:nvSpPr>
-          <p:cNvPr id="130" name="Google Shape;130;p7"/>
-          <p:cNvSpPr/>
-          <p:nvPr/>
-        </p:nvSpPr>
-        <p:spPr>
-          <a:xfrm>
-            <a:off x="2779776" y="2048256"/>
-            <a:ext cx="2387498" cy="566928"/>
-          </a:xfrm>
-          <a:prstGeom prst="rect">
-            <a:avLst/>
-          </a:prstGeom>
-          <a:noFill/>
-          <a:ln>
-            <a:noFill/>
-          </a:ln>
-        </p:spPr>
-        <p:txBody>
-          <a:bodyPr anchorCtr="0" anchor="ctr" bIns="0" lIns="0" spcFirstLastPara="1" rIns="0" wrap="square" tIns="0">
-            <a:noAutofit/>
-          </a:bodyPr>
-          <a:lstStyle/>
-          <a:p>
-            <a:pPr indent="0" lvl="0" marL="0" marR="0" rtl="0" algn="l">
-              <a:lnSpc>
-                <a:spcPct val="140000"/>
-              </a:lnSpc>
-              <a:spcBef>
-                <a:spcPts val="0"/>
-              </a:spcBef>
-              <a:spcAft>
-                <a:spcPts val="0"/>
-              </a:spcAft>
-              <a:buClr>
-                <a:srgbClr val="65708A"/>
-              </a:buClr>
-              <a:buSzPts val="1000"/>
-              <a:buFont typeface="Malgun Gothic"/>
-              <a:buNone/>
-            </a:pPr>
-            <a:r>
-              <a:rPr b="0" i="0" lang="en-US" sz="1000" u="none" cap="none" strike="noStrike">
-                <a:solidFill>
-                  <a:srgbClr val="65708A"/>
-                </a:solidFill>
-                <a:latin typeface="Malgun Gothic"/>
-                <a:ea typeface="Malgun Gothic"/>
-                <a:cs typeface="Malgun Gothic"/>
-                <a:sym typeface="Malgun Gothic"/>
-              </a:rPr>
-              <a:t>서버 렌더링 4개 화면</a:t>
-            </a:r>
-            <a:endParaRPr b="0" i="0" sz="1000" u="none" cap="none" strike="noStrike">
-              <a:solidFill>
-                <a:schemeClr val="dk1"/>
-              </a:solidFill>
-              <a:latin typeface="Calibri"/>
-              <a:ea typeface="Calibri"/>
-              <a:cs typeface="Calibri"/>
-              <a:sym typeface="Calibri"/>
-            </a:endParaRPr>
-          </a:p>
-        </p:txBody>
-      </p:sp>
-      <p:sp>
-        <p:nvSpPr>
-          <p:cNvPr id="131" name="Google Shape;131;p7"/>
-          <p:cNvSpPr/>
-          <p:nvPr/>
-        </p:nvSpPr>
-        <p:spPr>
-          <a:xfrm>
-            <a:off x="5606186" y="1609344"/>
-            <a:ext cx="2753258" cy="1097280"/>
-          </a:xfrm>
-          <a:prstGeom prst="roundRect">
-            <a:avLst>
-              <a:gd fmla="val 5833" name="adj"/>
-            </a:avLst>
-          </a:prstGeom>
-          <a:solidFill>
-            <a:srgbClr val="F5F7FB"/>
-          </a:solidFill>
-          <a:ln cap="flat" cmpd="sng" w="12700">
-            <a:solidFill>
-              <a:srgbClr val="DFE5EF"/>
-            </a:solidFill>
-            <a:prstDash val="solid"/>
-            <a:round/>
-            <a:headEnd len="sm" w="sm" type="none"/>
-            <a:tailEnd len="sm" w="sm" type="none"/>
-          </a:ln>
-        </p:spPr>
-        <p:txBody>
-          <a:bodyPr anchorCtr="0" anchor="ctr" bIns="91425" lIns="91425" spcFirstLastPara="1" rIns="91425" wrap="square" tIns="91425">
-            <a:noAutofit/>
-          </a:bodyPr>
-          <a:lstStyle/>
-          <a:p>
-            <a:pPr indent="0" lvl="0" marL="0" rtl="0" algn="l">
-              <a:spcBef>
-                <a:spcPts val="0"/>
-              </a:spcBef>
-              <a:spcAft>
-                <a:spcPts val="0"/>
-              </a:spcAft>
-              <a:buNone/>
-            </a:pPr>
-            <a:r>
-              <a:t/>
-            </a:r>
-            <a:endParaRPr/>
-          </a:p>
-        </p:txBody>
-      </p:sp>
-      <p:sp>
-        <p:nvSpPr>
-          <p:cNvPr id="132" name="Google Shape;132;p7"/>
-          <p:cNvSpPr/>
-          <p:nvPr/>
-        </p:nvSpPr>
-        <p:spPr>
-          <a:xfrm>
-            <a:off x="5789066" y="1755648"/>
-            <a:ext cx="2387498" cy="274320"/>
-          </a:xfrm>
-          <a:prstGeom prst="rect">
-            <a:avLst/>
-          </a:prstGeom>
-          <a:noFill/>
-          <a:ln>
-            <a:noFill/>
-          </a:ln>
-        </p:spPr>
-        <p:txBody>
-          <a:bodyPr anchorCtr="0" anchor="ctr" bIns="0" lIns="0" spcFirstLastPara="1" rIns="0" wrap="square" tIns="0">
-            <a:noAutofit/>
-          </a:bodyPr>
-          <a:lstStyle/>
-          <a:p>
-            <a:pPr indent="0" lvl="0" marL="0" marR="0" rtl="0" algn="l">
-              <a:spcBef>
-                <a:spcPts val="0"/>
-              </a:spcBef>
-              <a:spcAft>
-                <a:spcPts val="0"/>
-              </a:spcAft>
-              <a:buClr>
-                <a:srgbClr val="002D5A"/>
-              </a:buClr>
-              <a:buSzPts val="1200"/>
-              <a:buFont typeface="Malgun Gothic"/>
-              <a:buNone/>
-            </a:pPr>
-            <a:r>
-              <a:rPr b="1" i="0" lang="en-US" sz="1200" u="none" cap="none" strike="noStrike">
-                <a:solidFill>
-                  <a:srgbClr val="002D5A"/>
-                </a:solidFill>
-                <a:latin typeface="Malgun Gothic"/>
-                <a:ea typeface="Malgun Gothic"/>
-                <a:cs typeface="Malgun Gothic"/>
-                <a:sym typeface="Malgun Gothic"/>
-              </a:rPr>
-              <a:t>Chart.js (로컬 번들)</a:t>
-            </a:r>
-            <a:endParaRPr b="0" i="0" sz="1200" u="none" cap="none" strike="noStrike">
-              <a:solidFill>
-                <a:schemeClr val="dk1"/>
-              </a:solidFill>
-              <a:latin typeface="Calibri"/>
-              <a:ea typeface="Calibri"/>
-              <a:cs typeface="Calibri"/>
-              <a:sym typeface="Calibri"/>
-            </a:endParaRPr>
-          </a:p>
-        </p:txBody>
-      </p:sp>
-      <p:sp>
-        <p:nvSpPr>
-          <p:cNvPr id="133" name="Google Shape;133;p7"/>
-          <p:cNvSpPr/>
-          <p:nvPr/>
-        </p:nvSpPr>
-        <p:spPr>
-          <a:xfrm>
-            <a:off x="5789066" y="2048256"/>
-            <a:ext cx="2387498" cy="566928"/>
-          </a:xfrm>
-          <a:prstGeom prst="rect">
-            <a:avLst/>
-          </a:prstGeom>
-          <a:noFill/>
-          <a:ln>
-            <a:noFill/>
-          </a:ln>
-        </p:spPr>
-        <p:txBody>
-          <a:bodyPr anchorCtr="0" anchor="ctr" bIns="0" lIns="0" spcFirstLastPara="1" rIns="0" wrap="square" tIns="0">
-            <a:noAutofit/>
-          </a:bodyPr>
-          <a:lstStyle/>
-          <a:p>
-            <a:pPr indent="0" lvl="0" marL="0" marR="0" rtl="0" algn="l">
-              <a:lnSpc>
-                <a:spcPct val="140000"/>
-              </a:lnSpc>
-              <a:spcBef>
-                <a:spcPts val="0"/>
-              </a:spcBef>
-              <a:spcAft>
-                <a:spcPts val="0"/>
-              </a:spcAft>
-              <a:buClr>
-                <a:srgbClr val="65708A"/>
-              </a:buClr>
-              <a:buSzPts val="1000"/>
-              <a:buFont typeface="Malgun Gothic"/>
-              <a:buNone/>
-            </a:pPr>
-            <a:r>
-              <a:rPr b="0" i="0" lang="en-US" sz="1000" u="none" cap="none" strike="noStrike">
-                <a:solidFill>
-                  <a:srgbClr val="65708A"/>
-                </a:solidFill>
-                <a:latin typeface="Malgun Gothic"/>
-                <a:ea typeface="Malgun Gothic"/>
-                <a:cs typeface="Malgun Gothic"/>
-                <a:sym typeface="Malgun Gothic"/>
-              </a:rPr>
-              <a:t>인터넷 없이도 차트 렌더링</a:t>
-            </a:r>
-            <a:endParaRPr b="0" i="0" sz="1000" u="none" cap="none" strike="noStrike">
-              <a:solidFill>
-                <a:schemeClr val="dk1"/>
-              </a:solidFill>
-              <a:latin typeface="Calibri"/>
-              <a:ea typeface="Calibri"/>
-              <a:cs typeface="Calibri"/>
-              <a:sym typeface="Calibri"/>
-            </a:endParaRPr>
-          </a:p>
-        </p:txBody>
-      </p:sp>
-      <p:sp>
-        <p:nvSpPr>
-          <p:cNvPr id="134" name="Google Shape;134;p7"/>
-          <p:cNvSpPr/>
-          <p:nvPr/>
-        </p:nvSpPr>
-        <p:spPr>
-          <a:xfrm>
-            <a:off x="8615477" y="1609344"/>
-            <a:ext cx="2753258" cy="1097280"/>
-          </a:xfrm>
-          <a:prstGeom prst="roundRect">
-            <a:avLst>
-              <a:gd fmla="val 5833" name="adj"/>
-            </a:avLst>
-          </a:prstGeom>
-          <a:solidFill>
-            <a:srgbClr val="F5F7FB"/>
-          </a:solidFill>
-          <a:ln cap="flat" cmpd="sng" w="12700">
-            <a:solidFill>
-              <a:srgbClr val="DFE5EF"/>
-            </a:solidFill>
-            <a:prstDash val="solid"/>
-            <a:round/>
-            <a:headEnd len="sm" w="sm" type="none"/>
-            <a:tailEnd len="sm" w="sm" type="none"/>
-          </a:ln>
-        </p:spPr>
-        <p:txBody>
-          <a:bodyPr anchorCtr="0" anchor="ctr" bIns="91425" lIns="91425" spcFirstLastPara="1" rIns="91425" wrap="square" tIns="91425">
-            <a:noAutofit/>
-          </a:bodyPr>
-          <a:lstStyle/>
-          <a:p>
-            <a:pPr indent="0" lvl="0" marL="0" rtl="0" algn="l">
-              <a:spcBef>
-                <a:spcPts val="0"/>
-              </a:spcBef>
-              <a:spcAft>
-                <a:spcPts val="0"/>
-              </a:spcAft>
-              <a:buNone/>
-            </a:pPr>
-            <a:r>
-              <a:t/>
-            </a:r>
-            <a:endParaRPr/>
-          </a:p>
-        </p:txBody>
-      </p:sp>
-      <p:sp>
-        <p:nvSpPr>
-          <p:cNvPr id="135" name="Google Shape;135;p7"/>
-          <p:cNvSpPr/>
-          <p:nvPr/>
-        </p:nvSpPr>
-        <p:spPr>
-          <a:xfrm>
-            <a:off x="8798357" y="1755648"/>
-            <a:ext cx="2387498" cy="274320"/>
-          </a:xfrm>
-          <a:prstGeom prst="rect">
-            <a:avLst/>
-          </a:prstGeom>
-          <a:noFill/>
-          <a:ln>
-            <a:noFill/>
-          </a:ln>
-        </p:spPr>
-        <p:txBody>
-          <a:bodyPr anchorCtr="0" anchor="ctr" bIns="0" lIns="0" spcFirstLastPara="1" rIns="0" wrap="square" tIns="0">
-            <a:noAutofit/>
-          </a:bodyPr>
-          <a:lstStyle/>
-          <a:p>
-            <a:pPr indent="0" lvl="0" marL="0" marR="0" rtl="0" algn="l">
-              <a:spcBef>
-                <a:spcPts val="0"/>
-              </a:spcBef>
-              <a:spcAft>
-                <a:spcPts val="0"/>
-              </a:spcAft>
-              <a:buClr>
-                <a:srgbClr val="002D5A"/>
-              </a:buClr>
-              <a:buSzPts val="1200"/>
-              <a:buFont typeface="Malgun Gothic"/>
-              <a:buNone/>
-            </a:pPr>
-            <a:r>
-              <a:rPr b="1" i="0" lang="en-US" sz="1200" u="none" cap="none" strike="noStrike">
-                <a:solidFill>
-                  <a:srgbClr val="002D5A"/>
-                </a:solidFill>
-                <a:latin typeface="Malgun Gothic"/>
-                <a:ea typeface="Malgun Gothic"/>
-                <a:cs typeface="Malgun Gothic"/>
-                <a:sym typeface="Malgun Gothic"/>
-              </a:rPr>
-              <a:t>report.js / admin.js</a:t>
-            </a:r>
-            <a:endParaRPr b="0" i="0" sz="1200" u="none" cap="none" strike="noStrike">
-              <a:solidFill>
-                <a:schemeClr val="dk1"/>
-              </a:solidFill>
-              <a:latin typeface="Calibri"/>
-              <a:ea typeface="Calibri"/>
-              <a:cs typeface="Calibri"/>
-              <a:sym typeface="Calibri"/>
-            </a:endParaRPr>
-          </a:p>
-        </p:txBody>
-      </p:sp>
-      <p:sp>
-        <p:nvSpPr>
-          <p:cNvPr id="136" name="Google Shape;136;p7"/>
-          <p:cNvSpPr/>
-          <p:nvPr/>
-        </p:nvSpPr>
-        <p:spPr>
-          <a:xfrm>
-            <a:off x="8798357" y="2048256"/>
-            <a:ext cx="2387498" cy="566928"/>
-          </a:xfrm>
-          <a:prstGeom prst="rect">
-            <a:avLst/>
-          </a:prstGeom>
-          <a:noFill/>
-          <a:ln>
-            <a:noFill/>
-          </a:ln>
-        </p:spPr>
-        <p:txBody>
-          <a:bodyPr anchorCtr="0" anchor="ctr" bIns="0" lIns="0" spcFirstLastPara="1" rIns="0" wrap="square" tIns="0">
-            <a:noAutofit/>
-          </a:bodyPr>
-          <a:lstStyle/>
-          <a:p>
-            <a:pPr indent="0" lvl="0" marL="0" marR="0" rtl="0" algn="l">
-              <a:lnSpc>
-                <a:spcPct val="140000"/>
-              </a:lnSpc>
-              <a:spcBef>
-                <a:spcPts val="0"/>
-              </a:spcBef>
-              <a:spcAft>
-                <a:spcPts val="0"/>
-              </a:spcAft>
-              <a:buClr>
-                <a:srgbClr val="65708A"/>
-              </a:buClr>
-              <a:buSzPts val="1000"/>
-              <a:buFont typeface="Malgun Gothic"/>
-              <a:buNone/>
-            </a:pPr>
-            <a:r>
-              <a:rPr b="0" i="0" lang="en-US" sz="1000" u="none" cap="none" strike="noStrike">
-                <a:solidFill>
-                  <a:srgbClr val="65708A"/>
-                </a:solidFill>
-                <a:latin typeface="Malgun Gothic"/>
-                <a:ea typeface="Malgun Gothic"/>
-                <a:cs typeface="Malgun Gothic"/>
-                <a:sym typeface="Malgun Gothic"/>
-              </a:rPr>
-              <a:t>필터·정렬·스크롤·챗봇 UI</a:t>
-            </a:r>
-            <a:endParaRPr b="0" i="0" sz="1000" u="none" cap="none" strike="noStrike">
-              <a:solidFill>
-                <a:schemeClr val="dk1"/>
-              </a:solidFill>
-              <a:latin typeface="Calibri"/>
-              <a:ea typeface="Calibri"/>
-              <a:cs typeface="Calibri"/>
-              <a:sym typeface="Calibri"/>
-            </a:endParaRPr>
-          </a:p>
-        </p:txBody>
-      </p:sp>
-      <p:sp>
-        <p:nvSpPr>
-          <p:cNvPr id="137" name="Google Shape;137;p7"/>
-          <p:cNvSpPr/>
-          <p:nvPr/>
-        </p:nvSpPr>
-        <p:spPr>
-          <a:xfrm>
-            <a:off x="566928" y="3054096"/>
-            <a:ext cx="11057839" cy="1481328"/>
-          </a:xfrm>
-          <a:prstGeom prst="roundRect">
-            <a:avLst>
-              <a:gd fmla="val 4938" name="adj"/>
-            </a:avLst>
-          </a:prstGeom>
-          <a:solidFill>
-            <a:srgbClr val="FFFFFF"/>
-          </a:solidFill>
-          <a:ln cap="flat" cmpd="sng" w="12700">
-            <a:solidFill>
-              <a:srgbClr val="DFE5EF"/>
-            </a:solidFill>
-            <a:prstDash val="solid"/>
-            <a:round/>
-            <a:headEnd len="sm" w="sm" type="none"/>
-            <a:tailEnd len="sm" w="sm" type="none"/>
-          </a:ln>
-          <a:effectLst>
-            <a:outerShdw blurRad="127000" rotWithShape="0" algn="bl" dir="5400000" dist="25400">
-              <a:srgbClr val="8894A8">
-                <a:alpha val="18039"/>
-              </a:srgbClr>
-            </a:outerShdw>
-          </a:effectLst>
-        </p:spPr>
-        <p:txBody>
-          <a:bodyPr anchorCtr="0" anchor="ctr" bIns="91425" lIns="91425" spcFirstLastPara="1" rIns="91425" wrap="square" tIns="91425">
-            <a:noAutofit/>
-          </a:bodyPr>
-          <a:lstStyle/>
-          <a:p>
-            <a:pPr indent="0" lvl="0" marL="0" rtl="0" algn="l">
-              <a:spcBef>
-                <a:spcPts val="0"/>
-              </a:spcBef>
-              <a:spcAft>
-                <a:spcPts val="0"/>
-              </a:spcAft>
-              <a:buNone/>
-            </a:pPr>
-            <a:r>
-              <a:t/>
-            </a:r>
-            <a:endParaRPr/>
-          </a:p>
-        </p:txBody>
-      </p:sp>
-      <p:sp>
-        <p:nvSpPr>
-          <p:cNvPr id="138" name="Google Shape;138;p7"/>
-          <p:cNvSpPr/>
-          <p:nvPr/>
-        </p:nvSpPr>
-        <p:spPr>
-          <a:xfrm>
-            <a:off x="804672" y="3291840"/>
-            <a:ext cx="1572768" cy="420624"/>
-          </a:xfrm>
-          <a:prstGeom prst="roundRect">
-            <a:avLst>
-              <a:gd fmla="val 19565" name="adj"/>
-            </a:avLst>
-          </a:prstGeom>
-          <a:solidFill>
-            <a:srgbClr val="0098D9"/>
-          </a:solidFill>
-          <a:ln>
-            <a:noFill/>
-          </a:ln>
-        </p:spPr>
-        <p:txBody>
-          <a:bodyPr anchorCtr="0" anchor="ctr" bIns="91425" lIns="91425" spcFirstLastPara="1" rIns="91425" wrap="square" tIns="91425">
-            <a:noAutofit/>
-          </a:bodyPr>
-          <a:lstStyle/>
-          <a:p>
-            <a:pPr indent="0" lvl="0" marL="0" rtl="0" algn="l">
-              <a:spcBef>
-                <a:spcPts val="0"/>
-              </a:spcBef>
-              <a:spcAft>
-                <a:spcPts val="0"/>
-              </a:spcAft>
-              <a:buNone/>
-            </a:pPr>
-            <a:r>
-              <a:t/>
-            </a:r>
-            <a:endParaRPr/>
-          </a:p>
-        </p:txBody>
-      </p:sp>
-      <p:sp>
-        <p:nvSpPr>
-          <p:cNvPr id="139" name="Google Shape;139;p7"/>
-          <p:cNvSpPr/>
-          <p:nvPr/>
-        </p:nvSpPr>
-        <p:spPr>
-          <a:xfrm>
-            <a:off x="804672" y="3291840"/>
-            <a:ext cx="1572768" cy="420624"/>
-          </a:xfrm>
-          <a:prstGeom prst="rect">
-            <a:avLst/>
-          </a:prstGeom>
-          <a:noFill/>
-          <a:ln>
-            <a:noFill/>
-          </a:ln>
-        </p:spPr>
-        <p:txBody>
-          <a:bodyPr anchorCtr="0" anchor="ctr" bIns="0" lIns="0" spcFirstLastPara="1" rIns="0" wrap="square" tIns="0">
-            <a:noAutofit/>
-          </a:bodyPr>
-          <a:lstStyle/>
-          <a:p>
-            <a:pPr indent="0" lvl="0" marL="0" marR="0" rtl="0" algn="ctr">
-              <a:spcBef>
-                <a:spcPts val="0"/>
-              </a:spcBef>
-              <a:spcAft>
-                <a:spcPts val="0"/>
-              </a:spcAft>
-              <a:buClr>
-                <a:srgbClr val="FFFFFF"/>
-              </a:buClr>
-              <a:buSzPts val="1150"/>
-              <a:buFont typeface="Malgun Gothic"/>
-              <a:buNone/>
-            </a:pPr>
-            <a:r>
-              <a:rPr b="1" i="0" lang="en-US" sz="1150" u="none" cap="none" strike="noStrike">
-                <a:solidFill>
-                  <a:srgbClr val="FFFFFF"/>
-                </a:solidFill>
-                <a:latin typeface="Malgun Gothic"/>
-                <a:ea typeface="Malgun Gothic"/>
-                <a:cs typeface="Malgun Gothic"/>
-                <a:sym typeface="Malgun Gothic"/>
-              </a:rPr>
-              <a:t>Domain Logic</a:t>
-            </a:r>
-            <a:endParaRPr b="0" i="0" sz="1150" u="none" cap="none" strike="noStrike">
-              <a:solidFill>
-                <a:schemeClr val="dk1"/>
-              </a:solidFill>
-              <a:latin typeface="Calibri"/>
-              <a:ea typeface="Calibri"/>
-              <a:cs typeface="Calibri"/>
-              <a:sym typeface="Calibri"/>
-            </a:endParaRPr>
-          </a:p>
-        </p:txBody>
-      </p:sp>
-      <p:sp>
-        <p:nvSpPr>
-          <p:cNvPr id="140" name="Google Shape;140;p7"/>
-          <p:cNvSpPr/>
-          <p:nvPr/>
-        </p:nvSpPr>
-        <p:spPr>
-          <a:xfrm>
-            <a:off x="2596896" y="3236976"/>
-            <a:ext cx="2753258" cy="1097280"/>
-          </a:xfrm>
-          <a:prstGeom prst="roundRect">
-            <a:avLst>
-              <a:gd fmla="val 5833" name="adj"/>
-            </a:avLst>
-          </a:prstGeom>
-          <a:solidFill>
-            <a:srgbClr val="F5F7FB"/>
-          </a:solidFill>
-          <a:ln cap="flat" cmpd="sng" w="12700">
-            <a:solidFill>
-              <a:srgbClr val="DFE5EF"/>
-            </a:solidFill>
-            <a:prstDash val="solid"/>
-            <a:round/>
-            <a:headEnd len="sm" w="sm" type="none"/>
-            <a:tailEnd len="sm" w="sm" type="none"/>
-          </a:ln>
-        </p:spPr>
-        <p:txBody>
-          <a:bodyPr anchorCtr="0" anchor="ctr" bIns="91425" lIns="91425" spcFirstLastPara="1" rIns="91425" wrap="square" tIns="91425">
-            <a:noAutofit/>
-          </a:bodyPr>
-          <a:lstStyle/>
-          <a:p>
-            <a:pPr indent="0" lvl="0" marL="0" rtl="0" algn="l">
-              <a:spcBef>
-                <a:spcPts val="0"/>
-              </a:spcBef>
-              <a:spcAft>
-                <a:spcPts val="0"/>
-              </a:spcAft>
-              <a:buNone/>
-            </a:pPr>
-            <a:r>
-              <a:t/>
-            </a:r>
-            <a:endParaRPr/>
-          </a:p>
-        </p:txBody>
-      </p:sp>
-      <p:sp>
-        <p:nvSpPr>
-          <p:cNvPr id="141" name="Google Shape;141;p7"/>
-          <p:cNvSpPr/>
-          <p:nvPr/>
-        </p:nvSpPr>
-        <p:spPr>
-          <a:xfrm>
-            <a:off x="2779776" y="3383280"/>
-            <a:ext cx="2387498" cy="274320"/>
-          </a:xfrm>
-          <a:prstGeom prst="rect">
-            <a:avLst/>
-          </a:prstGeom>
-          <a:noFill/>
-          <a:ln>
-            <a:noFill/>
-          </a:ln>
-        </p:spPr>
-        <p:txBody>
-          <a:bodyPr anchorCtr="0" anchor="ctr" bIns="0" lIns="0" spcFirstLastPara="1" rIns="0" wrap="square" tIns="0">
-            <a:noAutofit/>
-          </a:bodyPr>
-          <a:lstStyle/>
-          <a:p>
-            <a:pPr indent="0" lvl="0" marL="0" marR="0" rtl="0" algn="l">
-              <a:spcBef>
-                <a:spcPts val="0"/>
-              </a:spcBef>
-              <a:spcAft>
-                <a:spcPts val="0"/>
-              </a:spcAft>
-              <a:buClr>
-                <a:srgbClr val="002D5A"/>
-              </a:buClr>
-              <a:buSzPts val="1200"/>
-              <a:buFont typeface="Malgun Gothic"/>
-              <a:buNone/>
-            </a:pPr>
-            <a:r>
-              <a:rPr b="1" i="0" lang="en-US" sz="1200" u="none" cap="none" strike="noStrike">
-                <a:solidFill>
-                  <a:srgbClr val="002D5A"/>
-                </a:solidFill>
-                <a:latin typeface="Malgun Gothic"/>
-                <a:ea typeface="Malgun Gothic"/>
-                <a:cs typeface="Malgun Gothic"/>
-                <a:sym typeface="Malgun Gothic"/>
-              </a:rPr>
-              <a:t>analytics.py</a:t>
-            </a:r>
-            <a:endParaRPr b="0" i="0" sz="1200" u="none" cap="none" strike="noStrike">
-              <a:solidFill>
-                <a:schemeClr val="dk1"/>
-              </a:solidFill>
-              <a:latin typeface="Calibri"/>
-              <a:ea typeface="Calibri"/>
-              <a:cs typeface="Calibri"/>
-              <a:sym typeface="Calibri"/>
-            </a:endParaRPr>
-          </a:p>
-        </p:txBody>
-      </p:sp>
-      <p:sp>
-        <p:nvSpPr>
-          <p:cNvPr id="142" name="Google Shape;142;p7"/>
-          <p:cNvSpPr/>
-          <p:nvPr/>
-        </p:nvSpPr>
-        <p:spPr>
-          <a:xfrm>
-            <a:off x="2779776" y="3675888"/>
-            <a:ext cx="2387498" cy="566928"/>
-          </a:xfrm>
-          <a:prstGeom prst="rect">
-            <a:avLst/>
-          </a:prstGeom>
-          <a:noFill/>
-          <a:ln>
-            <a:noFill/>
-          </a:ln>
-        </p:spPr>
-        <p:txBody>
-          <a:bodyPr anchorCtr="0" anchor="ctr" bIns="0" lIns="0" spcFirstLastPara="1" rIns="0" wrap="square" tIns="0">
-            <a:noAutofit/>
-          </a:bodyPr>
-          <a:lstStyle/>
-          <a:p>
-            <a:pPr indent="0" lvl="0" marL="0" marR="0" rtl="0" algn="l">
-              <a:lnSpc>
-                <a:spcPct val="140000"/>
-              </a:lnSpc>
-              <a:spcBef>
-                <a:spcPts val="0"/>
-              </a:spcBef>
-              <a:spcAft>
-                <a:spcPts val="0"/>
-              </a:spcAft>
-              <a:buClr>
-                <a:srgbClr val="65708A"/>
-              </a:buClr>
-              <a:buSzPts val="1000"/>
-              <a:buFont typeface="Malgun Gothic"/>
-              <a:buNone/>
-            </a:pPr>
-            <a:r>
-              <a:rPr b="0" i="0" lang="en-US" sz="1000" u="none" cap="none" strike="noStrike">
-                <a:solidFill>
-                  <a:srgbClr val="65708A"/>
-                </a:solidFill>
-                <a:latin typeface="Malgun Gothic"/>
-                <a:ea typeface="Malgun Gothic"/>
-                <a:cs typeface="Malgun Gothic"/>
-                <a:sym typeface="Malgun Gothic"/>
-              </a:rPr>
-              <a:t>SQL 집계 + 부서 내부 비교 해석</a:t>
-            </a:r>
-            <a:endParaRPr b="0" i="0" sz="1000" u="none" cap="none" strike="noStrike">
-              <a:solidFill>
-                <a:schemeClr val="dk1"/>
-              </a:solidFill>
-              <a:latin typeface="Calibri"/>
-              <a:ea typeface="Calibri"/>
-              <a:cs typeface="Calibri"/>
-              <a:sym typeface="Calibri"/>
-            </a:endParaRPr>
-          </a:p>
-        </p:txBody>
-      </p:sp>
-      <p:sp>
-        <p:nvSpPr>
-          <p:cNvPr id="143" name="Google Shape;143;p7"/>
-          <p:cNvSpPr/>
-          <p:nvPr/>
-        </p:nvSpPr>
-        <p:spPr>
-          <a:xfrm>
-            <a:off x="5606186" y="3236976"/>
-            <a:ext cx="2753258" cy="1097280"/>
-          </a:xfrm>
-          <a:prstGeom prst="roundRect">
-            <a:avLst>
-              <a:gd fmla="val 5833" name="adj"/>
-            </a:avLst>
-          </a:prstGeom>
-          <a:solidFill>
-            <a:srgbClr val="F5F7FB"/>
-          </a:solidFill>
-          <a:ln cap="flat" cmpd="sng" w="12700">
-            <a:solidFill>
-              <a:srgbClr val="DFE5EF"/>
-            </a:solidFill>
-            <a:prstDash val="solid"/>
-            <a:round/>
-            <a:headEnd len="sm" w="sm" type="none"/>
-            <a:tailEnd len="sm" w="sm" type="none"/>
-          </a:ln>
-        </p:spPr>
-        <p:txBody>
-          <a:bodyPr anchorCtr="0" anchor="ctr" bIns="91425" lIns="91425" spcFirstLastPara="1" rIns="91425" wrap="square" tIns="91425">
-            <a:noAutofit/>
-          </a:bodyPr>
-          <a:lstStyle/>
-          <a:p>
-            <a:pPr indent="0" lvl="0" marL="0" rtl="0" algn="l">
-              <a:spcBef>
-                <a:spcPts val="0"/>
-              </a:spcBef>
-              <a:spcAft>
-                <a:spcPts val="0"/>
-              </a:spcAft>
-              <a:buNone/>
-            </a:pPr>
-            <a:r>
-              <a:t/>
-            </a:r>
-            <a:endParaRPr/>
-          </a:p>
-        </p:txBody>
-      </p:sp>
-      <p:sp>
-        <p:nvSpPr>
-          <p:cNvPr id="144" name="Google Shape;144;p7"/>
-          <p:cNvSpPr/>
-          <p:nvPr/>
-        </p:nvSpPr>
-        <p:spPr>
-          <a:xfrm>
-            <a:off x="5789066" y="3383280"/>
-            <a:ext cx="2387498" cy="274320"/>
-          </a:xfrm>
-          <a:prstGeom prst="rect">
-            <a:avLst/>
-          </a:prstGeom>
-          <a:noFill/>
-          <a:ln>
-            <a:noFill/>
-          </a:ln>
-        </p:spPr>
-        <p:txBody>
-          <a:bodyPr anchorCtr="0" anchor="ctr" bIns="0" lIns="0" spcFirstLastPara="1" rIns="0" wrap="square" tIns="0">
-            <a:noAutofit/>
-          </a:bodyPr>
-          <a:lstStyle/>
-          <a:p>
-            <a:pPr indent="0" lvl="0" marL="0" marR="0" rtl="0" algn="l">
-              <a:spcBef>
-                <a:spcPts val="0"/>
-              </a:spcBef>
-              <a:spcAft>
-                <a:spcPts val="0"/>
-              </a:spcAft>
-              <a:buClr>
-                <a:srgbClr val="002D5A"/>
-              </a:buClr>
-              <a:buSzPts val="1200"/>
-              <a:buFont typeface="Malgun Gothic"/>
-              <a:buNone/>
-            </a:pPr>
-            <a:r>
-              <a:rPr b="1" i="0" lang="en-US" sz="1200" u="none" cap="none" strike="noStrike">
-                <a:solidFill>
-                  <a:srgbClr val="002D5A"/>
-                </a:solidFill>
-                <a:latin typeface="Malgun Gothic"/>
-                <a:ea typeface="Malgun Gothic"/>
-                <a:cs typeface="Malgun Gothic"/>
-                <a:sym typeface="Malgun Gothic"/>
-              </a:rPr>
-              <a:t>chat_service.py</a:t>
-            </a:r>
-            <a:endParaRPr b="0" i="0" sz="1200" u="none" cap="none" strike="noStrike">
-              <a:solidFill>
-                <a:schemeClr val="dk1"/>
-              </a:solidFill>
-              <a:latin typeface="Calibri"/>
-              <a:ea typeface="Calibri"/>
-              <a:cs typeface="Calibri"/>
-              <a:sym typeface="Calibri"/>
-            </a:endParaRPr>
-          </a:p>
-        </p:txBody>
-      </p:sp>
-      <p:sp>
-        <p:nvSpPr>
-          <p:cNvPr id="145" name="Google Shape;145;p7"/>
-          <p:cNvSpPr/>
-          <p:nvPr/>
-        </p:nvSpPr>
-        <p:spPr>
-          <a:xfrm>
-            <a:off x="5789066" y="3675888"/>
-            <a:ext cx="2387498" cy="566928"/>
-          </a:xfrm>
-          <a:prstGeom prst="rect">
-            <a:avLst/>
-          </a:prstGeom>
-          <a:noFill/>
-          <a:ln>
-            <a:noFill/>
-          </a:ln>
-        </p:spPr>
-        <p:txBody>
-          <a:bodyPr anchorCtr="0" anchor="ctr" bIns="0" lIns="0" spcFirstLastPara="1" rIns="0" wrap="square" tIns="0">
-            <a:noAutofit/>
-          </a:bodyPr>
-          <a:lstStyle/>
-          <a:p>
-            <a:pPr indent="0" lvl="0" marL="0" marR="0" rtl="0" algn="l">
-              <a:lnSpc>
-                <a:spcPct val="140000"/>
-              </a:lnSpc>
-              <a:spcBef>
-                <a:spcPts val="0"/>
-              </a:spcBef>
-              <a:spcAft>
-                <a:spcPts val="0"/>
-              </a:spcAft>
-              <a:buClr>
-                <a:srgbClr val="65708A"/>
-              </a:buClr>
-              <a:buSzPts val="1000"/>
-              <a:buFont typeface="Malgun Gothic"/>
-              <a:buNone/>
-            </a:pPr>
-            <a:r>
-              <a:rPr b="0" i="0" lang="en-US" sz="1000" u="none" cap="none" strike="noStrike">
-                <a:solidFill>
-                  <a:srgbClr val="65708A"/>
-                </a:solidFill>
-                <a:latin typeface="Malgun Gothic"/>
-                <a:ea typeface="Malgun Gothic"/>
-                <a:cs typeface="Malgun Gothic"/>
-                <a:sym typeface="Malgun Gothic"/>
-              </a:rPr>
-              <a:t>3단 라우팅 + 금지 요청 차단</a:t>
-            </a:r>
-            <a:endParaRPr b="0" i="0" sz="1000" u="none" cap="none" strike="noStrike">
-              <a:solidFill>
-                <a:schemeClr val="dk1"/>
-              </a:solidFill>
-              <a:latin typeface="Calibri"/>
-              <a:ea typeface="Calibri"/>
-              <a:cs typeface="Calibri"/>
-              <a:sym typeface="Calibri"/>
-            </a:endParaRPr>
-          </a:p>
-        </p:txBody>
-      </p:sp>
-      <p:sp>
-        <p:nvSpPr>
-          <p:cNvPr id="146" name="Google Shape;146;p7"/>
-          <p:cNvSpPr/>
-          <p:nvPr/>
-        </p:nvSpPr>
-        <p:spPr>
-          <a:xfrm>
-            <a:off x="8615477" y="3236976"/>
-            <a:ext cx="2753258" cy="1097280"/>
-          </a:xfrm>
-          <a:prstGeom prst="roundRect">
-            <a:avLst>
-              <a:gd fmla="val 5833" name="adj"/>
-            </a:avLst>
-          </a:prstGeom>
-          <a:solidFill>
-            <a:srgbClr val="F5F7FB"/>
-          </a:solidFill>
-          <a:ln cap="flat" cmpd="sng" w="12700">
-            <a:solidFill>
-              <a:srgbClr val="DFE5EF"/>
-            </a:solidFill>
-            <a:prstDash val="solid"/>
-            <a:round/>
-            <a:headEnd len="sm" w="sm" type="none"/>
-            <a:tailEnd len="sm" w="sm" type="none"/>
-          </a:ln>
-        </p:spPr>
-        <p:txBody>
-          <a:bodyPr anchorCtr="0" anchor="ctr" bIns="91425" lIns="91425" spcFirstLastPara="1" rIns="91425" wrap="square" tIns="91425">
-            <a:noAutofit/>
-          </a:bodyPr>
-          <a:lstStyle/>
-          <a:p>
-            <a:pPr indent="0" lvl="0" marL="0" rtl="0" algn="l">
-              <a:spcBef>
-                <a:spcPts val="0"/>
-              </a:spcBef>
-              <a:spcAft>
-                <a:spcPts val="0"/>
-              </a:spcAft>
-              <a:buNone/>
-            </a:pPr>
-            <a:r>
-              <a:t/>
-            </a:r>
-            <a:endParaRPr/>
-          </a:p>
-        </p:txBody>
-      </p:sp>
-      <p:sp>
-        <p:nvSpPr>
-          <p:cNvPr id="147" name="Google Shape;147;p7"/>
-          <p:cNvSpPr/>
-          <p:nvPr/>
-        </p:nvSpPr>
-        <p:spPr>
-          <a:xfrm>
-            <a:off x="8798357" y="3383280"/>
-            <a:ext cx="2387498" cy="274320"/>
-          </a:xfrm>
-          <a:prstGeom prst="rect">
-            <a:avLst/>
-          </a:prstGeom>
-          <a:noFill/>
-          <a:ln>
-            <a:noFill/>
-          </a:ln>
-        </p:spPr>
-        <p:txBody>
-          <a:bodyPr anchorCtr="0" anchor="ctr" bIns="0" lIns="0" spcFirstLastPara="1" rIns="0" wrap="square" tIns="0">
-            <a:noAutofit/>
-          </a:bodyPr>
-          <a:lstStyle/>
-          <a:p>
-            <a:pPr indent="0" lvl="0" marL="0" marR="0" rtl="0" algn="l">
-              <a:spcBef>
-                <a:spcPts val="0"/>
-              </a:spcBef>
-              <a:spcAft>
-                <a:spcPts val="0"/>
-              </a:spcAft>
-              <a:buClr>
-                <a:srgbClr val="002D5A"/>
-              </a:buClr>
-              <a:buSzPts val="1200"/>
-              <a:buFont typeface="Malgun Gothic"/>
-              <a:buNone/>
-            </a:pPr>
-            <a:r>
-              <a:rPr b="1" i="0" lang="en-US" sz="1200" u="none" cap="none" strike="noStrike">
-                <a:solidFill>
-                  <a:srgbClr val="002D5A"/>
-                </a:solidFill>
-                <a:latin typeface="Malgun Gothic"/>
-                <a:ea typeface="Malgun Gothic"/>
-                <a:cs typeface="Malgun Gothic"/>
-                <a:sym typeface="Malgun Gothic"/>
-              </a:rPr>
-              <a:t>catalog.py</a:t>
-            </a:r>
-            <a:endParaRPr b="0" i="0" sz="1200" u="none" cap="none" strike="noStrike">
-              <a:solidFill>
-                <a:schemeClr val="dk1"/>
-              </a:solidFill>
-              <a:latin typeface="Calibri"/>
-              <a:ea typeface="Calibri"/>
-              <a:cs typeface="Calibri"/>
-              <a:sym typeface="Calibri"/>
-            </a:endParaRPr>
-          </a:p>
-        </p:txBody>
-      </p:sp>
-      <p:sp>
-        <p:nvSpPr>
-          <p:cNvPr id="148" name="Google Shape;148;p7"/>
-          <p:cNvSpPr/>
-          <p:nvPr/>
-        </p:nvSpPr>
-        <p:spPr>
-          <a:xfrm>
-            <a:off x="8798357" y="3675888"/>
-            <a:ext cx="2387498" cy="566928"/>
-          </a:xfrm>
-          <a:prstGeom prst="rect">
-            <a:avLst/>
-          </a:prstGeom>
-          <a:noFill/>
-          <a:ln>
-            <a:noFill/>
-          </a:ln>
-        </p:spPr>
-        <p:txBody>
-          <a:bodyPr anchorCtr="0" anchor="ctr" bIns="0" lIns="0" spcFirstLastPara="1" rIns="0" wrap="square" tIns="0">
-            <a:noAutofit/>
-          </a:bodyPr>
-          <a:lstStyle/>
-          <a:p>
-            <a:pPr indent="0" lvl="0" marL="0" marR="0" rtl="0" algn="l">
-              <a:lnSpc>
-                <a:spcPct val="140000"/>
-              </a:lnSpc>
-              <a:spcBef>
-                <a:spcPts val="0"/>
-              </a:spcBef>
-              <a:spcAft>
-                <a:spcPts val="0"/>
-              </a:spcAft>
-              <a:buClr>
-                <a:srgbClr val="65708A"/>
-              </a:buClr>
-              <a:buSzPts val="1000"/>
-              <a:buFont typeface="Malgun Gothic"/>
-              <a:buNone/>
-            </a:pPr>
-            <a:r>
-              <a:rPr b="0" i="0" lang="en-US" sz="1000" u="none" cap="none" strike="noStrike">
-                <a:solidFill>
-                  <a:srgbClr val="65708A"/>
-                </a:solidFill>
-                <a:latin typeface="Malgun Gothic"/>
-                <a:ea typeface="Malgun Gothic"/>
-                <a:cs typeface="Malgun Gothic"/>
-                <a:sym typeface="Malgun Gothic"/>
-              </a:rPr>
-              <a:t>문항 매핑 · 해석 사전 (공용)</a:t>
-            </a:r>
-            <a:endParaRPr b="0" i="0" sz="1000" u="none" cap="none" strike="noStrike">
-              <a:solidFill>
-                <a:schemeClr val="dk1"/>
-              </a:solidFill>
-              <a:latin typeface="Calibri"/>
-              <a:ea typeface="Calibri"/>
-              <a:cs typeface="Calibri"/>
-              <a:sym typeface="Calibri"/>
-            </a:endParaRPr>
-          </a:p>
-        </p:txBody>
-      </p:sp>
-      <p:sp>
-        <p:nvSpPr>
-          <p:cNvPr id="149" name="Google Shape;149;p7"/>
-          <p:cNvSpPr/>
-          <p:nvPr/>
-        </p:nvSpPr>
-        <p:spPr>
-          <a:xfrm>
-            <a:off x="566928" y="4681728"/>
-            <a:ext cx="11057839" cy="1481328"/>
-          </a:xfrm>
-          <a:prstGeom prst="roundRect">
-            <a:avLst>
-              <a:gd fmla="val 4938" name="adj"/>
-            </a:avLst>
-          </a:prstGeom>
-          <a:solidFill>
-            <a:srgbClr val="FFFFFF"/>
-          </a:solidFill>
-          <a:ln cap="flat" cmpd="sng" w="12700">
-            <a:solidFill>
-              <a:srgbClr val="DFE5EF"/>
-            </a:solidFill>
-            <a:prstDash val="solid"/>
-            <a:round/>
-            <a:headEnd len="sm" w="sm" type="none"/>
-            <a:tailEnd len="sm" w="sm" type="none"/>
-          </a:ln>
-          <a:effectLst>
-            <a:outerShdw blurRad="127000" rotWithShape="0" algn="bl" dir="5400000" dist="25400">
-              <a:srgbClr val="8894A8">
-                <a:alpha val="18039"/>
-              </a:srgbClr>
-            </a:outerShdw>
-          </a:effectLst>
-        </p:spPr>
-        <p:txBody>
-          <a:bodyPr anchorCtr="0" anchor="ctr" bIns="91425" lIns="91425" spcFirstLastPara="1" rIns="91425" wrap="square" tIns="91425">
-            <a:noAutofit/>
-          </a:bodyPr>
-          <a:lstStyle/>
-          <a:p>
-            <a:pPr indent="0" lvl="0" marL="0" rtl="0" algn="l">
-              <a:spcBef>
-                <a:spcPts val="0"/>
-              </a:spcBef>
-              <a:spcAft>
-                <a:spcPts val="0"/>
-              </a:spcAft>
-              <a:buNone/>
-            </a:pPr>
-            <a:r>
-              <a:t/>
-            </a:r>
-            <a:endParaRPr/>
-          </a:p>
-        </p:txBody>
-      </p:sp>
-      <p:sp>
-        <p:nvSpPr>
-          <p:cNvPr id="150" name="Google Shape;150;p7"/>
-          <p:cNvSpPr/>
-          <p:nvPr/>
-        </p:nvSpPr>
-        <p:spPr>
-          <a:xfrm>
-            <a:off x="804672" y="4919472"/>
-            <a:ext cx="1572768" cy="420624"/>
-          </a:xfrm>
-          <a:prstGeom prst="roundRect">
-            <a:avLst>
-              <a:gd fmla="val 19565" name="adj"/>
-            </a:avLst>
-          </a:prstGeom>
-          <a:solidFill>
-            <a:srgbClr val="00A950"/>
-          </a:solidFill>
-          <a:ln>
-            <a:noFill/>
-          </a:ln>
-        </p:spPr>
-        <p:txBody>
-          <a:bodyPr anchorCtr="0" anchor="ctr" bIns="91425" lIns="91425" spcFirstLastPara="1" rIns="91425" wrap="square" tIns="91425">
-            <a:noAutofit/>
-          </a:bodyPr>
-          <a:lstStyle/>
-          <a:p>
-            <a:pPr indent="0" lvl="0" marL="0" rtl="0" algn="l">
-              <a:spcBef>
-                <a:spcPts val="0"/>
-              </a:spcBef>
-              <a:spcAft>
-                <a:spcPts val="0"/>
-              </a:spcAft>
-              <a:buNone/>
-            </a:pPr>
-            <a:r>
-              <a:t/>
-            </a:r>
-            <a:endParaRPr/>
-          </a:p>
-        </p:txBody>
-      </p:sp>
-      <p:sp>
-        <p:nvSpPr>
-          <p:cNvPr id="151" name="Google Shape;151;p7"/>
-          <p:cNvSpPr/>
-          <p:nvPr/>
-        </p:nvSpPr>
-        <p:spPr>
-          <a:xfrm>
-            <a:off x="804672" y="4919472"/>
-            <a:ext cx="1572768" cy="420624"/>
-          </a:xfrm>
-          <a:prstGeom prst="rect">
-            <a:avLst/>
-          </a:prstGeom>
-          <a:noFill/>
-          <a:ln>
-            <a:noFill/>
-          </a:ln>
-        </p:spPr>
-        <p:txBody>
-          <a:bodyPr anchorCtr="0" anchor="ctr" bIns="0" lIns="0" spcFirstLastPara="1" rIns="0" wrap="square" tIns="0">
-            <a:noAutofit/>
-          </a:bodyPr>
-          <a:lstStyle/>
-          <a:p>
-            <a:pPr indent="0" lvl="0" marL="0" marR="0" rtl="0" algn="ctr">
-              <a:spcBef>
-                <a:spcPts val="0"/>
-              </a:spcBef>
-              <a:spcAft>
-                <a:spcPts val="0"/>
-              </a:spcAft>
-              <a:buClr>
-                <a:srgbClr val="FFFFFF"/>
-              </a:buClr>
-              <a:buSzPts val="1150"/>
-              <a:buFont typeface="Malgun Gothic"/>
-              <a:buNone/>
-            </a:pPr>
-            <a:r>
-              <a:rPr b="1" i="0" lang="en-US" sz="1150" u="none" cap="none" strike="noStrike">
-                <a:solidFill>
-                  <a:srgbClr val="FFFFFF"/>
-                </a:solidFill>
-                <a:latin typeface="Malgun Gothic"/>
-                <a:ea typeface="Malgun Gothic"/>
-                <a:cs typeface="Malgun Gothic"/>
-                <a:sym typeface="Malgun Gothic"/>
-              </a:rPr>
-              <a:t>Data &amp; External</a:t>
-            </a:r>
-            <a:endParaRPr b="0" i="0" sz="1150" u="none" cap="none" strike="noStrike">
-              <a:solidFill>
-                <a:schemeClr val="dk1"/>
-              </a:solidFill>
-              <a:latin typeface="Calibri"/>
-              <a:ea typeface="Calibri"/>
-              <a:cs typeface="Calibri"/>
-              <a:sym typeface="Calibri"/>
-            </a:endParaRPr>
-          </a:p>
-        </p:txBody>
-      </p:sp>
-      <p:sp>
-        <p:nvSpPr>
-          <p:cNvPr id="152" name="Google Shape;152;p7"/>
-          <p:cNvSpPr/>
-          <p:nvPr/>
-        </p:nvSpPr>
-        <p:spPr>
-          <a:xfrm>
-            <a:off x="2596896" y="4864608"/>
-            <a:ext cx="2753258" cy="1097280"/>
-          </a:xfrm>
-          <a:prstGeom prst="roundRect">
-            <a:avLst>
-              <a:gd fmla="val 5833" name="adj"/>
-            </a:avLst>
-          </a:prstGeom>
-          <a:solidFill>
-            <a:srgbClr val="F5F7FB"/>
-          </a:solidFill>
-          <a:ln cap="flat" cmpd="sng" w="12700">
-            <a:solidFill>
-              <a:srgbClr val="DFE5EF"/>
-            </a:solidFill>
-            <a:prstDash val="solid"/>
-            <a:round/>
-            <a:headEnd len="sm" w="sm" type="none"/>
-            <a:tailEnd len="sm" w="sm" type="none"/>
-          </a:ln>
-        </p:spPr>
-        <p:txBody>
-          <a:bodyPr anchorCtr="0" anchor="ctr" bIns="91425" lIns="91425" spcFirstLastPara="1" rIns="91425" wrap="square" tIns="91425">
-            <a:noAutofit/>
-          </a:bodyPr>
-          <a:lstStyle/>
-          <a:p>
-            <a:pPr indent="0" lvl="0" marL="0" rtl="0" algn="l">
-              <a:spcBef>
-                <a:spcPts val="0"/>
-              </a:spcBef>
-              <a:spcAft>
-                <a:spcPts val="0"/>
-              </a:spcAft>
-              <a:buNone/>
-            </a:pPr>
-            <a:r>
-              <a:t/>
-            </a:r>
-            <a:endParaRPr/>
-          </a:p>
-        </p:txBody>
-      </p:sp>
-      <p:sp>
-        <p:nvSpPr>
-          <p:cNvPr id="153" name="Google Shape;153;p7"/>
-          <p:cNvSpPr/>
-          <p:nvPr/>
-        </p:nvSpPr>
-        <p:spPr>
-          <a:xfrm>
-            <a:off x="2779776" y="5010912"/>
-            <a:ext cx="2387498" cy="274320"/>
-          </a:xfrm>
-          <a:prstGeom prst="rect">
-            <a:avLst/>
-          </a:prstGeom>
-          <a:noFill/>
-          <a:ln>
-            <a:noFill/>
-          </a:ln>
-        </p:spPr>
-        <p:txBody>
-          <a:bodyPr anchorCtr="0" anchor="ctr" bIns="0" lIns="0" spcFirstLastPara="1" rIns="0" wrap="square" tIns="0">
-            <a:noAutofit/>
-          </a:bodyPr>
-          <a:lstStyle/>
-          <a:p>
-            <a:pPr indent="0" lvl="0" marL="0" marR="0" rtl="0" algn="l">
-              <a:spcBef>
-                <a:spcPts val="0"/>
-              </a:spcBef>
-              <a:spcAft>
-                <a:spcPts val="0"/>
-              </a:spcAft>
-              <a:buClr>
-                <a:srgbClr val="002D5A"/>
-              </a:buClr>
-              <a:buSzPts val="1200"/>
-              <a:buFont typeface="Malgun Gothic"/>
-              <a:buNone/>
-            </a:pPr>
-            <a:r>
-              <a:rPr b="1" i="0" lang="en-US" sz="1200" u="none" cap="none" strike="noStrike">
-                <a:solidFill>
-                  <a:srgbClr val="002D5A"/>
-                </a:solidFill>
-                <a:latin typeface="Malgun Gothic"/>
-                <a:ea typeface="Malgun Gothic"/>
-                <a:cs typeface="Malgun Gothic"/>
-                <a:sym typeface="Malgun Gothic"/>
-              </a:rPr>
-              <a:t>SQLite 5 tables</a:t>
-            </a:r>
-            <a:endParaRPr b="0" i="0" sz="1200" u="none" cap="none" strike="noStrike">
-              <a:solidFill>
-                <a:schemeClr val="dk1"/>
-              </a:solidFill>
-              <a:latin typeface="Calibri"/>
-              <a:ea typeface="Calibri"/>
-              <a:cs typeface="Calibri"/>
-              <a:sym typeface="Calibri"/>
-            </a:endParaRPr>
-          </a:p>
-        </p:txBody>
-      </p:sp>
-      <p:sp>
-        <p:nvSpPr>
-          <p:cNvPr id="154" name="Google Shape;154;p7"/>
-          <p:cNvSpPr/>
-          <p:nvPr/>
-        </p:nvSpPr>
-        <p:spPr>
-          <a:xfrm>
-            <a:off x="2779776" y="5303520"/>
-            <a:ext cx="2387498" cy="566928"/>
-          </a:xfrm>
-          <a:prstGeom prst="rect">
-            <a:avLst/>
-          </a:prstGeom>
-          <a:noFill/>
-          <a:ln>
-            <a:noFill/>
-          </a:ln>
-        </p:spPr>
-        <p:txBody>
-          <a:bodyPr anchorCtr="0" anchor="ctr" bIns="0" lIns="0" spcFirstLastPara="1" rIns="0" wrap="square" tIns="0">
-            <a:noAutofit/>
-          </a:bodyPr>
-          <a:lstStyle/>
-          <a:p>
-            <a:pPr indent="0" lvl="0" marL="0" marR="0" rtl="0" algn="l">
-              <a:lnSpc>
-                <a:spcPct val="140000"/>
-              </a:lnSpc>
-              <a:spcBef>
-                <a:spcPts val="0"/>
-              </a:spcBef>
-              <a:spcAft>
-                <a:spcPts val="0"/>
-              </a:spcAft>
-              <a:buClr>
-                <a:srgbClr val="65708A"/>
-              </a:buClr>
-              <a:buSzPts val="1000"/>
-              <a:buFont typeface="Malgun Gothic"/>
-              <a:buNone/>
-            </a:pPr>
-            <a:r>
-              <a:rPr b="0" i="0" lang="en-US" sz="1000" u="none" cap="none" strike="noStrike">
-                <a:solidFill>
-                  <a:srgbClr val="65708A"/>
-                </a:solidFill>
-                <a:latin typeface="Malgun Gothic"/>
-                <a:ea typeface="Malgun Gothic"/>
-                <a:cs typeface="Malgun Gothic"/>
-                <a:sym typeface="Malgun Gothic"/>
-              </a:rPr>
-              <a:t>responses · open_texts · orgs · admins · logs</a:t>
-            </a:r>
-            <a:endParaRPr b="0" i="0" sz="1000" u="none" cap="none" strike="noStrike">
-              <a:solidFill>
-                <a:schemeClr val="dk1"/>
-              </a:solidFill>
-              <a:latin typeface="Calibri"/>
-              <a:ea typeface="Calibri"/>
-              <a:cs typeface="Calibri"/>
-              <a:sym typeface="Calibri"/>
-            </a:endParaRPr>
-          </a:p>
-        </p:txBody>
-      </p:sp>
-      <p:sp>
-        <p:nvSpPr>
-          <p:cNvPr id="155" name="Google Shape;155;p7"/>
-          <p:cNvSpPr/>
-          <p:nvPr/>
-        </p:nvSpPr>
-        <p:spPr>
-          <a:xfrm>
-            <a:off x="5606186" y="4864608"/>
-            <a:ext cx="2753258" cy="1097280"/>
-          </a:xfrm>
-          <a:prstGeom prst="roundRect">
-            <a:avLst>
-              <a:gd fmla="val 5833" name="adj"/>
-            </a:avLst>
-          </a:prstGeom>
-          <a:solidFill>
-            <a:srgbClr val="F5F7FB"/>
-          </a:solidFill>
-          <a:ln cap="flat" cmpd="sng" w="12700">
-            <a:solidFill>
-              <a:srgbClr val="DFE5EF"/>
-            </a:solidFill>
-            <a:prstDash val="solid"/>
-            <a:round/>
-            <a:headEnd len="sm" w="sm" type="none"/>
-            <a:tailEnd len="sm" w="sm" type="none"/>
-          </a:ln>
-        </p:spPr>
-        <p:txBody>
-          <a:bodyPr anchorCtr="0" anchor="ctr" bIns="91425" lIns="91425" spcFirstLastPara="1" rIns="91425" wrap="square" tIns="91425">
-            <a:noAutofit/>
-          </a:bodyPr>
-          <a:lstStyle/>
-          <a:p>
-            <a:pPr indent="0" lvl="0" marL="0" rtl="0" algn="l">
-              <a:spcBef>
-                <a:spcPts val="0"/>
-              </a:spcBef>
-              <a:spcAft>
-                <a:spcPts val="0"/>
-              </a:spcAft>
-              <a:buNone/>
-            </a:pPr>
-            <a:r>
-              <a:t/>
-            </a:r>
-            <a:endParaRPr/>
-          </a:p>
-        </p:txBody>
-      </p:sp>
-      <p:sp>
-        <p:nvSpPr>
-          <p:cNvPr id="156" name="Google Shape;156;p7"/>
-          <p:cNvSpPr/>
-          <p:nvPr/>
-        </p:nvSpPr>
-        <p:spPr>
-          <a:xfrm>
-            <a:off x="5789066" y="5010912"/>
-            <a:ext cx="2387498" cy="274320"/>
-          </a:xfrm>
-          <a:prstGeom prst="rect">
-            <a:avLst/>
-          </a:prstGeom>
-          <a:noFill/>
-          <a:ln>
-            <a:noFill/>
-          </a:ln>
-        </p:spPr>
-        <p:txBody>
-          <a:bodyPr anchorCtr="0" anchor="ctr" bIns="0" lIns="0" spcFirstLastPara="1" rIns="0" wrap="square" tIns="0">
-            <a:noAutofit/>
-          </a:bodyPr>
-          <a:lstStyle/>
-          <a:p>
-            <a:pPr indent="0" lvl="0" marL="0" marR="0" rtl="0" algn="l">
-              <a:spcBef>
-                <a:spcPts val="0"/>
-              </a:spcBef>
-              <a:spcAft>
-                <a:spcPts val="0"/>
-              </a:spcAft>
-              <a:buClr>
-                <a:srgbClr val="002D5A"/>
-              </a:buClr>
-              <a:buSzPts val="1200"/>
-              <a:buFont typeface="Malgun Gothic"/>
-              <a:buNone/>
-            </a:pPr>
-            <a:r>
-              <a:rPr b="1" i="0" lang="en-US" sz="1200" u="none" cap="none" strike="noStrike">
-                <a:solidFill>
-                  <a:srgbClr val="002D5A"/>
-                </a:solidFill>
-                <a:latin typeface="Malgun Gothic"/>
-                <a:ea typeface="Malgun Gothic"/>
-                <a:cs typeface="Malgun Gothic"/>
-                <a:sym typeface="Malgun Gothic"/>
-              </a:rPr>
-              <a:t>seed.py</a:t>
-            </a:r>
-            <a:endParaRPr b="0" i="0" sz="1200" u="none" cap="none" strike="noStrike">
-              <a:solidFill>
-                <a:schemeClr val="dk1"/>
-              </a:solidFill>
-              <a:latin typeface="Calibri"/>
-              <a:ea typeface="Calibri"/>
-              <a:cs typeface="Calibri"/>
-              <a:sym typeface="Calibri"/>
-            </a:endParaRPr>
-          </a:p>
-        </p:txBody>
-      </p:sp>
-      <p:sp>
-        <p:nvSpPr>
-          <p:cNvPr id="157" name="Google Shape;157;p7"/>
-          <p:cNvSpPr/>
-          <p:nvPr/>
-        </p:nvSpPr>
-        <p:spPr>
-          <a:xfrm>
-            <a:off x="5789066" y="5303520"/>
-            <a:ext cx="2387498" cy="566928"/>
-          </a:xfrm>
-          <a:prstGeom prst="rect">
-            <a:avLst/>
-          </a:prstGeom>
-          <a:noFill/>
-          <a:ln>
-            <a:noFill/>
-          </a:ln>
-        </p:spPr>
-        <p:txBody>
-          <a:bodyPr anchorCtr="0" anchor="ctr" bIns="0" lIns="0" spcFirstLastPara="1" rIns="0" wrap="square" tIns="0">
-            <a:noAutofit/>
-          </a:bodyPr>
-          <a:lstStyle/>
-          <a:p>
-            <a:pPr indent="0" lvl="0" marL="0" marR="0" rtl="0" algn="l">
-              <a:lnSpc>
-                <a:spcPct val="140000"/>
-              </a:lnSpc>
-              <a:spcBef>
-                <a:spcPts val="0"/>
-              </a:spcBef>
-              <a:spcAft>
-                <a:spcPts val="0"/>
-              </a:spcAft>
-              <a:buClr>
-                <a:srgbClr val="65708A"/>
-              </a:buClr>
-              <a:buSzPts val="1000"/>
-              <a:buFont typeface="Malgun Gothic"/>
-              <a:buNone/>
-            </a:pPr>
-            <a:r>
-              <a:rPr b="0" i="0" lang="en-US" sz="1000" u="none" cap="none" strike="noStrike">
-                <a:solidFill>
-                  <a:srgbClr val="65708A"/>
-                </a:solidFill>
-                <a:latin typeface="Malgun Gothic"/>
-                <a:ea typeface="Malgun Gothic"/>
-                <a:cs typeface="Malgun Gothic"/>
-                <a:sym typeface="Malgun Gothic"/>
-              </a:rPr>
-              <a:t>엑셀 → DB 적재 (업로드 시 재사용)</a:t>
-            </a:r>
-            <a:endParaRPr b="0" i="0" sz="1000" u="none" cap="none" strike="noStrike">
-              <a:solidFill>
-                <a:schemeClr val="dk1"/>
-              </a:solidFill>
-              <a:latin typeface="Calibri"/>
-              <a:ea typeface="Calibri"/>
-              <a:cs typeface="Calibri"/>
-              <a:sym typeface="Calibri"/>
-            </a:endParaRPr>
-          </a:p>
-        </p:txBody>
-      </p:sp>
-      <p:sp>
-        <p:nvSpPr>
-          <p:cNvPr id="158" name="Google Shape;158;p7"/>
-          <p:cNvSpPr/>
-          <p:nvPr/>
-        </p:nvSpPr>
-        <p:spPr>
-          <a:xfrm>
-            <a:off x="8615477" y="4864608"/>
-            <a:ext cx="2753258" cy="1097280"/>
-          </a:xfrm>
-          <a:prstGeom prst="roundRect">
-            <a:avLst>
-              <a:gd fmla="val 5833" name="adj"/>
-            </a:avLst>
-          </a:prstGeom>
-          <a:solidFill>
-            <a:srgbClr val="F5F7FB"/>
-          </a:solidFill>
-          <a:ln cap="flat" cmpd="sng" w="12700">
-            <a:solidFill>
-              <a:srgbClr val="DFE5EF"/>
-            </a:solidFill>
-            <a:prstDash val="solid"/>
-            <a:round/>
-            <a:headEnd len="sm" w="sm" type="none"/>
-            <a:tailEnd len="sm" w="sm" type="none"/>
-          </a:ln>
-        </p:spPr>
-        <p:txBody>
-          <a:bodyPr anchorCtr="0" anchor="ctr" bIns="91425" lIns="91425" spcFirstLastPara="1" rIns="91425" wrap="square" tIns="91425">
-            <a:noAutofit/>
-          </a:bodyPr>
-          <a:lstStyle/>
-          <a:p>
-            <a:pPr indent="0" lvl="0" marL="0" rtl="0" algn="l">
-              <a:spcBef>
-                <a:spcPts val="0"/>
-              </a:spcBef>
-              <a:spcAft>
-                <a:spcPts val="0"/>
-              </a:spcAft>
-              <a:buNone/>
-            </a:pPr>
-            <a:r>
-              <a:t/>
-            </a:r>
-            <a:endParaRPr/>
-          </a:p>
-        </p:txBody>
-      </p:sp>
-      <p:sp>
-        <p:nvSpPr>
-          <p:cNvPr id="159" name="Google Shape;159;p7"/>
-          <p:cNvSpPr/>
-          <p:nvPr/>
-        </p:nvSpPr>
-        <p:spPr>
-          <a:xfrm>
-            <a:off x="8798357" y="5010912"/>
-            <a:ext cx="2387498" cy="274320"/>
-          </a:xfrm>
-          <a:prstGeom prst="rect">
-            <a:avLst/>
-          </a:prstGeom>
-          <a:noFill/>
-          <a:ln>
-            <a:noFill/>
-          </a:ln>
-        </p:spPr>
-        <p:txBody>
-          <a:bodyPr anchorCtr="0" anchor="ctr" bIns="0" lIns="0" spcFirstLastPara="1" rIns="0" wrap="square" tIns="0">
-            <a:noAutofit/>
-          </a:bodyPr>
-          <a:lstStyle/>
-          <a:p>
-            <a:pPr indent="0" lvl="0" marL="0" marR="0" rtl="0" algn="l">
-              <a:spcBef>
-                <a:spcPts val="0"/>
-              </a:spcBef>
-              <a:spcAft>
-                <a:spcPts val="0"/>
-              </a:spcAft>
-              <a:buClr>
-                <a:srgbClr val="002D5A"/>
-              </a:buClr>
-              <a:buSzPts val="1200"/>
-              <a:buFont typeface="Malgun Gothic"/>
-              <a:buNone/>
-            </a:pPr>
-            <a:r>
-              <a:rPr b="1" i="0" lang="en-US" sz="1200" u="none" cap="none" strike="noStrike">
-                <a:solidFill>
-                  <a:srgbClr val="002D5A"/>
-                </a:solidFill>
-                <a:latin typeface="Malgun Gothic"/>
-                <a:ea typeface="Malgun Gothic"/>
-                <a:cs typeface="Malgun Gothic"/>
-                <a:sym typeface="Malgun Gothic"/>
-              </a:rPr>
-              <a:t>OpenAI · Tavily</a:t>
-            </a:r>
-            <a:endParaRPr b="0" i="0" sz="1200" u="none" cap="none" strike="noStrike">
-              <a:solidFill>
-                <a:schemeClr val="dk1"/>
-              </a:solidFill>
-              <a:latin typeface="Calibri"/>
-              <a:ea typeface="Calibri"/>
-              <a:cs typeface="Calibri"/>
-              <a:sym typeface="Calibri"/>
-            </a:endParaRPr>
-          </a:p>
-        </p:txBody>
-      </p:sp>
-      <p:sp>
-        <p:nvSpPr>
-          <p:cNvPr id="160" name="Google Shape;160;p7"/>
-          <p:cNvSpPr/>
-          <p:nvPr/>
-        </p:nvSpPr>
-        <p:spPr>
-          <a:xfrm>
-            <a:off x="8798357" y="5303520"/>
-            <a:ext cx="2387498" cy="566928"/>
-          </a:xfrm>
-          <a:prstGeom prst="rect">
-            <a:avLst/>
-          </a:prstGeom>
-          <a:noFill/>
-          <a:ln>
-            <a:noFill/>
-          </a:ln>
-        </p:spPr>
-        <p:txBody>
-          <a:bodyPr anchorCtr="0" anchor="ctr" bIns="0" lIns="0" spcFirstLastPara="1" rIns="0" wrap="square" tIns="0">
-            <a:noAutofit/>
-          </a:bodyPr>
-          <a:lstStyle/>
-          <a:p>
-            <a:pPr indent="0" lvl="0" marL="0" marR="0" rtl="0" algn="l">
-              <a:lnSpc>
-                <a:spcPct val="140000"/>
-              </a:lnSpc>
-              <a:spcBef>
-                <a:spcPts val="0"/>
-              </a:spcBef>
-              <a:spcAft>
-                <a:spcPts val="0"/>
-              </a:spcAft>
-              <a:buClr>
-                <a:srgbClr val="65708A"/>
-              </a:buClr>
-              <a:buSzPts val="1000"/>
-              <a:buFont typeface="Malgun Gothic"/>
-              <a:buNone/>
-            </a:pPr>
-            <a:r>
-              <a:rPr b="0" i="0" lang="en-US" sz="1000" u="none" cap="none" strike="noStrike">
-                <a:solidFill>
-                  <a:srgbClr val="65708A"/>
-                </a:solidFill>
-                <a:latin typeface="Malgun Gothic"/>
-                <a:ea typeface="Malgun Gothic"/>
-                <a:cs typeface="Malgun Gothic"/>
-                <a:sym typeface="Malgun Gothic"/>
-              </a:rPr>
-              <a:t>근거 기반 답변 · 웹검색 · 대화 요약</a:t>
-            </a:r>
-            <a:endParaRPr b="0" i="0" sz="1000" u="none" cap="none" strike="noStrike">
-              <a:solidFill>
-                <a:schemeClr val="dk1"/>
-              </a:solidFill>
-              <a:latin typeface="Calibri"/>
-              <a:ea typeface="Calibri"/>
-              <a:cs typeface="Calibri"/>
-              <a:sym typeface="Calibri"/>
-            </a:endParaRPr>
-          </a:p>
-        </p:txBody>
-      </p:sp>
-    </p:spTree>
-  </p:cSld>
-  <p:clrMapOvr>
-    <a:masterClrMapping/>
-  </p:clrMapOvr>
-</p:sld>
-</file>
-
 <file path=ppt/slides/slide6.xml><?xml version="1.0" encoding="utf-8"?>
 <p:sld xmlns:a="http://schemas.openxmlformats.org/drawingml/2006/main" xmlns:r="http://schemas.openxmlformats.org/officeDocument/2006/relationships" xmlns:mc="http://schemas.openxmlformats.org/markup-compatibility/2006" xmlns:mv="urn:schemas-microsoft-com:mac:vml" xmlns:p="http://schemas.openxmlformats.org/presentationml/2006/main" xmlns:c="http://schemas.openxmlformats.org/drawingml/2006/chart" xmlns:dgm="http://schemas.openxmlformats.org/drawingml/2006/diagram" xmlns:o="urn:schemas-microsoft-com:office:office" xmlns:v="urn:schemas-microsoft-com:vml" xmlns:pvml="urn:schemas-microsoft-com:office:powerpoint" xmlns:com="http://schemas.openxmlformats.org/drawingml/2006/compatibility" xmlns:p14="http://schemas.microsoft.com/office/powerpoint/2010/main" xmlns:p15="http://schemas.microsoft.com/office/powerpoint/2012/main" xmlns:ahyp="http://schemas.microsoft.com/office/drawing/2018/hyperlinkcolor">
   <p:cSld>
@@ -19014,7 +15174,7 @@
                 <a:cs typeface="Malgun Gothic"/>
                 <a:sym typeface="Malgun Gothic"/>
               </a:rPr>
-              <a:t>5</a:t>
+              <a:t>4</a:t>
             </a:r>
             <a:endParaRPr b="0" i="0" sz="1000" u="none" cap="none" strike="noStrike">
               <a:solidFill>
@@ -20653,7 +16813,7 @@
                 <a:cs typeface="Malgun Gothic"/>
                 <a:sym typeface="Malgun Gothic"/>
               </a:rPr>
-              <a:t>6</a:t>
+              <a:t>5</a:t>
             </a:r>
             <a:endParaRPr b="0" i="0" sz="1000" u="none" cap="none" strike="noStrike">
               <a:solidFill>
@@ -22297,7 +18457,7 @@
                 <a:cs typeface="Malgun Gothic"/>
                 <a:sym typeface="Malgun Gothic"/>
               </a:rPr>
-              <a:t>7</a:t>
+              <a:t>6</a:t>
             </a:r>
             <a:endParaRPr b="0" i="0" sz="1000" u="none" cap="none" strike="noStrike">
               <a:solidFill>

</xml_diff>

<commit_message>
docs: re-embed Pretendard and restore it on the cover and closing
PowerPoint had dropped the embedded font on save, and retyping the cover
and closing slide had moved those runs to Arial (no Hangul glyphs). Six
runs return to Pretendard and the regular/bold faces are embedded again;
the other 224 Korean runs stay on Malgun Gothic. No text or layout change.

Co-Authored-By: Claude Opus 5 <noreply@anthropic.com>
</commit_message>
<xml_diff>
--- a/Org_health_diag/docs/2026_조직건강도_AI_Agent_수행결과.pptx
+++ b/Org_health_diag/docs/2026_조직건강도_AI_Agent_수행결과.pptx
@@ -1,6 +1,6 @@
 
 <file path=ppt/presentation.xml><?xml version="1.0" encoding="utf-8"?>
-<p:presentation xmlns:a="http://schemas.openxmlformats.org/drawingml/2006/main" xmlns:r="http://schemas.openxmlformats.org/officeDocument/2006/relationships" xmlns:mc="http://schemas.openxmlformats.org/markup-compatibility/2006" xmlns:mv="urn:schemas-microsoft-com:mac:vml" xmlns:p="http://schemas.openxmlformats.org/presentationml/2006/main" xmlns:c="http://schemas.openxmlformats.org/drawingml/2006/chart" xmlns:dgm="http://schemas.openxmlformats.org/drawingml/2006/diagram" xmlns:o="urn:schemas-microsoft-com:office:office" xmlns:v="urn:schemas-microsoft-com:vml" xmlns:pvml="urn:schemas-microsoft-com:office:powerpoint" xmlns:com="http://schemas.openxmlformats.org/drawingml/2006/compatibility" xmlns:p14="http://schemas.microsoft.com/office/powerpoint/2010/main" xmlns:p15="http://schemas.microsoft.com/office/powerpoint/2012/main" xmlns:ahyp="http://schemas.microsoft.com/office/drawing/2018/hyperlinkcolor" autoCompressPictures="0" strictFirstAndLastChars="0" saveSubsetFonts="1">
+<p:presentation xmlns:a="http://schemas.openxmlformats.org/drawingml/2006/main" xmlns:r="http://schemas.openxmlformats.org/officeDocument/2006/relationships" xmlns:mc="http://schemas.openxmlformats.org/markup-compatibility/2006" xmlns:mv="urn:schemas-microsoft-com:mac:vml" xmlns:p="http://schemas.openxmlformats.org/presentationml/2006/main" xmlns:c="http://schemas.openxmlformats.org/drawingml/2006/chart" xmlns:dgm="http://schemas.openxmlformats.org/drawingml/2006/diagram" xmlns:o="urn:schemas-microsoft-com:office:office" xmlns:v="urn:schemas-microsoft-com:vml" xmlns:pvml="urn:schemas-microsoft-com:office:powerpoint" xmlns:com="http://schemas.openxmlformats.org/drawingml/2006/compatibility" xmlns:p14="http://schemas.microsoft.com/office/powerpoint/2010/main" xmlns:p15="http://schemas.microsoft.com/office/powerpoint/2012/main" xmlns:ahyp="http://schemas.microsoft.com/office/drawing/2018/hyperlinkcolor" autoCompressPictures="0" strictFirstAndLastChars="0" saveSubsetFonts="1" embedTrueTypeFonts="1">
   <p:sldMasterIdLst>
     <p:sldMasterId id="2147483648" r:id="rId3"/>
     <p:sldMasterId id="2147483650" r:id="rId4"/>
@@ -23,6 +23,13 @@
   </p:sldIdLst>
   <p:sldSz cy="6858000" cx="12192000"/>
   <p:notesSz cx="6858000" cy="12192000"/>
+  <p:embeddedFontLst>
+    <p:embeddedFont>
+      <p:font typeface="Pretendard" panose="02000503000000020004" pitchFamily="2" charset="-127"/>
+      <p:regular r:id="rId18"/>
+      <p:bold r:id="rId19"/>
+    </p:embeddedFont>
+  </p:embeddedFontLst>
   <p:defaultTextStyle>
     <a:defPPr lvl="0" marR="0" rtl="0" algn="l">
       <a:lnSpc>
@@ -11301,15 +11308,19 @@
                 <a:solidFill>
                   <a:srgbClr val="000000"/>
                 </a:solidFill>
-                <a:latin typeface="Arial"/>
-                <a:ea typeface="Arial"/>
-                <a:cs typeface="Arial"/>
                 <a:sym typeface="Arial"/>
+                <a:latin typeface="Pretendard" panose="02000503000000020004" pitchFamily="2" charset="-127"/>
+                <a:ea typeface="Pretendard" panose="02000503000000020004" pitchFamily="2" charset="-127"/>
+                <a:cs typeface="Pretendard" panose="02000503000000020004" pitchFamily="2" charset="-127"/>
               </a:rPr>
               <a:t>조직건강도 </a:t>
             </a:r>
             <a:r>
-              <a:rPr b="1" lang="en-US" sz="4400"/>
+              <a:rPr b="1" lang="en-US" sz="4400">
+                <a:latin typeface="Pretendard" panose="02000503000000020004" pitchFamily="2" charset="-127"/>
+                <a:ea typeface="Pretendard" panose="02000503000000020004" pitchFamily="2" charset="-127"/>
+                <a:cs typeface="Pretendard" panose="02000503000000020004" pitchFamily="2" charset="-127"/>
+              </a:rPr>
               <a:t>진단 </a:t>
             </a:r>
             <a:r>
@@ -11317,10 +11328,10 @@
                 <a:solidFill>
                   <a:srgbClr val="000000"/>
                 </a:solidFill>
-                <a:latin typeface="Arial"/>
-                <a:ea typeface="Arial"/>
-                <a:cs typeface="Arial"/>
                 <a:sym typeface="Arial"/>
+                <a:latin typeface="Pretendard" panose="02000503000000020004" pitchFamily="2" charset="-127"/>
+                <a:ea typeface="Pretendard" panose="02000503000000020004" pitchFamily="2" charset="-127"/>
+                <a:cs typeface="Pretendard" panose="02000503000000020004" pitchFamily="2" charset="-127"/>
               </a:rPr>
               <a:t>AI Agent 개발 결과</a:t>
             </a:r>
@@ -11370,10 +11381,10 @@
                 <a:solidFill>
                   <a:srgbClr val="0E2841"/>
                 </a:solidFill>
-                <a:latin typeface="Arial"/>
-                <a:ea typeface="Arial"/>
-                <a:cs typeface="Arial"/>
                 <a:sym typeface="Arial"/>
+                <a:latin typeface="Pretendard" panose="02000503000000020004" pitchFamily="2" charset="-127"/>
+                <a:ea typeface="Pretendard" panose="02000503000000020004" pitchFamily="2" charset="-127"/>
+                <a:cs typeface="Pretendard" panose="02000503000000020004" pitchFamily="2" charset="-127"/>
               </a:rPr>
               <a:t>포스코</a:t>
             </a:r>
@@ -11401,10 +11412,10 @@
                 <a:solidFill>
                   <a:srgbClr val="0E2841"/>
                 </a:solidFill>
-                <a:latin typeface="Arial"/>
-                <a:ea typeface="Arial"/>
-                <a:cs typeface="Arial"/>
                 <a:sym typeface="Arial"/>
+                <a:latin typeface="Pretendard" panose="02000503000000020004" pitchFamily="2" charset="-127"/>
+                <a:ea typeface="Pretendard" panose="02000503000000020004" pitchFamily="2" charset="-127"/>
+                <a:cs typeface="Pretendard" panose="02000503000000020004" pitchFamily="2" charset="-127"/>
               </a:rPr>
               <a:t>곽경제</a:t>
             </a:r>
@@ -13611,10 +13622,10 @@
             </a:pPr>
             <a:r>
               <a:rPr b="1" lang="en-US" sz="5700">
-                <a:latin typeface="Arial"/>
-                <a:ea typeface="Arial"/>
-                <a:cs typeface="Arial"/>
                 <a:sym typeface="Arial"/>
+                <a:latin typeface="Pretendard" panose="02000503000000020004" pitchFamily="2" charset="-127"/>
+                <a:ea typeface="Pretendard" panose="02000503000000020004" pitchFamily="2" charset="-127"/>
+                <a:cs typeface="Pretendard" panose="02000503000000020004" pitchFamily="2" charset="-127"/>
               </a:rPr>
               <a:t>감사합니다.</a:t>
             </a:r>

</xml_diff>